<commit_message>
Explain reliability with concrete salon examples on slide 3
</commit_message>
<xml_diff>
--- a/presentation/juniper-salon.pptx
+++ b/presentation/juniper-salon.pptx
@@ -2,16 +2,16 @@
 <file path=ppt/presentation.xml><?xml version="1.0" encoding="utf-8"?>
 <p:presentation xmlns:p="http://schemas.openxmlformats.org/presentationml/2006/main">
   <p:sldMasterIdLst>
-    <p:sldMasterId xmlns:r="http://schemas.openxmlformats.org/officeDocument/2006/relationships" id="2147483648" r:id="Rb9934a1c32cb44eb"/>
+    <p:sldMasterId xmlns:r="http://schemas.openxmlformats.org/officeDocument/2006/relationships" id="2147483648" r:id="R56a86403c11541b3"/>
   </p:sldMasterIdLst>
   <p:notesMasterIdLst>
-    <p:notesMasterId xmlns:r="http://schemas.openxmlformats.org/officeDocument/2006/relationships" r:id="R3c629d14eb904d86"/>
+    <p:notesMasterId xmlns:r="http://schemas.openxmlformats.org/officeDocument/2006/relationships" r:id="R70e0b21e980f4644"/>
   </p:notesMasterIdLst>
   <p:sldIdLst>
-    <p:sldId xmlns:r="http://schemas.openxmlformats.org/officeDocument/2006/relationships" id="256" r:id="Rc7b36c46173a4853"/>
-    <p:sldId xmlns:r="http://schemas.openxmlformats.org/officeDocument/2006/relationships" id="257" r:id="R24860ec2e2104052"/>
-    <p:sldId xmlns:r="http://schemas.openxmlformats.org/officeDocument/2006/relationships" id="258" r:id="Rf7059018cde04cc0"/>
-    <p:sldId xmlns:r="http://schemas.openxmlformats.org/officeDocument/2006/relationships" id="259" r:id="R5f8cc8e028c34b62"/>
+    <p:sldId xmlns:r="http://schemas.openxmlformats.org/officeDocument/2006/relationships" id="256" r:id="R2220a17a7d07489d"/>
+    <p:sldId xmlns:r="http://schemas.openxmlformats.org/officeDocument/2006/relationships" id="257" r:id="Rbab6cb77b39c4f0a"/>
+    <p:sldId xmlns:r="http://schemas.openxmlformats.org/officeDocument/2006/relationships" id="258" r:id="Re8b8317f64994abe"/>
+    <p:sldId xmlns:r="http://schemas.openxmlformats.org/officeDocument/2006/relationships" id="259" r:id="Refd11eb9f94e4862"/>
   </p:sldIdLst>
   <p:sldSz cx="12192000" cy="6858000"/>
   <p:notesSz cx="6858000" cy="9144000"/>
@@ -585,7 +585,7 @@
           <a:lstStyle xmlns:a="http://schemas.openxmlformats.org/drawingml/2006/main"/>
           <a:p xmlns:a="http://schemas.openxmlformats.org/drawingml/2006/main">
             <a:r>
-              <a:t>Observed evidence: evidence/worker-recovery.json records SIGKILL, unchanged offer ID/deadline, one offer, and successful acceptance after restart. tests/workflow.test.ts covers deadline, duplicate Update ID, stale acceptance, booking confirmation, release, retries, withdrawal, opt-outs, and no matches. No real SMS side-effect guarantee is claimed.</a:t>
+              <a:t>Observed evidence: evidence/worker-recovery.json records SIGKILL, unchanged offer ID/deadline, one offer, and successful acceptance after restart. tests/workflow.test.ts covers expired replies, repeated acceptance, retries, and permanent delivery failure. The restart test stopped the background Worker, not the entire Temporal service. No real SMS side-effect guarantee is claimed. Staff confirmation and release remain described on slide 2 and in the demo.</a:t>
             </a:r>
           </a:p>
         </p:txBody>
@@ -723,7 +723,7 @@
   </p:cSld>
   <p:clrMap bg1="lt1" tx1="dk1" bg2="lt2" tx2="dk2" accent1="accent1" accent2="accent2" accent3="accent3" accent4="accent4" accent5="accent5" accent6="accent6" hlink="hlink" folHlink="folHlink"/>
   <p:sldLayoutIdLst>
-    <p:sldLayoutId xmlns:r="http://schemas.openxmlformats.org/officeDocument/2006/relationships" id="2147483649" r:id="R29c8e724d6b547c5"/>
+    <p:sldLayoutId xmlns:r="http://schemas.openxmlformats.org/officeDocument/2006/relationships" id="2147483649" r:id="Rc138f056295442c4"/>
   </p:sldLayoutIdLst>
   <p:txStyles>
     <p:titleStyle>
@@ -1274,7 +1274,7 @@
           <p:cNvPr id="12" name="">
             <a:extLst xmlns:a="http://schemas.openxmlformats.org/drawingml/2006/main">
               <a:ext uri="{FF2B5EF4-FFF2-40B4-BE49-F238E27FC236}">
-                <a16:creationId xmlns:a16="http://schemas.microsoft.com/office/drawing/2014/main" id="{C90A1833-DCB0-4820-9EFA-A734F1E893A0}"/>
+                <a16:creationId xmlns:a16="http://schemas.microsoft.com/office/drawing/2014/main" id="{CCD17CA5-5F79-44A9-A8B7-A6590B15F89F}"/>
               </a:ext>
             </a:extLst>
           </p:cNvPr>
@@ -1331,7 +1331,7 @@
           <p:cNvPr id="2" name="">
             <a:extLst xmlns:a="http://schemas.openxmlformats.org/drawingml/2006/main">
               <a:ext uri="{FF2B5EF4-FFF2-40B4-BE49-F238E27FC236}">
-                <a16:creationId xmlns:a16="http://schemas.microsoft.com/office/drawing/2014/main" id="{C1C2975A-FF28-4785-B6A0-86D45E234C1A}"/>
+                <a16:creationId xmlns:a16="http://schemas.microsoft.com/office/drawing/2014/main" id="{FBA3CD5F-ED09-4072-8716-1999D8464530}"/>
               </a:ext>
             </a:extLst>
           </p:cNvPr>
@@ -1411,7 +1411,7 @@
           <p:cNvPr id="3" name="">
             <a:extLst xmlns:a="http://schemas.openxmlformats.org/drawingml/2006/main">
               <a:ext uri="{FF2B5EF4-FFF2-40B4-BE49-F238E27FC236}">
-                <a16:creationId xmlns:a16="http://schemas.microsoft.com/office/drawing/2014/main" id="{9B559530-D042-4CE9-BDDF-8DD914DBF5DB}"/>
+                <a16:creationId xmlns:a16="http://schemas.microsoft.com/office/drawing/2014/main" id="{A506456C-79C6-4363-858E-738FA57C5EA4}"/>
               </a:ext>
             </a:extLst>
           </p:cNvPr>
@@ -1468,7 +1468,7 @@
           <p:cNvPr id="4" name="">
             <a:extLst xmlns:a="http://schemas.openxmlformats.org/drawingml/2006/main">
               <a:ext uri="{FF2B5EF4-FFF2-40B4-BE49-F238E27FC236}">
-                <a16:creationId xmlns:a16="http://schemas.microsoft.com/office/drawing/2014/main" id="{6F78C200-8AA6-4B4F-A5EB-9566FC7E2587}"/>
+                <a16:creationId xmlns:a16="http://schemas.microsoft.com/office/drawing/2014/main" id="{75C5098E-BB95-40F9-8BC7-F651361D27B7}"/>
               </a:ext>
             </a:extLst>
           </p:cNvPr>
@@ -1548,7 +1548,7 @@
           <p:cNvPr id="5" name="">
             <a:extLst xmlns:a="http://schemas.openxmlformats.org/drawingml/2006/main">
               <a:ext uri="{FF2B5EF4-FFF2-40B4-BE49-F238E27FC236}">
-                <a16:creationId xmlns:a16="http://schemas.microsoft.com/office/drawing/2014/main" id="{18E32177-B9F5-478B-ADD5-ABEE88CA3602}"/>
+                <a16:creationId xmlns:a16="http://schemas.microsoft.com/office/drawing/2014/main" id="{C1F806A7-AC08-41A0-A962-501A1859B453}"/>
               </a:ext>
             </a:extLst>
           </p:cNvPr>
@@ -1605,7 +1605,7 @@
           <p:cNvPr id="6" name="">
             <a:extLst xmlns:a="http://schemas.openxmlformats.org/drawingml/2006/main">
               <a:ext uri="{FF2B5EF4-FFF2-40B4-BE49-F238E27FC236}">
-                <a16:creationId xmlns:a16="http://schemas.microsoft.com/office/drawing/2014/main" id="{96A066CC-A5B6-4837-A2BC-FA75123D4BB5}"/>
+                <a16:creationId xmlns:a16="http://schemas.microsoft.com/office/drawing/2014/main" id="{01BFB640-2352-490C-A4CA-A58DEEB90F98}"/>
               </a:ext>
             </a:extLst>
           </p:cNvPr>
@@ -1662,7 +1662,7 @@
           <p:cNvPr id="7" name="">
             <a:extLst xmlns:a="http://schemas.openxmlformats.org/drawingml/2006/main">
               <a:ext uri="{FF2B5EF4-FFF2-40B4-BE49-F238E27FC236}">
-                <a16:creationId xmlns:a16="http://schemas.microsoft.com/office/drawing/2014/main" id="{35AAEE01-FEAE-4FD9-9167-D121648C2BD0}"/>
+                <a16:creationId xmlns:a16="http://schemas.microsoft.com/office/drawing/2014/main" id="{72CD5076-ED76-4890-BF9D-A97437E1C1A0}"/>
               </a:ext>
             </a:extLst>
           </p:cNvPr>
@@ -1719,7 +1719,7 @@
           <p:cNvPr id="8" name="">
             <a:extLst xmlns:a="http://schemas.openxmlformats.org/drawingml/2006/main">
               <a:ext uri="{FF2B5EF4-FFF2-40B4-BE49-F238E27FC236}">
-                <a16:creationId xmlns:a16="http://schemas.microsoft.com/office/drawing/2014/main" id="{68E1D493-BF47-4C44-A67F-BEFD73B8624A}"/>
+                <a16:creationId xmlns:a16="http://schemas.microsoft.com/office/drawing/2014/main" id="{0C53BF82-DAC0-49EB-84FC-F23FBD326D18}"/>
               </a:ext>
             </a:extLst>
           </p:cNvPr>
@@ -1776,7 +1776,7 @@
           <p:cNvPr id="9" name="">
             <a:extLst xmlns:a="http://schemas.openxmlformats.org/drawingml/2006/main">
               <a:ext uri="{FF2B5EF4-FFF2-40B4-BE49-F238E27FC236}">
-                <a16:creationId xmlns:a16="http://schemas.microsoft.com/office/drawing/2014/main" id="{5A17D22E-3B2D-4CA7-89B9-4216E4B1FB73}"/>
+                <a16:creationId xmlns:a16="http://schemas.microsoft.com/office/drawing/2014/main" id="{F0DA5889-1B71-4701-9CB3-F4913A3AA3A7}"/>
               </a:ext>
             </a:extLst>
           </p:cNvPr>
@@ -1833,7 +1833,7 @@
           <p:cNvPr id="10" name="">
             <a:extLst xmlns:a="http://schemas.openxmlformats.org/drawingml/2006/main">
               <a:ext uri="{FF2B5EF4-FFF2-40B4-BE49-F238E27FC236}">
-                <a16:creationId xmlns:a16="http://schemas.microsoft.com/office/drawing/2014/main" id="{414F744F-DF65-40BA-A2BF-C863ECE93375}"/>
+                <a16:creationId xmlns:a16="http://schemas.microsoft.com/office/drawing/2014/main" id="{CC3A4EA5-2067-4B30-967E-0ACD96BC78A4}"/>
               </a:ext>
             </a:extLst>
           </p:cNvPr>
@@ -1890,7 +1890,7 @@
           <p:cNvPr id="11" name="">
             <a:extLst xmlns:a="http://schemas.openxmlformats.org/drawingml/2006/main">
               <a:ext uri="{FF2B5EF4-FFF2-40B4-BE49-F238E27FC236}">
-                <a16:creationId xmlns:a16="http://schemas.microsoft.com/office/drawing/2014/main" id="{919E59D5-1672-45BB-AC9A-586F97DA45D2}"/>
+                <a16:creationId xmlns:a16="http://schemas.microsoft.com/office/drawing/2014/main" id="{A7E6BE9A-0D5B-4400-A872-2BF1D61F7E07}"/>
               </a:ext>
             </a:extLst>
           </p:cNvPr>
@@ -1945,7 +1945,7 @@
     </p:spTree>
     <p:extLst>
       <p:ext uri="{BB962C8B-B14F-4D97-AF65-F5344CB8AC3E}">
-        <p14:creationId xmlns:p14="http://schemas.microsoft.com/office/powerpoint/2010/main" val="199974615"/>
+        <p14:creationId xmlns:p14="http://schemas.microsoft.com/office/powerpoint/2010/main" val="1889479378"/>
       </p:ext>
     </p:extLst>
   </p:cSld>
@@ -1976,7 +1976,7 @@
           <p:cNvPr id="12" name="">
             <a:extLst xmlns:a="http://schemas.openxmlformats.org/drawingml/2006/main">
               <a:ext uri="{FF2B5EF4-FFF2-40B4-BE49-F238E27FC236}">
-                <a16:creationId xmlns:a16="http://schemas.microsoft.com/office/drawing/2014/main" id="{6FDA8278-54D9-4A61-A6F1-304D3C614526}"/>
+                <a16:creationId xmlns:a16="http://schemas.microsoft.com/office/drawing/2014/main" id="{385E1F3D-5097-4B59-8F56-FF26F544D3BD}"/>
               </a:ext>
             </a:extLst>
           </p:cNvPr>
@@ -2033,7 +2033,7 @@
           <p:cNvPr id="2" name="">
             <a:extLst xmlns:a="http://schemas.openxmlformats.org/drawingml/2006/main">
               <a:ext uri="{FF2B5EF4-FFF2-40B4-BE49-F238E27FC236}">
-                <a16:creationId xmlns:a16="http://schemas.microsoft.com/office/drawing/2014/main" id="{8BBD0F9B-BEDB-49CD-BA35-D4DAAD1493B9}"/>
+                <a16:creationId xmlns:a16="http://schemas.microsoft.com/office/drawing/2014/main" id="{93E339D3-CEDC-4984-8E6F-25232B80A5AD}"/>
               </a:ext>
             </a:extLst>
           </p:cNvPr>
@@ -2090,7 +2090,7 @@
           <p:cNvPr id="3" name="">
             <a:extLst xmlns:a="http://schemas.openxmlformats.org/drawingml/2006/main">
               <a:ext uri="{FF2B5EF4-FFF2-40B4-BE49-F238E27FC236}">
-                <a16:creationId xmlns:a16="http://schemas.microsoft.com/office/drawing/2014/main" id="{D6C30A2A-FF8C-4420-B637-38CC040996C4}"/>
+                <a16:creationId xmlns:a16="http://schemas.microsoft.com/office/drawing/2014/main" id="{EFBA130D-862E-447A-BAD0-F1AD5728399B}"/>
               </a:ext>
             </a:extLst>
           </p:cNvPr>
@@ -2147,7 +2147,7 @@
           <p:cNvPr id="4" name="">
             <a:extLst xmlns:a="http://schemas.openxmlformats.org/drawingml/2006/main">
               <a:ext uri="{FF2B5EF4-FFF2-40B4-BE49-F238E27FC236}">
-                <a16:creationId xmlns:a16="http://schemas.microsoft.com/office/drawing/2014/main" id="{4755BB97-2E5C-47E4-8001-726481CA0A75}"/>
+                <a16:creationId xmlns:a16="http://schemas.microsoft.com/office/drawing/2014/main" id="{1B5E0AB9-A229-42D3-8A9F-6C9E546B5D87}"/>
               </a:ext>
             </a:extLst>
           </p:cNvPr>
@@ -2204,7 +2204,7 @@
           <p:cNvPr id="5" name="">
             <a:extLst xmlns:a="http://schemas.openxmlformats.org/drawingml/2006/main">
               <a:ext uri="{FF2B5EF4-FFF2-40B4-BE49-F238E27FC236}">
-                <a16:creationId xmlns:a16="http://schemas.microsoft.com/office/drawing/2014/main" id="{D26263A4-7FA2-4119-B863-537A0F1071D2}"/>
+                <a16:creationId xmlns:a16="http://schemas.microsoft.com/office/drawing/2014/main" id="{263E5BD3-9185-48B0-AB7F-F99D73B61DF6}"/>
               </a:ext>
             </a:extLst>
           </p:cNvPr>
@@ -2261,7 +2261,7 @@
           <p:cNvPr id="6" name="">
             <a:extLst xmlns:a="http://schemas.openxmlformats.org/drawingml/2006/main">
               <a:ext uri="{FF2B5EF4-FFF2-40B4-BE49-F238E27FC236}">
-                <a16:creationId xmlns:a16="http://schemas.microsoft.com/office/drawing/2014/main" id="{8311392D-8300-46B3-A654-17254D009596}"/>
+                <a16:creationId xmlns:a16="http://schemas.microsoft.com/office/drawing/2014/main" id="{B8CA5ADF-CD09-43BF-9D1D-040F9E2C6546}"/>
               </a:ext>
             </a:extLst>
           </p:cNvPr>
@@ -2341,7 +2341,7 @@
           <p:cNvPr id="7" name="">
             <a:extLst xmlns:a="http://schemas.openxmlformats.org/drawingml/2006/main">
               <a:ext uri="{FF2B5EF4-FFF2-40B4-BE49-F238E27FC236}">
-                <a16:creationId xmlns:a16="http://schemas.microsoft.com/office/drawing/2014/main" id="{A5889A3D-61D8-4A55-98D5-2AFD80BC4D3E}"/>
+                <a16:creationId xmlns:a16="http://schemas.microsoft.com/office/drawing/2014/main" id="{21D9A5AC-5478-4D7C-BA83-F6973006B4E3}"/>
               </a:ext>
             </a:extLst>
           </p:cNvPr>
@@ -2398,7 +2398,7 @@
           <p:cNvPr id="8" name="">
             <a:extLst xmlns:a="http://schemas.openxmlformats.org/drawingml/2006/main">
               <a:ext uri="{FF2B5EF4-FFF2-40B4-BE49-F238E27FC236}">
-                <a16:creationId xmlns:a16="http://schemas.microsoft.com/office/drawing/2014/main" id="{77F23CC2-81B2-4087-A9C1-5EC626982B19}"/>
+                <a16:creationId xmlns:a16="http://schemas.microsoft.com/office/drawing/2014/main" id="{97BB4E53-7B5E-45D2-ADB7-2A744BE48DA6}"/>
               </a:ext>
             </a:extLst>
           </p:cNvPr>
@@ -2478,7 +2478,7 @@
           <p:cNvPr id="9" name="">
             <a:extLst xmlns:a="http://schemas.openxmlformats.org/drawingml/2006/main">
               <a:ext uri="{FF2B5EF4-FFF2-40B4-BE49-F238E27FC236}">
-                <a16:creationId xmlns:a16="http://schemas.microsoft.com/office/drawing/2014/main" id="{73271101-6785-4B21-87E6-C414A542F69C}"/>
+                <a16:creationId xmlns:a16="http://schemas.microsoft.com/office/drawing/2014/main" id="{C608F858-6C78-4590-8304-14AB630C00F5}"/>
               </a:ext>
             </a:extLst>
           </p:cNvPr>
@@ -2535,7 +2535,7 @@
           <p:cNvPr id="10" name="">
             <a:extLst xmlns:a="http://schemas.openxmlformats.org/drawingml/2006/main">
               <a:ext uri="{FF2B5EF4-FFF2-40B4-BE49-F238E27FC236}">
-                <a16:creationId xmlns:a16="http://schemas.microsoft.com/office/drawing/2014/main" id="{B82127A6-356C-49B3-A422-B161E55361EA}"/>
+                <a16:creationId xmlns:a16="http://schemas.microsoft.com/office/drawing/2014/main" id="{953753CE-3C2E-4D83-81EC-655A360B7372}"/>
               </a:ext>
             </a:extLst>
           </p:cNvPr>
@@ -2596,7 +2596,7 @@
           <p:nvPr/>
         </p:nvPicPr>
         <p:blipFill>
-          <a:blip xmlns:r="http://schemas.openxmlformats.org/officeDocument/2006/relationships" xmlns:a="http://schemas.openxmlformats.org/drawingml/2006/main" r:embed="R3003488045ce4cb2"/>
+          <a:blip xmlns:r="http://schemas.openxmlformats.org/officeDocument/2006/relationships" xmlns:a="http://schemas.openxmlformats.org/drawingml/2006/main" r:embed="Reed54357c26d42d9"/>
           <a:stretch xmlns:a="http://schemas.openxmlformats.org/drawingml/2006/main"/>
         </p:blipFill>
         <p:spPr>
@@ -2612,7 +2612,7 @@
     </p:spTree>
     <p:extLst>
       <p:ext uri="{BB962C8B-B14F-4D97-AF65-F5344CB8AC3E}">
-        <p14:creationId xmlns:p14="http://schemas.microsoft.com/office/powerpoint/2010/main" val="1833219386"/>
+        <p14:creationId xmlns:p14="http://schemas.microsoft.com/office/powerpoint/2010/main" val="1646060719"/>
       </p:ext>
     </p:extLst>
   </p:cSld>
@@ -2640,10 +2640,10 @@
       </p:grpSpPr>
       <p:sp>
         <p:nvSpPr>
-          <p:cNvPr id="10" name="">
+          <p:cNvPr id="14" name="">
             <a:extLst xmlns:a="http://schemas.openxmlformats.org/drawingml/2006/main">
               <a:ext uri="{FF2B5EF4-FFF2-40B4-BE49-F238E27FC236}">
-                <a16:creationId xmlns:a16="http://schemas.microsoft.com/office/drawing/2014/main" id="{D8EC2623-B3FF-4B42-98C0-2B19447EC1D4}"/>
+                <a16:creationId xmlns:a16="http://schemas.microsoft.com/office/drawing/2014/main" id="{9626A570-8F7D-4B07-8888-9EFA0CB71C0D}"/>
               </a:ext>
             </a:extLst>
           </p:cNvPr>
@@ -2700,7 +2700,7 @@
           <p:cNvPr id="2" name="">
             <a:extLst xmlns:a="http://schemas.openxmlformats.org/drawingml/2006/main">
               <a:ext uri="{FF2B5EF4-FFF2-40B4-BE49-F238E27FC236}">
-                <a16:creationId xmlns:a16="http://schemas.microsoft.com/office/drawing/2014/main" id="{61FEEB36-0409-41D1-AE8F-94DF8B7FF5B1}"/>
+                <a16:creationId xmlns:a16="http://schemas.microsoft.com/office/drawing/2014/main" id="{580D5B3E-3D6F-4940-A844-1DE51BD9D3D2}"/>
               </a:ext>
             </a:extLst>
           </p:cNvPr>
@@ -2747,7 +2747,7 @@
                 <a:ea typeface="Helvetica Neue"/>
                 <a:cs typeface="Helvetica Neue"/>
               </a:rPr>
-              <a:t>The process remembers where it left off</a:t>
+              <a:t>What happens when things go wrong?</a:t>
             </a:r>
           </a:p>
         </p:txBody>
@@ -2757,7 +2757,7 @@
           <p:cNvPr id="3" name="">
             <a:extLst xmlns:a="http://schemas.openxmlformats.org/drawingml/2006/main">
               <a:ext uri="{FF2B5EF4-FFF2-40B4-BE49-F238E27FC236}">
-                <a16:creationId xmlns:a16="http://schemas.microsoft.com/office/drawing/2014/main" id="{73EE7F48-20B5-4CB3-9CED-57024F7C67A9}"/>
+                <a16:creationId xmlns:a16="http://schemas.microsoft.com/office/drawing/2014/main" id="{77076506-1A5D-48BE-AF73-A541E04A76AA}"/>
               </a:ext>
             </a:extLst>
           </p:cNvPr>
@@ -2814,7 +2814,7 @@
           <p:cNvPr id="4" name="">
             <a:extLst xmlns:a="http://schemas.openxmlformats.org/drawingml/2006/main">
               <a:ext uri="{FF2B5EF4-FFF2-40B4-BE49-F238E27FC236}">
-                <a16:creationId xmlns:a16="http://schemas.microsoft.com/office/drawing/2014/main" id="{A0EDE2FF-332F-428A-8C9E-962520B9FBA5}"/>
+                <a16:creationId xmlns:a16="http://schemas.microsoft.com/office/drawing/2014/main" id="{858F0228-1CE4-4BA8-8E9B-53D480DD7E2A}"/>
               </a:ext>
             </a:extLst>
           </p:cNvPr>
@@ -2861,7 +2861,7 @@
                 <a:ea typeface="Helvetica Neue"/>
                 <a:cs typeface="Helvetica Neue"/>
               </a:rPr>
-              <a:t>Temporal keeps the offer, its deadline, and the booking hold durable.</a:t>
+              <a:t>Temporal remembers who has the offer and how long they have to answer.</a:t>
             </a:r>
           </a:p>
         </p:txBody>
@@ -2871,7 +2871,7 @@
           <p:cNvPr id="5" name="">
             <a:extLst xmlns:a="http://schemas.openxmlformats.org/drawingml/2006/main">
               <a:ext uri="{FF2B5EF4-FFF2-40B4-BE49-F238E27FC236}">
-                <a16:creationId xmlns:a16="http://schemas.microsoft.com/office/drawing/2014/main" id="{E7A7B949-D854-4BFF-BEBC-7C57D705C246}"/>
+                <a16:creationId xmlns:a16="http://schemas.microsoft.com/office/drawing/2014/main" id="{291A67FD-32E8-4744-8A4F-512EAAF16C04}"/>
               </a:ext>
             </a:extLst>
           </p:cNvPr>
@@ -2882,8 +2882,8 @@
         </p:nvSpPr>
         <p:spPr>
           <a:xfrm xmlns:a="http://schemas.openxmlformats.org/drawingml/2006/main">
-            <a:off x="609600" y="2714625"/>
-            <a:ext cx="5334000" cy="400050"/>
+            <a:off x="609600" y="2667000"/>
+            <a:ext cx="5191125" cy="590550"/>
           </a:xfrm>
           <a:prstGeom xmlns:a="http://schemas.openxmlformats.org/drawingml/2006/main" prst="rect">
             <a:avLst/>
@@ -2900,25 +2900,25 @@
           <a:lstStyle xmlns:a="http://schemas.openxmlformats.org/drawingml/2006/main"/>
           <a:p xmlns:a="http://schemas.openxmlformats.org/drawingml/2006/main">
             <a:pPr>
-              <a:defRPr sz="2175" b="1">
-                <a:solidFill>
-                  <a:srgbClr val="243E35"/>
-                </a:solidFill>
-                <a:latin typeface="Helvetica Neue"/>
-                <a:ea typeface="Helvetica Neue"/>
-                <a:cs typeface="Helvetica Neue"/>
-              </a:defRPr>
-            </a:pPr>
-            <a:r>
-              <a:rPr sz="2175" b="1">
-                <a:solidFill>
-                  <a:srgbClr val="243E35"/>
-                </a:solidFill>
-                <a:latin typeface="Helvetica Neue"/>
-                <a:ea typeface="Helvetica Neue"/>
-                <a:cs typeface="Helvetica Neue"/>
-              </a:rPr>
-              <a:t>Verified in this prototype</a:t>
+              <a:defRPr sz="2100" b="1">
+                <a:solidFill>
+                  <a:srgbClr val="243E35"/>
+                </a:solidFill>
+                <a:latin typeface="Helvetica Neue"/>
+                <a:ea typeface="Helvetica Neue"/>
+                <a:cs typeface="Helvetica Neue"/>
+              </a:defRPr>
+            </a:pPr>
+            <a:r>
+              <a:rPr sz="2100" b="1">
+                <a:solidFill>
+                  <a:srgbClr val="243E35"/>
+                </a:solidFill>
+                <a:latin typeface="Helvetica Neue"/>
+                <a:ea typeface="Helvetica Neue"/>
+                <a:cs typeface="Helvetica Neue"/>
+              </a:rPr>
+              <a:t>The app stops while someone is deciding</a:t>
             </a:r>
           </a:p>
         </p:txBody>
@@ -2928,7 +2928,7 @@
           <p:cNvPr id="6" name="">
             <a:extLst xmlns:a="http://schemas.openxmlformats.org/drawingml/2006/main">
               <a:ext uri="{FF2B5EF4-FFF2-40B4-BE49-F238E27FC236}">
-                <a16:creationId xmlns:a16="http://schemas.microsoft.com/office/drawing/2014/main" id="{F30F7B06-D1B8-4B03-9201-18CCFFF978AF}"/>
+                <a16:creationId xmlns:a16="http://schemas.microsoft.com/office/drawing/2014/main" id="{407E6596-FFE4-4D9C-8540-36D4B8A5A044}"/>
               </a:ext>
             </a:extLst>
           </p:cNvPr>
@@ -2939,8 +2939,8 @@
         </p:nvSpPr>
         <p:spPr>
           <a:xfrm xmlns:a="http://schemas.openxmlformats.org/drawingml/2006/main">
-            <a:off x="609600" y="3295650"/>
-            <a:ext cx="6096000" cy="2476500"/>
+            <a:off x="609600" y="3333750"/>
+            <a:ext cx="5286375" cy="1123950"/>
           </a:xfrm>
           <a:prstGeom xmlns:a="http://schemas.openxmlformats.org/drawingml/2006/main" prst="rect">
             <a:avLst/>
@@ -2975,7 +2975,7 @@
                 <a:ea typeface="Helvetica Neue"/>
                 <a:cs typeface="Helvetica Neue"/>
               </a:rPr>
-              <a:t>A Worker was forcibly stopped and restarted.</a:t>
+              <a:t>We stopped and restarted the software handling</a:t>
             </a:r>
           </a:p>
           <a:p xmlns:a="http://schemas.openxmlformats.org/drawingml/2006/main">
@@ -2998,12 +2998,7 @@
                 <a:ea typeface="Helvetica Neue"/>
                 <a:cs typeface="Helvetica Neue"/>
               </a:rPr>
-              <a:t>The same offer and deadline survived.</a:t>
-            </a:r>
-          </a:p>
-          <a:p xmlns:a="http://schemas.openxmlformats.org/drawingml/2006/main">
-            <a:r>
-              <a:t/>
+              <a:t>the waitlist. It remembered the same client</a:t>
             </a:r>
           </a:p>
           <a:p xmlns:a="http://schemas.openxmlformats.org/drawingml/2006/main">
@@ -3026,53 +3021,7 @@
                 <a:ea typeface="Helvetica Neue"/>
                 <a:cs typeface="Helvetica Neue"/>
               </a:rPr>
-              <a:t>Expired replies are rejected.</a:t>
-            </a:r>
-          </a:p>
-          <a:p xmlns:a="http://schemas.openxmlformats.org/drawingml/2006/main">
-            <a:pPr>
-              <a:defRPr sz="1875" b="0">
-                <a:solidFill>
-                  <a:srgbClr val="243E35"/>
-                </a:solidFill>
-                <a:latin typeface="Helvetica Neue"/>
-                <a:ea typeface="Helvetica Neue"/>
-                <a:cs typeface="Helvetica Neue"/>
-              </a:defRPr>
-            </a:pPr>
-            <a:r>
-              <a:rPr sz="1875" b="0">
-                <a:solidFill>
-                  <a:srgbClr val="243E35"/>
-                </a:solidFill>
-                <a:latin typeface="Helvetica Neue"/>
-                <a:ea typeface="Helvetica Neue"/>
-                <a:cs typeface="Helvetica Neue"/>
-              </a:rPr>
-              <a:t>Repeated acceptance cannot create another hold.</a:t>
-            </a:r>
-          </a:p>
-          <a:p xmlns:a="http://schemas.openxmlformats.org/drawingml/2006/main">
-            <a:pPr>
-              <a:defRPr sz="1875" b="0">
-                <a:solidFill>
-                  <a:srgbClr val="243E35"/>
-                </a:solidFill>
-                <a:latin typeface="Helvetica Neue"/>
-                <a:ea typeface="Helvetica Neue"/>
-                <a:cs typeface="Helvetica Neue"/>
-              </a:defRPr>
-            </a:pPr>
-            <a:r>
-              <a:rPr sz="1875" b="0">
-                <a:solidFill>
-                  <a:srgbClr val="243E35"/>
-                </a:solidFill>
-                <a:latin typeface="Helvetica Neue"/>
-                <a:ea typeface="Helvetica Neue"/>
-                <a:cs typeface="Helvetica Neue"/>
-              </a:rPr>
-              <a:t>Failed delivery advances; temporary failure retries.</a:t>
+              <a:t>and their original deadline.</a:t>
             </a:r>
           </a:p>
         </p:txBody>
@@ -3082,7 +3031,7 @@
           <p:cNvPr id="7" name="">
             <a:extLst xmlns:a="http://schemas.openxmlformats.org/drawingml/2006/main">
               <a:ext uri="{FF2B5EF4-FFF2-40B4-BE49-F238E27FC236}">
-                <a16:creationId xmlns:a16="http://schemas.microsoft.com/office/drawing/2014/main" id="{3D71286E-AD79-4457-A36F-AFEF876D7759}"/>
+                <a16:creationId xmlns:a16="http://schemas.microsoft.com/office/drawing/2014/main" id="{85E2B525-2D1E-4317-9575-4D01C3FF615A}"/>
               </a:ext>
             </a:extLst>
           </p:cNvPr>
@@ -3093,8 +3042,8 @@
         </p:nvSpPr>
         <p:spPr>
           <a:xfrm xmlns:a="http://schemas.openxmlformats.org/drawingml/2006/main">
-            <a:off x="7429500" y="2714625"/>
-            <a:ext cx="4048125" cy="400050"/>
+            <a:off x="6572250" y="2667000"/>
+            <a:ext cx="5000625" cy="590550"/>
           </a:xfrm>
           <a:prstGeom xmlns:a="http://schemas.openxmlformats.org/drawingml/2006/main" prst="rect">
             <a:avLst/>
@@ -3111,25 +3060,25 @@
           <a:lstStyle xmlns:a="http://schemas.openxmlformats.org/drawingml/2006/main"/>
           <a:p xmlns:a="http://schemas.openxmlformats.org/drawingml/2006/main">
             <a:pPr>
-              <a:defRPr sz="2175" b="1">
-                <a:solidFill>
-                  <a:srgbClr val="243E35"/>
-                </a:solidFill>
-                <a:latin typeface="Helvetica Neue"/>
-                <a:ea typeface="Helvetica Neue"/>
-                <a:cs typeface="Helvetica Neue"/>
-              </a:defRPr>
-            </a:pPr>
-            <a:r>
-              <a:rPr sz="2175" b="1">
-                <a:solidFill>
-                  <a:srgbClr val="243E35"/>
-                </a:solidFill>
-                <a:latin typeface="Helvetica Neue"/>
-                <a:ea typeface="Helvetica Neue"/>
-                <a:cs typeface="Helvetica Neue"/>
-              </a:rPr>
-              <a:t>Staff remain in control</a:t>
+              <a:defRPr sz="2100" b="1">
+                <a:solidFill>
+                  <a:srgbClr val="243E35"/>
+                </a:solidFill>
+                <a:latin typeface="Helvetica Neue"/>
+                <a:ea typeface="Helvetica Neue"/>
+                <a:cs typeface="Helvetica Neue"/>
+              </a:defRPr>
+            </a:pPr>
+            <a:r>
+              <a:rPr sz="2100" b="1">
+                <a:solidFill>
+                  <a:srgbClr val="243E35"/>
+                </a:solidFill>
+                <a:latin typeface="Helvetica Neue"/>
+                <a:ea typeface="Helvetica Neue"/>
+                <a:cs typeface="Helvetica Neue"/>
+              </a:rPr>
+              <a:t>A client replies after their time is up</a:t>
             </a:r>
           </a:p>
         </p:txBody>
@@ -3139,7 +3088,7 @@
           <p:cNvPr id="8" name="">
             <a:extLst xmlns:a="http://schemas.openxmlformats.org/drawingml/2006/main">
               <a:ext uri="{FF2B5EF4-FFF2-40B4-BE49-F238E27FC236}">
-                <a16:creationId xmlns:a16="http://schemas.microsoft.com/office/drawing/2014/main" id="{B6A4D28D-A926-4EA8-AAD3-33CBF81220DB}"/>
+                <a16:creationId xmlns:a16="http://schemas.microsoft.com/office/drawing/2014/main" id="{5EA1C07A-D90B-4977-8973-EF12626649B2}"/>
               </a:ext>
             </a:extLst>
           </p:cNvPr>
@@ -3150,8 +3099,8 @@
         </p:nvSpPr>
         <p:spPr>
           <a:xfrm xmlns:a="http://schemas.openxmlformats.org/drawingml/2006/main">
-            <a:off x="7429500" y="3295650"/>
-            <a:ext cx="4000500" cy="2476500"/>
+            <a:off x="6572250" y="3333750"/>
+            <a:ext cx="5000625" cy="1123950"/>
           </a:xfrm>
           <a:prstGeom xmlns:a="http://schemas.openxmlformats.org/drawingml/2006/main" prst="rect">
             <a:avLst/>
@@ -3186,12 +3135,7 @@
                 <a:ea typeface="Helvetica Neue"/>
                 <a:cs typeface="Helvetica Neue"/>
               </a:rPr>
-              <a:t>A question does not extend the deadline.</a:t>
-            </a:r>
-          </a:p>
-          <a:p xmlns:a="http://schemas.openxmlformats.org/drawingml/2006/main">
-            <a:r>
-              <a:t/>
+              <a:t>They see that their offer has expired.</a:t>
             </a:r>
           </a:p>
           <a:p xmlns:a="http://schemas.openxmlformats.org/drawingml/2006/main">
@@ -3214,7 +3158,7 @@
                 <a:ea typeface="Helvetica Neue"/>
                 <a:cs typeface="Helvetica Neue"/>
               </a:rPr>
-              <a:t>A held slot stays reserved until staff</a:t>
+              <a:t>They cannot claim a spot now offered</a:t>
             </a:r>
           </a:p>
           <a:p xmlns:a="http://schemas.openxmlformats.org/drawingml/2006/main">
@@ -3237,58 +3181,7 @@
                 <a:ea typeface="Helvetica Neue"/>
                 <a:cs typeface="Helvetica Neue"/>
               </a:rPr>
-              <a:t>confirm, release, or withdraw it.</a:t>
-            </a:r>
-          </a:p>
-          <a:p xmlns:a="http://schemas.openxmlformats.org/drawingml/2006/main">
-            <a:r>
-              <a:t/>
-            </a:r>
-          </a:p>
-          <a:p xmlns:a="http://schemas.openxmlformats.org/drawingml/2006/main">
-            <a:pPr>
-              <a:defRPr sz="1875" b="0">
-                <a:solidFill>
-                  <a:srgbClr val="243E35"/>
-                </a:solidFill>
-                <a:latin typeface="Helvetica Neue"/>
-                <a:ea typeface="Helvetica Neue"/>
-                <a:cs typeface="Helvetica Neue"/>
-              </a:defRPr>
-            </a:pPr>
-            <a:r>
-              <a:rPr sz="1875" b="0">
-                <a:solidFill>
-                  <a:srgbClr val="243E35"/>
-                </a:solidFill>
-                <a:latin typeface="Helvetica Neue"/>
-                <a:ea typeface="Helvetica Neue"/>
-                <a:cs typeface="Helvetica Neue"/>
-              </a:rPr>
-              <a:t>The activity journal shows what happened</a:t>
-            </a:r>
-          </a:p>
-          <a:p xmlns:a="http://schemas.openxmlformats.org/drawingml/2006/main">
-            <a:pPr>
-              <a:defRPr sz="1875" b="0">
-                <a:solidFill>
-                  <a:srgbClr val="243E35"/>
-                </a:solidFill>
-                <a:latin typeface="Helvetica Neue"/>
-                <a:ea typeface="Helvetica Neue"/>
-                <a:cs typeface="Helvetica Neue"/>
-              </a:defRPr>
-            </a:pPr>
-            <a:r>
-              <a:rPr sz="1875" b="0">
-                <a:solidFill>
-                  <a:srgbClr val="243E35"/>
-                </a:solidFill>
-                <a:latin typeface="Helvetica Neue"/>
-                <a:ea typeface="Helvetica Neue"/>
-                <a:cs typeface="Helvetica Neue"/>
-              </a:rPr>
-              <a:t>and what needs attention.</a:t>
+              <a:t>to someone else.</a:t>
             </a:r>
           </a:p>
         </p:txBody>
@@ -3298,7 +3191,7 @@
           <p:cNvPr id="9" name="">
             <a:extLst xmlns:a="http://schemas.openxmlformats.org/drawingml/2006/main">
               <a:ext uri="{FF2B5EF4-FFF2-40B4-BE49-F238E27FC236}">
-                <a16:creationId xmlns:a16="http://schemas.microsoft.com/office/drawing/2014/main" id="{C2DA6336-3327-49B2-9DF9-1B3820813EEF}"/>
+                <a16:creationId xmlns:a16="http://schemas.microsoft.com/office/drawing/2014/main" id="{569221FA-0309-4AA7-8A0E-6C99E18A1B4D}"/>
               </a:ext>
             </a:extLst>
           </p:cNvPr>
@@ -3309,8 +3202,8 @@
         </p:nvSpPr>
         <p:spPr>
           <a:xfrm xmlns:a="http://schemas.openxmlformats.org/drawingml/2006/main">
-            <a:off x="609600" y="6143625"/>
-            <a:ext cx="10096500" cy="285750"/>
+            <a:off x="609600" y="4610100"/>
+            <a:ext cx="5191125" cy="419100"/>
           </a:xfrm>
           <a:prstGeom xmlns:a="http://schemas.openxmlformats.org/drawingml/2006/main" prst="rect">
             <a:avLst/>
@@ -3327,6 +3220,303 @@
           <a:lstStyle xmlns:a="http://schemas.openxmlformats.org/drawingml/2006/main"/>
           <a:p xmlns:a="http://schemas.openxmlformats.org/drawingml/2006/main">
             <a:pPr>
+              <a:defRPr sz="2100" b="1">
+                <a:solidFill>
+                  <a:srgbClr val="243E35"/>
+                </a:solidFill>
+                <a:latin typeface="Helvetica Neue"/>
+                <a:ea typeface="Helvetica Neue"/>
+                <a:cs typeface="Helvetica Neue"/>
+              </a:defRPr>
+            </a:pPr>
+            <a:r>
+              <a:rPr sz="2100" b="1">
+                <a:solidFill>
+                  <a:srgbClr val="243E35"/>
+                </a:solidFill>
+                <a:latin typeface="Helvetica Neue"/>
+                <a:ea typeface="Helvetica Neue"/>
+                <a:cs typeface="Helvetica Neue"/>
+              </a:rPr>
+              <a:t>A text won’t go through</a:t>
+            </a:r>
+          </a:p>
+        </p:txBody>
+      </p:sp>
+      <p:sp>
+        <p:nvSpPr>
+          <p:cNvPr id="10" name="">
+            <a:extLst xmlns:a="http://schemas.openxmlformats.org/drawingml/2006/main">
+              <a:ext uri="{FF2B5EF4-FFF2-40B4-BE49-F238E27FC236}">
+                <a16:creationId xmlns:a16="http://schemas.microsoft.com/office/drawing/2014/main" id="{3BD514CC-C12A-4CA4-81A7-3B56DD16338E}"/>
+              </a:ext>
+            </a:extLst>
+          </p:cNvPr>
+          <p:cNvSpPr>
+            <a:spLocks xmlns:a="http://schemas.openxmlformats.org/drawingml/2006/main" noGrp="1"/>
+          </p:cNvSpPr>
+          <p:nvPr/>
+        </p:nvSpPr>
+        <p:spPr>
+          <a:xfrm xmlns:a="http://schemas.openxmlformats.org/drawingml/2006/main">
+            <a:off x="609600" y="5114925"/>
+            <a:ext cx="5286375" cy="952500"/>
+          </a:xfrm>
+          <a:prstGeom xmlns:a="http://schemas.openxmlformats.org/drawingml/2006/main" prst="rect">
+            <a:avLst/>
+          </a:prstGeom>
+          <a:noFill xmlns:a="http://schemas.openxmlformats.org/drawingml/2006/main"/>
+          <a:ln xmlns:a="http://schemas.openxmlformats.org/drawingml/2006/main" w="0">
+            <a:noFill/>
+          </a:ln>
+        </p:spPr>
+        <p:txBody>
+          <a:bodyPr xmlns:a="http://schemas.openxmlformats.org/drawingml/2006/main">
+            <a:noAutofit/>
+          </a:bodyPr>
+          <a:lstStyle xmlns:a="http://schemas.openxmlformats.org/drawingml/2006/main"/>
+          <a:p xmlns:a="http://schemas.openxmlformats.org/drawingml/2006/main">
+            <a:pPr>
+              <a:defRPr sz="1875" b="0">
+                <a:solidFill>
+                  <a:srgbClr val="243E35"/>
+                </a:solidFill>
+                <a:latin typeface="Helvetica Neue"/>
+                <a:ea typeface="Helvetica Neue"/>
+                <a:cs typeface="Helvetica Neue"/>
+              </a:defRPr>
+            </a:pPr>
+            <a:r>
+              <a:rPr sz="1875" b="0">
+                <a:solidFill>
+                  <a:srgbClr val="243E35"/>
+                </a:solidFill>
+                <a:latin typeface="Helvetica Neue"/>
+                <a:ea typeface="Helvetica Neue"/>
+                <a:cs typeface="Helvetica Neue"/>
+              </a:rPr>
+              <a:t>For a temporary problem, the demo tries sending</a:t>
+            </a:r>
+          </a:p>
+          <a:p xmlns:a="http://schemas.openxmlformats.org/drawingml/2006/main">
+            <a:pPr>
+              <a:defRPr sz="1875" b="0">
+                <a:solidFill>
+                  <a:srgbClr val="243E35"/>
+                </a:solidFill>
+                <a:latin typeface="Helvetica Neue"/>
+                <a:ea typeface="Helvetica Neue"/>
+                <a:cs typeface="Helvetica Neue"/>
+              </a:defRPr>
+            </a:pPr>
+            <a:r>
+              <a:rPr sz="1875" b="0">
+                <a:solidFill>
+                  <a:srgbClr val="243E35"/>
+                </a:solidFill>
+                <a:latin typeface="Helvetica Neue"/>
+                <a:ea typeface="Helvetica Neue"/>
+                <a:cs typeface="Helvetica Neue"/>
+              </a:rPr>
+              <a:t>again. If delivery fails, it offers the opening</a:t>
+            </a:r>
+          </a:p>
+          <a:p xmlns:a="http://schemas.openxmlformats.org/drawingml/2006/main">
+            <a:pPr>
+              <a:defRPr sz="1875" b="0">
+                <a:solidFill>
+                  <a:srgbClr val="243E35"/>
+                </a:solidFill>
+                <a:latin typeface="Helvetica Neue"/>
+                <a:ea typeface="Helvetica Neue"/>
+                <a:cs typeface="Helvetica Neue"/>
+              </a:defRPr>
+            </a:pPr>
+            <a:r>
+              <a:rPr sz="1875" b="0">
+                <a:solidFill>
+                  <a:srgbClr val="243E35"/>
+                </a:solidFill>
+                <a:latin typeface="Helvetica Neue"/>
+                <a:ea typeface="Helvetica Neue"/>
+                <a:cs typeface="Helvetica Neue"/>
+              </a:rPr>
+              <a:t>to the next client who fits.</a:t>
+            </a:r>
+          </a:p>
+        </p:txBody>
+      </p:sp>
+      <p:sp>
+        <p:nvSpPr>
+          <p:cNvPr id="11" name="">
+            <a:extLst xmlns:a="http://schemas.openxmlformats.org/drawingml/2006/main">
+              <a:ext uri="{FF2B5EF4-FFF2-40B4-BE49-F238E27FC236}">
+                <a16:creationId xmlns:a16="http://schemas.microsoft.com/office/drawing/2014/main" id="{5E3ADDBA-EE33-49D5-A7DF-0B638161E248}"/>
+              </a:ext>
+            </a:extLst>
+          </p:cNvPr>
+          <p:cNvSpPr>
+            <a:spLocks xmlns:a="http://schemas.openxmlformats.org/drawingml/2006/main" noGrp="1"/>
+          </p:cNvSpPr>
+          <p:nvPr/>
+        </p:nvSpPr>
+        <p:spPr>
+          <a:xfrm xmlns:a="http://schemas.openxmlformats.org/drawingml/2006/main">
+            <a:off x="6572250" y="4610100"/>
+            <a:ext cx="5000625" cy="419100"/>
+          </a:xfrm>
+          <a:prstGeom xmlns:a="http://schemas.openxmlformats.org/drawingml/2006/main" prst="rect">
+            <a:avLst/>
+          </a:prstGeom>
+          <a:noFill xmlns:a="http://schemas.openxmlformats.org/drawingml/2006/main"/>
+          <a:ln xmlns:a="http://schemas.openxmlformats.org/drawingml/2006/main" w="0">
+            <a:noFill/>
+          </a:ln>
+        </p:spPr>
+        <p:txBody>
+          <a:bodyPr xmlns:a="http://schemas.openxmlformats.org/drawingml/2006/main">
+            <a:noAutofit/>
+          </a:bodyPr>
+          <a:lstStyle xmlns:a="http://schemas.openxmlformats.org/drawingml/2006/main"/>
+          <a:p xmlns:a="http://schemas.openxmlformats.org/drawingml/2006/main">
+            <a:pPr>
+              <a:defRPr sz="2100" b="1">
+                <a:solidFill>
+                  <a:srgbClr val="243E35"/>
+                </a:solidFill>
+                <a:latin typeface="Helvetica Neue"/>
+                <a:ea typeface="Helvetica Neue"/>
+                <a:cs typeface="Helvetica Neue"/>
+              </a:defRPr>
+            </a:pPr>
+            <a:r>
+              <a:rPr sz="2100" b="1">
+                <a:solidFill>
+                  <a:srgbClr val="243E35"/>
+                </a:solidFill>
+                <a:latin typeface="Helvetica Neue"/>
+                <a:ea typeface="Helvetica Neue"/>
+                <a:cs typeface="Helvetica Neue"/>
+              </a:rPr>
+              <a:t>A client taps “yes” twice</a:t>
+            </a:r>
+          </a:p>
+        </p:txBody>
+      </p:sp>
+      <p:sp>
+        <p:nvSpPr>
+          <p:cNvPr id="12" name="">
+            <a:extLst xmlns:a="http://schemas.openxmlformats.org/drawingml/2006/main">
+              <a:ext uri="{FF2B5EF4-FFF2-40B4-BE49-F238E27FC236}">
+                <a16:creationId xmlns:a16="http://schemas.microsoft.com/office/drawing/2014/main" id="{ABB5727D-36BF-4C90-9180-92D625D5420E}"/>
+              </a:ext>
+            </a:extLst>
+          </p:cNvPr>
+          <p:cNvSpPr>
+            <a:spLocks xmlns:a="http://schemas.openxmlformats.org/drawingml/2006/main" noGrp="1"/>
+          </p:cNvSpPr>
+          <p:nvPr/>
+        </p:nvSpPr>
+        <p:spPr>
+          <a:xfrm xmlns:a="http://schemas.openxmlformats.org/drawingml/2006/main">
+            <a:off x="6572250" y="5114925"/>
+            <a:ext cx="5000625" cy="952500"/>
+          </a:xfrm>
+          <a:prstGeom xmlns:a="http://schemas.openxmlformats.org/drawingml/2006/main" prst="rect">
+            <a:avLst/>
+          </a:prstGeom>
+          <a:noFill xmlns:a="http://schemas.openxmlformats.org/drawingml/2006/main"/>
+          <a:ln xmlns:a="http://schemas.openxmlformats.org/drawingml/2006/main" w="0">
+            <a:noFill/>
+          </a:ln>
+        </p:spPr>
+        <p:txBody>
+          <a:bodyPr xmlns:a="http://schemas.openxmlformats.org/drawingml/2006/main">
+            <a:noAutofit/>
+          </a:bodyPr>
+          <a:lstStyle xmlns:a="http://schemas.openxmlformats.org/drawingml/2006/main"/>
+          <a:p xmlns:a="http://schemas.openxmlformats.org/drawingml/2006/main">
+            <a:pPr>
+              <a:defRPr sz="1875" b="0">
+                <a:solidFill>
+                  <a:srgbClr val="243E35"/>
+                </a:solidFill>
+                <a:latin typeface="Helvetica Neue"/>
+                <a:ea typeface="Helvetica Neue"/>
+                <a:cs typeface="Helvetica Neue"/>
+              </a:defRPr>
+            </a:pPr>
+            <a:r>
+              <a:rPr sz="1875" b="0">
+                <a:solidFill>
+                  <a:srgbClr val="243E35"/>
+                </a:solidFill>
+                <a:latin typeface="Helvetica Neue"/>
+                <a:ea typeface="Helvetica Neue"/>
+                <a:cs typeface="Helvetica Neue"/>
+              </a:rPr>
+              <a:t>Their spot stays held. The second tap</a:t>
+            </a:r>
+          </a:p>
+          <a:p xmlns:a="http://schemas.openxmlformats.org/drawingml/2006/main">
+            <a:pPr>
+              <a:defRPr sz="1875" b="0">
+                <a:solidFill>
+                  <a:srgbClr val="243E35"/>
+                </a:solidFill>
+                <a:latin typeface="Helvetica Neue"/>
+                <a:ea typeface="Helvetica Neue"/>
+                <a:cs typeface="Helvetica Neue"/>
+              </a:defRPr>
+            </a:pPr>
+            <a:r>
+              <a:rPr sz="1875" b="0">
+                <a:solidFill>
+                  <a:srgbClr val="243E35"/>
+                </a:solidFill>
+                <a:latin typeface="Helvetica Neue"/>
+                <a:ea typeface="Helvetica Neue"/>
+                <a:cs typeface="Helvetica Neue"/>
+              </a:rPr>
+              <a:t>does not create another reservation.</a:t>
+            </a:r>
+          </a:p>
+        </p:txBody>
+      </p:sp>
+      <p:sp>
+        <p:nvSpPr>
+          <p:cNvPr id="13" name="">
+            <a:extLst xmlns:a="http://schemas.openxmlformats.org/drawingml/2006/main">
+              <a:ext uri="{FF2B5EF4-FFF2-40B4-BE49-F238E27FC236}">
+                <a16:creationId xmlns:a16="http://schemas.microsoft.com/office/drawing/2014/main" id="{1E4A6806-0BF4-458C-9C93-991FE273ECCD}"/>
+              </a:ext>
+            </a:extLst>
+          </p:cNvPr>
+          <p:cNvSpPr>
+            <a:spLocks xmlns:a="http://schemas.openxmlformats.org/drawingml/2006/main" noGrp="1"/>
+          </p:cNvSpPr>
+          <p:nvPr/>
+        </p:nvSpPr>
+        <p:spPr>
+          <a:xfrm xmlns:a="http://schemas.openxmlformats.org/drawingml/2006/main">
+            <a:off x="609600" y="6191250"/>
+            <a:ext cx="10096500" cy="285750"/>
+          </a:xfrm>
+          <a:prstGeom xmlns:a="http://schemas.openxmlformats.org/drawingml/2006/main" prst="rect">
+            <a:avLst/>
+          </a:prstGeom>
+          <a:noFill xmlns:a="http://schemas.openxmlformats.org/drawingml/2006/main"/>
+          <a:ln xmlns:a="http://schemas.openxmlformats.org/drawingml/2006/main" w="0">
+            <a:noFill/>
+          </a:ln>
+        </p:spPr>
+        <p:txBody>
+          <a:bodyPr xmlns:a="http://schemas.openxmlformats.org/drawingml/2006/main">
+            <a:noAutofit/>
+          </a:bodyPr>
+          <a:lstStyle xmlns:a="http://schemas.openxmlformats.org/drawingml/2006/main"/>
+          <a:p xmlns:a="http://schemas.openxmlformats.org/drawingml/2006/main">
+            <a:pPr>
               <a:defRPr sz="1275" b="0">
                 <a:solidFill>
                   <a:srgbClr val="617166"/>
@@ -3345,7 +3535,7 @@
                 <a:ea typeface="Helvetica Neue"/>
                 <a:cs typeface="Helvetica Neue"/>
               </a:rPr>
-              <a:t>Evidence: worker-recovery.json, temporal-workflow.jpg, and the automated workflow tests in the repository.</a:t>
+              <a:t>We tested these situations in the prototype. Text messages are simulated.</a:t>
             </a:r>
           </a:p>
         </p:txBody>
@@ -3353,7 +3543,7 @@
     </p:spTree>
     <p:extLst>
       <p:ext uri="{BB962C8B-B14F-4D97-AF65-F5344CB8AC3E}">
-        <p14:creationId xmlns:p14="http://schemas.microsoft.com/office/powerpoint/2010/main" val="2132997938"/>
+        <p14:creationId xmlns:p14="http://schemas.microsoft.com/office/powerpoint/2010/main" val="1637929445"/>
       </p:ext>
     </p:extLst>
   </p:cSld>
@@ -3384,7 +3574,7 @@
           <p:cNvPr id="9" name="">
             <a:extLst xmlns:a="http://schemas.openxmlformats.org/drawingml/2006/main">
               <a:ext uri="{FF2B5EF4-FFF2-40B4-BE49-F238E27FC236}">
-                <a16:creationId xmlns:a16="http://schemas.microsoft.com/office/drawing/2014/main" id="{7F8979C5-B9EB-4F99-A4C8-9F4B6A77C11B}"/>
+                <a16:creationId xmlns:a16="http://schemas.microsoft.com/office/drawing/2014/main" id="{3174C224-069F-498C-93FF-A3019B35511D}"/>
               </a:ext>
             </a:extLst>
           </p:cNvPr>
@@ -3441,7 +3631,7 @@
           <p:cNvPr id="2" name="">
             <a:extLst xmlns:a="http://schemas.openxmlformats.org/drawingml/2006/main">
               <a:ext uri="{FF2B5EF4-FFF2-40B4-BE49-F238E27FC236}">
-                <a16:creationId xmlns:a16="http://schemas.microsoft.com/office/drawing/2014/main" id="{688707A7-6249-4E6F-9768-F53B3B5AFB21}"/>
+                <a16:creationId xmlns:a16="http://schemas.microsoft.com/office/drawing/2014/main" id="{2D1919CE-9AD2-473B-8651-FE84227D60AB}"/>
               </a:ext>
             </a:extLst>
           </p:cNvPr>
@@ -3498,7 +3688,7 @@
           <p:cNvPr id="3" name="">
             <a:extLst xmlns:a="http://schemas.openxmlformats.org/drawingml/2006/main">
               <a:ext uri="{FF2B5EF4-FFF2-40B4-BE49-F238E27FC236}">
-                <a16:creationId xmlns:a16="http://schemas.microsoft.com/office/drawing/2014/main" id="{AEE6E553-A203-4A34-8B2F-46339ED5E8A8}"/>
+                <a16:creationId xmlns:a16="http://schemas.microsoft.com/office/drawing/2014/main" id="{7113C041-1338-4246-A6BF-8A4AB3B632E4}"/>
               </a:ext>
             </a:extLst>
           </p:cNvPr>
@@ -3555,7 +3745,7 @@
           <p:cNvPr id="4" name="">
             <a:extLst xmlns:a="http://schemas.openxmlformats.org/drawingml/2006/main">
               <a:ext uri="{FF2B5EF4-FFF2-40B4-BE49-F238E27FC236}">
-                <a16:creationId xmlns:a16="http://schemas.microsoft.com/office/drawing/2014/main" id="{9B19F9F6-A2CB-40B3-B5AE-D2B31790FBFE}"/>
+                <a16:creationId xmlns:a16="http://schemas.microsoft.com/office/drawing/2014/main" id="{2F592E29-4FED-4FAF-8125-9DEED26D95F0}"/>
               </a:ext>
             </a:extLst>
           </p:cNvPr>
@@ -3612,7 +3802,7 @@
           <p:cNvPr id="5" name="">
             <a:extLst xmlns:a="http://schemas.openxmlformats.org/drawingml/2006/main">
               <a:ext uri="{FF2B5EF4-FFF2-40B4-BE49-F238E27FC236}">
-                <a16:creationId xmlns:a16="http://schemas.microsoft.com/office/drawing/2014/main" id="{5B0675BE-134B-4774-A8EC-F5876C5D4278}"/>
+                <a16:creationId xmlns:a16="http://schemas.microsoft.com/office/drawing/2014/main" id="{209E3E52-A101-4749-95B0-FA5D89127EAE}"/>
               </a:ext>
             </a:extLst>
           </p:cNvPr>
@@ -3789,7 +3979,7 @@
           <p:cNvPr id="6" name="">
             <a:extLst xmlns:a="http://schemas.openxmlformats.org/drawingml/2006/main">
               <a:ext uri="{FF2B5EF4-FFF2-40B4-BE49-F238E27FC236}">
-                <a16:creationId xmlns:a16="http://schemas.microsoft.com/office/drawing/2014/main" id="{91E7DE82-1F6F-4DB8-8F24-D918AA23C130}"/>
+                <a16:creationId xmlns:a16="http://schemas.microsoft.com/office/drawing/2014/main" id="{3A9B8D80-C27D-4D64-921D-E39736ADD737}"/>
               </a:ext>
             </a:extLst>
           </p:cNvPr>
@@ -3846,7 +4036,7 @@
           <p:cNvPr id="7" name="">
             <a:extLst xmlns:a="http://schemas.openxmlformats.org/drawingml/2006/main">
               <a:ext uri="{FF2B5EF4-FFF2-40B4-BE49-F238E27FC236}">
-                <a16:creationId xmlns:a16="http://schemas.microsoft.com/office/drawing/2014/main" id="{B5F91AAE-DAEB-4E4B-8CEE-68AB60EEF419}"/>
+                <a16:creationId xmlns:a16="http://schemas.microsoft.com/office/drawing/2014/main" id="{06F929FA-F197-4718-A629-4A1A51B14A3D}"/>
               </a:ext>
             </a:extLst>
           </p:cNvPr>
@@ -4023,7 +4213,7 @@
           <p:cNvPr id="8" name="">
             <a:extLst xmlns:a="http://schemas.openxmlformats.org/drawingml/2006/main">
               <a:ext uri="{FF2B5EF4-FFF2-40B4-BE49-F238E27FC236}">
-                <a16:creationId xmlns:a16="http://schemas.microsoft.com/office/drawing/2014/main" id="{3B534479-53E2-4E6E-9C39-AB326B609FE9}"/>
+                <a16:creationId xmlns:a16="http://schemas.microsoft.com/office/drawing/2014/main" id="{DE08D76B-C418-4D74-B0D2-5D04F50800E1}"/>
               </a:ext>
             </a:extLst>
           </p:cNvPr>
@@ -4078,7 +4268,7 @@
     </p:spTree>
     <p:extLst>
       <p:ext uri="{BB962C8B-B14F-4D97-AF65-F5344CB8AC3E}">
-        <p14:creationId xmlns:p14="http://schemas.microsoft.com/office/powerpoint/2010/main" val="1944104386"/>
+        <p14:creationId xmlns:p14="http://schemas.microsoft.com/office/powerpoint/2010/main" val="2070891760"/>
       </p:ext>
     </p:extLst>
   </p:cSld>

</xml_diff>

<commit_message>
Show pilot targets, checklist, and illustrative timeline on final slide
</commit_message>
<xml_diff>
--- a/presentation/juniper-salon.pptx
+++ b/presentation/juniper-salon.pptx
@@ -2,16 +2,16 @@
 <file path=ppt/presentation.xml><?xml version="1.0" encoding="utf-8"?>
 <p:presentation xmlns:p="http://schemas.openxmlformats.org/presentationml/2006/main">
   <p:sldMasterIdLst>
-    <p:sldMasterId xmlns:r="http://schemas.openxmlformats.org/officeDocument/2006/relationships" id="2147483648" r:id="R56a86403c11541b3"/>
+    <p:sldMasterId xmlns:r="http://schemas.openxmlformats.org/officeDocument/2006/relationships" id="2147483648" r:id="R9a6615819391494b"/>
   </p:sldMasterIdLst>
   <p:notesMasterIdLst>
-    <p:notesMasterId xmlns:r="http://schemas.openxmlformats.org/officeDocument/2006/relationships" r:id="R70e0b21e980f4644"/>
+    <p:notesMasterId xmlns:r="http://schemas.openxmlformats.org/officeDocument/2006/relationships" r:id="Raa0e2d66774d4afb"/>
   </p:notesMasterIdLst>
   <p:sldIdLst>
-    <p:sldId xmlns:r="http://schemas.openxmlformats.org/officeDocument/2006/relationships" id="256" r:id="R2220a17a7d07489d"/>
-    <p:sldId xmlns:r="http://schemas.openxmlformats.org/officeDocument/2006/relationships" id="257" r:id="Rbab6cb77b39c4f0a"/>
-    <p:sldId xmlns:r="http://schemas.openxmlformats.org/officeDocument/2006/relationships" id="258" r:id="Re8b8317f64994abe"/>
-    <p:sldId xmlns:r="http://schemas.openxmlformats.org/officeDocument/2006/relationships" id="259" r:id="Refd11eb9f94e4862"/>
+    <p:sldId xmlns:r="http://schemas.openxmlformats.org/officeDocument/2006/relationships" id="256" r:id="Rcf8c569c6eb74c0f"/>
+    <p:sldId xmlns:r="http://schemas.openxmlformats.org/officeDocument/2006/relationships" id="257" r:id="Rc49d2d771abb4b7b"/>
+    <p:sldId xmlns:r="http://schemas.openxmlformats.org/officeDocument/2006/relationships" id="258" r:id="Rfda8c2bc8eec4f68"/>
+    <p:sldId xmlns:r="http://schemas.openxmlformats.org/officeDocument/2006/relationships" id="259" r:id="R07cbcfb1994b4e87"/>
   </p:sldIdLst>
   <p:sldSz cx="12192000" cy="6858000"/>
   <p:notesSz cx="6858000" cy="9144000"/>
@@ -655,7 +655,7 @@
           <a:lstStyle xmlns:a="http://schemas.openxmlformats.org/drawingml/2006/main"/>
           <a:p xmlns:a="http://schemas.openxmlformats.org/drawingml/2006/main">
             <a:r>
-              <a:t>Customer-confirmed pilot owners: Lena and Carla (turn 15). Two-week duration was proposed during interview and is a practical next-step proposal. Real integrations, staff authentication, production data retention, and cross-channel booking reconciliation are excluded. 9am–7pm contact hours, 30-minute arrival buffer confirmed turn 14. Los Angeles timezone is a disclosed prototype assumption, not a customer-confirmed salon location.</a:t>
+              <a:t>Illustrative timeline requested by the user, based on October 4, 2026: two weeks of preparation to October 18, followed by a proposed two-week pilot ending November 1. Dates are not a delivery commitment and launch depends on setup and testing. Lena and Carla were confirmed as pilot owners in customer interview turn 15. At least 50% refilled is Lena’s target, not observed performance. Zero conflicting booking promises is the proposed trust criterion. Refill rate means confirmed refills divided by eligible openings. Track staff follow-ups against baseline; no numerical staff-time target was established. The screenshot shows a fictional demo booking. Live messaging and waitlist integration, staff sign-in, consent records, and checking Square against the app are prerequisite work. One active opening at a time.</a:t>
             </a:r>
           </a:p>
         </p:txBody>
@@ -723,7 +723,7 @@
   </p:cSld>
   <p:clrMap bg1="lt1" tx1="dk1" bg2="lt2" tx2="dk2" accent1="accent1" accent2="accent2" accent3="accent3" accent4="accent4" accent5="accent5" accent6="accent6" hlink="hlink" folHlink="folHlink"/>
   <p:sldLayoutIdLst>
-    <p:sldLayoutId xmlns:r="http://schemas.openxmlformats.org/officeDocument/2006/relationships" id="2147483649" r:id="Rc138f056295442c4"/>
+    <p:sldLayoutId xmlns:r="http://schemas.openxmlformats.org/officeDocument/2006/relationships" id="2147483649" r:id="R3aa5e60be52c47a7"/>
   </p:sldLayoutIdLst>
   <p:txStyles>
     <p:titleStyle>
@@ -1274,7 +1274,7 @@
           <p:cNvPr id="12" name="">
             <a:extLst xmlns:a="http://schemas.openxmlformats.org/drawingml/2006/main">
               <a:ext uri="{FF2B5EF4-FFF2-40B4-BE49-F238E27FC236}">
-                <a16:creationId xmlns:a16="http://schemas.microsoft.com/office/drawing/2014/main" id="{CCD17CA5-5F79-44A9-A8B7-A6590B15F89F}"/>
+                <a16:creationId xmlns:a16="http://schemas.microsoft.com/office/drawing/2014/main" id="{3448D9F0-E679-4E03-B305-0AE980F07FEF}"/>
               </a:ext>
             </a:extLst>
           </p:cNvPr>
@@ -1331,7 +1331,7 @@
           <p:cNvPr id="2" name="">
             <a:extLst xmlns:a="http://schemas.openxmlformats.org/drawingml/2006/main">
               <a:ext uri="{FF2B5EF4-FFF2-40B4-BE49-F238E27FC236}">
-                <a16:creationId xmlns:a16="http://schemas.microsoft.com/office/drawing/2014/main" id="{FBA3CD5F-ED09-4072-8716-1999D8464530}"/>
+                <a16:creationId xmlns:a16="http://schemas.microsoft.com/office/drawing/2014/main" id="{A04B0700-AE97-48E9-9959-44C9DA4B76A9}"/>
               </a:ext>
             </a:extLst>
           </p:cNvPr>
@@ -1411,7 +1411,7 @@
           <p:cNvPr id="3" name="">
             <a:extLst xmlns:a="http://schemas.openxmlformats.org/drawingml/2006/main">
               <a:ext uri="{FF2B5EF4-FFF2-40B4-BE49-F238E27FC236}">
-                <a16:creationId xmlns:a16="http://schemas.microsoft.com/office/drawing/2014/main" id="{A506456C-79C6-4363-858E-738FA57C5EA4}"/>
+                <a16:creationId xmlns:a16="http://schemas.microsoft.com/office/drawing/2014/main" id="{30662F14-F0B4-4A0E-96A1-095BC5DBFFF9}"/>
               </a:ext>
             </a:extLst>
           </p:cNvPr>
@@ -1468,7 +1468,7 @@
           <p:cNvPr id="4" name="">
             <a:extLst xmlns:a="http://schemas.openxmlformats.org/drawingml/2006/main">
               <a:ext uri="{FF2B5EF4-FFF2-40B4-BE49-F238E27FC236}">
-                <a16:creationId xmlns:a16="http://schemas.microsoft.com/office/drawing/2014/main" id="{75C5098E-BB95-40F9-8BC7-F651361D27B7}"/>
+                <a16:creationId xmlns:a16="http://schemas.microsoft.com/office/drawing/2014/main" id="{61DD2F07-F226-414A-A2CA-CFC9B71D54C0}"/>
               </a:ext>
             </a:extLst>
           </p:cNvPr>
@@ -1548,7 +1548,7 @@
           <p:cNvPr id="5" name="">
             <a:extLst xmlns:a="http://schemas.openxmlformats.org/drawingml/2006/main">
               <a:ext uri="{FF2B5EF4-FFF2-40B4-BE49-F238E27FC236}">
-                <a16:creationId xmlns:a16="http://schemas.microsoft.com/office/drawing/2014/main" id="{C1F806A7-AC08-41A0-A962-501A1859B453}"/>
+                <a16:creationId xmlns:a16="http://schemas.microsoft.com/office/drawing/2014/main" id="{A92A4B60-F941-4D51-A171-8384634B5E15}"/>
               </a:ext>
             </a:extLst>
           </p:cNvPr>
@@ -1605,7 +1605,7 @@
           <p:cNvPr id="6" name="">
             <a:extLst xmlns:a="http://schemas.openxmlformats.org/drawingml/2006/main">
               <a:ext uri="{FF2B5EF4-FFF2-40B4-BE49-F238E27FC236}">
-                <a16:creationId xmlns:a16="http://schemas.microsoft.com/office/drawing/2014/main" id="{01BFB640-2352-490C-A4CA-A58DEEB90F98}"/>
+                <a16:creationId xmlns:a16="http://schemas.microsoft.com/office/drawing/2014/main" id="{BB222718-FBB6-421E-A8CE-47255332841C}"/>
               </a:ext>
             </a:extLst>
           </p:cNvPr>
@@ -1662,7 +1662,7 @@
           <p:cNvPr id="7" name="">
             <a:extLst xmlns:a="http://schemas.openxmlformats.org/drawingml/2006/main">
               <a:ext uri="{FF2B5EF4-FFF2-40B4-BE49-F238E27FC236}">
-                <a16:creationId xmlns:a16="http://schemas.microsoft.com/office/drawing/2014/main" id="{72CD5076-ED76-4890-BF9D-A97437E1C1A0}"/>
+                <a16:creationId xmlns:a16="http://schemas.microsoft.com/office/drawing/2014/main" id="{B0A60463-D536-4F01-A9E4-32F15D23A5DC}"/>
               </a:ext>
             </a:extLst>
           </p:cNvPr>
@@ -1719,7 +1719,7 @@
           <p:cNvPr id="8" name="">
             <a:extLst xmlns:a="http://schemas.openxmlformats.org/drawingml/2006/main">
               <a:ext uri="{FF2B5EF4-FFF2-40B4-BE49-F238E27FC236}">
-                <a16:creationId xmlns:a16="http://schemas.microsoft.com/office/drawing/2014/main" id="{0C53BF82-DAC0-49EB-84FC-F23FBD326D18}"/>
+                <a16:creationId xmlns:a16="http://schemas.microsoft.com/office/drawing/2014/main" id="{E952921F-4569-4953-B26E-11DB8F7DDF90}"/>
               </a:ext>
             </a:extLst>
           </p:cNvPr>
@@ -1776,7 +1776,7 @@
           <p:cNvPr id="9" name="">
             <a:extLst xmlns:a="http://schemas.openxmlformats.org/drawingml/2006/main">
               <a:ext uri="{FF2B5EF4-FFF2-40B4-BE49-F238E27FC236}">
-                <a16:creationId xmlns:a16="http://schemas.microsoft.com/office/drawing/2014/main" id="{F0DA5889-1B71-4701-9CB3-F4913A3AA3A7}"/>
+                <a16:creationId xmlns:a16="http://schemas.microsoft.com/office/drawing/2014/main" id="{85AA7D18-05E8-4F62-9120-78147475436F}"/>
               </a:ext>
             </a:extLst>
           </p:cNvPr>
@@ -1833,7 +1833,7 @@
           <p:cNvPr id="10" name="">
             <a:extLst xmlns:a="http://schemas.openxmlformats.org/drawingml/2006/main">
               <a:ext uri="{FF2B5EF4-FFF2-40B4-BE49-F238E27FC236}">
-                <a16:creationId xmlns:a16="http://schemas.microsoft.com/office/drawing/2014/main" id="{CC3A4EA5-2067-4B30-967E-0ACD96BC78A4}"/>
+                <a16:creationId xmlns:a16="http://schemas.microsoft.com/office/drawing/2014/main" id="{CDF0E997-95FC-40B5-B3D4-5AACCC62CA13}"/>
               </a:ext>
             </a:extLst>
           </p:cNvPr>
@@ -1890,7 +1890,7 @@
           <p:cNvPr id="11" name="">
             <a:extLst xmlns:a="http://schemas.openxmlformats.org/drawingml/2006/main">
               <a:ext uri="{FF2B5EF4-FFF2-40B4-BE49-F238E27FC236}">
-                <a16:creationId xmlns:a16="http://schemas.microsoft.com/office/drawing/2014/main" id="{A7E6BE9A-0D5B-4400-A872-2BF1D61F7E07}"/>
+                <a16:creationId xmlns:a16="http://schemas.microsoft.com/office/drawing/2014/main" id="{FB336A34-2C02-4826-9373-CC721F338004}"/>
               </a:ext>
             </a:extLst>
           </p:cNvPr>
@@ -1945,7 +1945,7 @@
     </p:spTree>
     <p:extLst>
       <p:ext uri="{BB962C8B-B14F-4D97-AF65-F5344CB8AC3E}">
-        <p14:creationId xmlns:p14="http://schemas.microsoft.com/office/powerpoint/2010/main" val="1889479378"/>
+        <p14:creationId xmlns:p14="http://schemas.microsoft.com/office/powerpoint/2010/main" val="949768049"/>
       </p:ext>
     </p:extLst>
   </p:cSld>
@@ -1976,7 +1976,7 @@
           <p:cNvPr id="12" name="">
             <a:extLst xmlns:a="http://schemas.openxmlformats.org/drawingml/2006/main">
               <a:ext uri="{FF2B5EF4-FFF2-40B4-BE49-F238E27FC236}">
-                <a16:creationId xmlns:a16="http://schemas.microsoft.com/office/drawing/2014/main" id="{385E1F3D-5097-4B59-8F56-FF26F544D3BD}"/>
+                <a16:creationId xmlns:a16="http://schemas.microsoft.com/office/drawing/2014/main" id="{7D38ED2B-410F-49E4-B95B-BBDE6A51EB5C}"/>
               </a:ext>
             </a:extLst>
           </p:cNvPr>
@@ -2033,7 +2033,7 @@
           <p:cNvPr id="2" name="">
             <a:extLst xmlns:a="http://schemas.openxmlformats.org/drawingml/2006/main">
               <a:ext uri="{FF2B5EF4-FFF2-40B4-BE49-F238E27FC236}">
-                <a16:creationId xmlns:a16="http://schemas.microsoft.com/office/drawing/2014/main" id="{93E339D3-CEDC-4984-8E6F-25232B80A5AD}"/>
+                <a16:creationId xmlns:a16="http://schemas.microsoft.com/office/drawing/2014/main" id="{795976B4-4352-49EB-BE39-7D29685A4F29}"/>
               </a:ext>
             </a:extLst>
           </p:cNvPr>
@@ -2090,7 +2090,7 @@
           <p:cNvPr id="3" name="">
             <a:extLst xmlns:a="http://schemas.openxmlformats.org/drawingml/2006/main">
               <a:ext uri="{FF2B5EF4-FFF2-40B4-BE49-F238E27FC236}">
-                <a16:creationId xmlns:a16="http://schemas.microsoft.com/office/drawing/2014/main" id="{EFBA130D-862E-447A-BAD0-F1AD5728399B}"/>
+                <a16:creationId xmlns:a16="http://schemas.microsoft.com/office/drawing/2014/main" id="{6340D9C3-2977-4A73-BAD4-AD12CB510742}"/>
               </a:ext>
             </a:extLst>
           </p:cNvPr>
@@ -2147,7 +2147,7 @@
           <p:cNvPr id="4" name="">
             <a:extLst xmlns:a="http://schemas.openxmlformats.org/drawingml/2006/main">
               <a:ext uri="{FF2B5EF4-FFF2-40B4-BE49-F238E27FC236}">
-                <a16:creationId xmlns:a16="http://schemas.microsoft.com/office/drawing/2014/main" id="{1B5E0AB9-A229-42D3-8A9F-6C9E546B5D87}"/>
+                <a16:creationId xmlns:a16="http://schemas.microsoft.com/office/drawing/2014/main" id="{B3069AF4-5175-406B-A002-8B665E827053}"/>
               </a:ext>
             </a:extLst>
           </p:cNvPr>
@@ -2204,7 +2204,7 @@
           <p:cNvPr id="5" name="">
             <a:extLst xmlns:a="http://schemas.openxmlformats.org/drawingml/2006/main">
               <a:ext uri="{FF2B5EF4-FFF2-40B4-BE49-F238E27FC236}">
-                <a16:creationId xmlns:a16="http://schemas.microsoft.com/office/drawing/2014/main" id="{263E5BD3-9185-48B0-AB7F-F99D73B61DF6}"/>
+                <a16:creationId xmlns:a16="http://schemas.microsoft.com/office/drawing/2014/main" id="{B53DA1F9-E489-4F93-8CF4-88C504E8BF11}"/>
               </a:ext>
             </a:extLst>
           </p:cNvPr>
@@ -2261,7 +2261,7 @@
           <p:cNvPr id="6" name="">
             <a:extLst xmlns:a="http://schemas.openxmlformats.org/drawingml/2006/main">
               <a:ext uri="{FF2B5EF4-FFF2-40B4-BE49-F238E27FC236}">
-                <a16:creationId xmlns:a16="http://schemas.microsoft.com/office/drawing/2014/main" id="{B8CA5ADF-CD09-43BF-9D1D-040F9E2C6546}"/>
+                <a16:creationId xmlns:a16="http://schemas.microsoft.com/office/drawing/2014/main" id="{052CB5D9-5CE8-43CF-A42F-502E68DF00C3}"/>
               </a:ext>
             </a:extLst>
           </p:cNvPr>
@@ -2341,7 +2341,7 @@
           <p:cNvPr id="7" name="">
             <a:extLst xmlns:a="http://schemas.openxmlformats.org/drawingml/2006/main">
               <a:ext uri="{FF2B5EF4-FFF2-40B4-BE49-F238E27FC236}">
-                <a16:creationId xmlns:a16="http://schemas.microsoft.com/office/drawing/2014/main" id="{21D9A5AC-5478-4D7C-BA83-F6973006B4E3}"/>
+                <a16:creationId xmlns:a16="http://schemas.microsoft.com/office/drawing/2014/main" id="{5017F93D-5187-4886-9CFE-63F1A19F59AD}"/>
               </a:ext>
             </a:extLst>
           </p:cNvPr>
@@ -2398,7 +2398,7 @@
           <p:cNvPr id="8" name="">
             <a:extLst xmlns:a="http://schemas.openxmlformats.org/drawingml/2006/main">
               <a:ext uri="{FF2B5EF4-FFF2-40B4-BE49-F238E27FC236}">
-                <a16:creationId xmlns:a16="http://schemas.microsoft.com/office/drawing/2014/main" id="{97BB4E53-7B5E-45D2-ADB7-2A744BE48DA6}"/>
+                <a16:creationId xmlns:a16="http://schemas.microsoft.com/office/drawing/2014/main" id="{2BFFA573-1B6A-428A-8FD7-F4C0BD1D3371}"/>
               </a:ext>
             </a:extLst>
           </p:cNvPr>
@@ -2478,7 +2478,7 @@
           <p:cNvPr id="9" name="">
             <a:extLst xmlns:a="http://schemas.openxmlformats.org/drawingml/2006/main">
               <a:ext uri="{FF2B5EF4-FFF2-40B4-BE49-F238E27FC236}">
-                <a16:creationId xmlns:a16="http://schemas.microsoft.com/office/drawing/2014/main" id="{C608F858-6C78-4590-8304-14AB630C00F5}"/>
+                <a16:creationId xmlns:a16="http://schemas.microsoft.com/office/drawing/2014/main" id="{9A2D9F47-259E-41BB-B010-CC533BA30524}"/>
               </a:ext>
             </a:extLst>
           </p:cNvPr>
@@ -2535,7 +2535,7 @@
           <p:cNvPr id="10" name="">
             <a:extLst xmlns:a="http://schemas.openxmlformats.org/drawingml/2006/main">
               <a:ext uri="{FF2B5EF4-FFF2-40B4-BE49-F238E27FC236}">
-                <a16:creationId xmlns:a16="http://schemas.microsoft.com/office/drawing/2014/main" id="{953753CE-3C2E-4D83-81EC-655A360B7372}"/>
+                <a16:creationId xmlns:a16="http://schemas.microsoft.com/office/drawing/2014/main" id="{53B994CA-814F-4E69-AA57-5330A76F469E}"/>
               </a:ext>
             </a:extLst>
           </p:cNvPr>
@@ -2596,7 +2596,7 @@
           <p:nvPr/>
         </p:nvPicPr>
         <p:blipFill>
-          <a:blip xmlns:r="http://schemas.openxmlformats.org/officeDocument/2006/relationships" xmlns:a="http://schemas.openxmlformats.org/drawingml/2006/main" r:embed="Reed54357c26d42d9"/>
+          <a:blip xmlns:r="http://schemas.openxmlformats.org/officeDocument/2006/relationships" xmlns:a="http://schemas.openxmlformats.org/drawingml/2006/main" r:embed="Rd42b87c8051b4193"/>
           <a:stretch xmlns:a="http://schemas.openxmlformats.org/drawingml/2006/main"/>
         </p:blipFill>
         <p:spPr>
@@ -2612,7 +2612,7 @@
     </p:spTree>
     <p:extLst>
       <p:ext uri="{BB962C8B-B14F-4D97-AF65-F5344CB8AC3E}">
-        <p14:creationId xmlns:p14="http://schemas.microsoft.com/office/powerpoint/2010/main" val="1646060719"/>
+        <p14:creationId xmlns:p14="http://schemas.microsoft.com/office/powerpoint/2010/main" val="1058087644"/>
       </p:ext>
     </p:extLst>
   </p:cSld>
@@ -2643,7 +2643,7 @@
           <p:cNvPr id="14" name="">
             <a:extLst xmlns:a="http://schemas.openxmlformats.org/drawingml/2006/main">
               <a:ext uri="{FF2B5EF4-FFF2-40B4-BE49-F238E27FC236}">
-                <a16:creationId xmlns:a16="http://schemas.microsoft.com/office/drawing/2014/main" id="{9626A570-8F7D-4B07-8888-9EFA0CB71C0D}"/>
+                <a16:creationId xmlns:a16="http://schemas.microsoft.com/office/drawing/2014/main" id="{1469748A-5541-4E49-AC14-8456E17F0F1A}"/>
               </a:ext>
             </a:extLst>
           </p:cNvPr>
@@ -2700,7 +2700,7 @@
           <p:cNvPr id="2" name="">
             <a:extLst xmlns:a="http://schemas.openxmlformats.org/drawingml/2006/main">
               <a:ext uri="{FF2B5EF4-FFF2-40B4-BE49-F238E27FC236}">
-                <a16:creationId xmlns:a16="http://schemas.microsoft.com/office/drawing/2014/main" id="{580D5B3E-3D6F-4940-A844-1DE51BD9D3D2}"/>
+                <a16:creationId xmlns:a16="http://schemas.microsoft.com/office/drawing/2014/main" id="{43DFAC28-F090-45A8-9F66-928401A534EC}"/>
               </a:ext>
             </a:extLst>
           </p:cNvPr>
@@ -2757,7 +2757,7 @@
           <p:cNvPr id="3" name="">
             <a:extLst xmlns:a="http://schemas.openxmlformats.org/drawingml/2006/main">
               <a:ext uri="{FF2B5EF4-FFF2-40B4-BE49-F238E27FC236}">
-                <a16:creationId xmlns:a16="http://schemas.microsoft.com/office/drawing/2014/main" id="{77076506-1A5D-48BE-AF73-A541E04A76AA}"/>
+                <a16:creationId xmlns:a16="http://schemas.microsoft.com/office/drawing/2014/main" id="{52C10EA7-512A-489E-A26A-6A7C70E0A18E}"/>
               </a:ext>
             </a:extLst>
           </p:cNvPr>
@@ -2814,7 +2814,7 @@
           <p:cNvPr id="4" name="">
             <a:extLst xmlns:a="http://schemas.openxmlformats.org/drawingml/2006/main">
               <a:ext uri="{FF2B5EF4-FFF2-40B4-BE49-F238E27FC236}">
-                <a16:creationId xmlns:a16="http://schemas.microsoft.com/office/drawing/2014/main" id="{858F0228-1CE4-4BA8-8E9B-53D480DD7E2A}"/>
+                <a16:creationId xmlns:a16="http://schemas.microsoft.com/office/drawing/2014/main" id="{697E6FF1-CF50-4EF1-A148-748C8EF78783}"/>
               </a:ext>
             </a:extLst>
           </p:cNvPr>
@@ -2871,7 +2871,7 @@
           <p:cNvPr id="5" name="">
             <a:extLst xmlns:a="http://schemas.openxmlformats.org/drawingml/2006/main">
               <a:ext uri="{FF2B5EF4-FFF2-40B4-BE49-F238E27FC236}">
-                <a16:creationId xmlns:a16="http://schemas.microsoft.com/office/drawing/2014/main" id="{291A67FD-32E8-4744-8A4F-512EAAF16C04}"/>
+                <a16:creationId xmlns:a16="http://schemas.microsoft.com/office/drawing/2014/main" id="{9D4F38B6-94FA-46B7-ACDC-6C6CBB5E2239}"/>
               </a:ext>
             </a:extLst>
           </p:cNvPr>
@@ -2928,7 +2928,7 @@
           <p:cNvPr id="6" name="">
             <a:extLst xmlns:a="http://schemas.openxmlformats.org/drawingml/2006/main">
               <a:ext uri="{FF2B5EF4-FFF2-40B4-BE49-F238E27FC236}">
-                <a16:creationId xmlns:a16="http://schemas.microsoft.com/office/drawing/2014/main" id="{407E6596-FFE4-4D9C-8540-36D4B8A5A044}"/>
+                <a16:creationId xmlns:a16="http://schemas.microsoft.com/office/drawing/2014/main" id="{D247A882-2E7E-4493-9329-02D05CD52B60}"/>
               </a:ext>
             </a:extLst>
           </p:cNvPr>
@@ -3031,7 +3031,7 @@
           <p:cNvPr id="7" name="">
             <a:extLst xmlns:a="http://schemas.openxmlformats.org/drawingml/2006/main">
               <a:ext uri="{FF2B5EF4-FFF2-40B4-BE49-F238E27FC236}">
-                <a16:creationId xmlns:a16="http://schemas.microsoft.com/office/drawing/2014/main" id="{85E2B525-2D1E-4317-9575-4D01C3FF615A}"/>
+                <a16:creationId xmlns:a16="http://schemas.microsoft.com/office/drawing/2014/main" id="{43B180D2-548C-4575-9D87-1AEAE08FBBE8}"/>
               </a:ext>
             </a:extLst>
           </p:cNvPr>
@@ -3088,7 +3088,7 @@
           <p:cNvPr id="8" name="">
             <a:extLst xmlns:a="http://schemas.openxmlformats.org/drawingml/2006/main">
               <a:ext uri="{FF2B5EF4-FFF2-40B4-BE49-F238E27FC236}">
-                <a16:creationId xmlns:a16="http://schemas.microsoft.com/office/drawing/2014/main" id="{5EA1C07A-D90B-4977-8973-EF12626649B2}"/>
+                <a16:creationId xmlns:a16="http://schemas.microsoft.com/office/drawing/2014/main" id="{072D427E-C1CA-45E1-99FC-06EDCC2D0909}"/>
               </a:ext>
             </a:extLst>
           </p:cNvPr>
@@ -3191,7 +3191,7 @@
           <p:cNvPr id="9" name="">
             <a:extLst xmlns:a="http://schemas.openxmlformats.org/drawingml/2006/main">
               <a:ext uri="{FF2B5EF4-FFF2-40B4-BE49-F238E27FC236}">
-                <a16:creationId xmlns:a16="http://schemas.microsoft.com/office/drawing/2014/main" id="{569221FA-0309-4AA7-8A0E-6C99E18A1B4D}"/>
+                <a16:creationId xmlns:a16="http://schemas.microsoft.com/office/drawing/2014/main" id="{CAAF31FE-B679-42D9-88AA-3157A0E94211}"/>
               </a:ext>
             </a:extLst>
           </p:cNvPr>
@@ -3248,7 +3248,7 @@
           <p:cNvPr id="10" name="">
             <a:extLst xmlns:a="http://schemas.openxmlformats.org/drawingml/2006/main">
               <a:ext uri="{FF2B5EF4-FFF2-40B4-BE49-F238E27FC236}">
-                <a16:creationId xmlns:a16="http://schemas.microsoft.com/office/drawing/2014/main" id="{3BD514CC-C12A-4CA4-81A7-3B56DD16338E}"/>
+                <a16:creationId xmlns:a16="http://schemas.microsoft.com/office/drawing/2014/main" id="{302579B1-D62E-49FB-9638-1D1BABD14A08}"/>
               </a:ext>
             </a:extLst>
           </p:cNvPr>
@@ -3351,7 +3351,7 @@
           <p:cNvPr id="11" name="">
             <a:extLst xmlns:a="http://schemas.openxmlformats.org/drawingml/2006/main">
               <a:ext uri="{FF2B5EF4-FFF2-40B4-BE49-F238E27FC236}">
-                <a16:creationId xmlns:a16="http://schemas.microsoft.com/office/drawing/2014/main" id="{5E3ADDBA-EE33-49D5-A7DF-0B638161E248}"/>
+                <a16:creationId xmlns:a16="http://schemas.microsoft.com/office/drawing/2014/main" id="{54D5491A-CB87-4480-A5E9-79601D7D823E}"/>
               </a:ext>
             </a:extLst>
           </p:cNvPr>
@@ -3408,7 +3408,7 @@
           <p:cNvPr id="12" name="">
             <a:extLst xmlns:a="http://schemas.openxmlformats.org/drawingml/2006/main">
               <a:ext uri="{FF2B5EF4-FFF2-40B4-BE49-F238E27FC236}">
-                <a16:creationId xmlns:a16="http://schemas.microsoft.com/office/drawing/2014/main" id="{ABB5727D-36BF-4C90-9180-92D625D5420E}"/>
+                <a16:creationId xmlns:a16="http://schemas.microsoft.com/office/drawing/2014/main" id="{12DE19F2-E7F6-4D57-B476-4AF0723738B9}"/>
               </a:ext>
             </a:extLst>
           </p:cNvPr>
@@ -3488,7 +3488,7 @@
           <p:cNvPr id="13" name="">
             <a:extLst xmlns:a="http://schemas.openxmlformats.org/drawingml/2006/main">
               <a:ext uri="{FF2B5EF4-FFF2-40B4-BE49-F238E27FC236}">
-                <a16:creationId xmlns:a16="http://schemas.microsoft.com/office/drawing/2014/main" id="{1E4A6806-0BF4-458C-9C93-991FE273ECCD}"/>
+                <a16:creationId xmlns:a16="http://schemas.microsoft.com/office/drawing/2014/main" id="{B95BD128-91C8-4CC3-A16D-4B77F9D79A8B}"/>
               </a:ext>
             </a:extLst>
           </p:cNvPr>
@@ -3543,7 +3543,7 @@
     </p:spTree>
     <p:extLst>
       <p:ext uri="{BB962C8B-B14F-4D97-AF65-F5344CB8AC3E}">
-        <p14:creationId xmlns:p14="http://schemas.microsoft.com/office/powerpoint/2010/main" val="1637929445"/>
+        <p14:creationId xmlns:p14="http://schemas.microsoft.com/office/powerpoint/2010/main" val="446883130"/>
       </p:ext>
     </p:extLst>
   </p:cSld>
@@ -3571,10 +3571,10 @@
       </p:grpSpPr>
       <p:sp>
         <p:nvSpPr>
-          <p:cNvPr id="9" name="">
-            <a:extLst xmlns:a="http://schemas.openxmlformats.org/drawingml/2006/main">
-              <a:ext uri="{FF2B5EF4-FFF2-40B4-BE49-F238E27FC236}">
-                <a16:creationId xmlns:a16="http://schemas.microsoft.com/office/drawing/2014/main" id="{3174C224-069F-498C-93FF-A3019B35511D}"/>
+          <p:cNvPr id="25" name="">
+            <a:extLst xmlns:a="http://schemas.openxmlformats.org/drawingml/2006/main">
+              <a:ext uri="{FF2B5EF4-FFF2-40B4-BE49-F238E27FC236}">
+                <a16:creationId xmlns:a16="http://schemas.microsoft.com/office/drawing/2014/main" id="{24AE8050-7B44-4943-B171-7C10557740CA}"/>
               </a:ext>
             </a:extLst>
           </p:cNvPr>
@@ -3631,7 +3631,7 @@
           <p:cNvPr id="2" name="">
             <a:extLst xmlns:a="http://schemas.openxmlformats.org/drawingml/2006/main">
               <a:ext uri="{FF2B5EF4-FFF2-40B4-BE49-F238E27FC236}">
-                <a16:creationId xmlns:a16="http://schemas.microsoft.com/office/drawing/2014/main" id="{2D1919CE-9AD2-473B-8651-FE84227D60AB}"/>
+                <a16:creationId xmlns:a16="http://schemas.microsoft.com/office/drawing/2014/main" id="{7693A194-2518-4BFF-9A8D-7B0569507966}"/>
               </a:ext>
             </a:extLst>
           </p:cNvPr>
@@ -3678,7 +3678,7 @@
                 <a:ea typeface="Helvetica Neue"/>
                 <a:cs typeface="Helvetica Neue"/>
               </a:rPr>
-              <a:t>A small, supervised pilot</a:t>
+              <a:t>A two-week trial with Lena and Carla</a:t>
             </a:r>
           </a:p>
         </p:txBody>
@@ -3688,7 +3688,7 @@
           <p:cNvPr id="3" name="">
             <a:extLst xmlns:a="http://schemas.openxmlformats.org/drawingml/2006/main">
               <a:ext uri="{FF2B5EF4-FFF2-40B4-BE49-F238E27FC236}">
-                <a16:creationId xmlns:a16="http://schemas.microsoft.com/office/drawing/2014/main" id="{7113C041-1338-4246-A6BF-8A4AB3B632E4}"/>
+                <a16:creationId xmlns:a16="http://schemas.microsoft.com/office/drawing/2014/main" id="{E4242A96-3537-497B-AA2B-F4AEEA1B3823}"/>
               </a:ext>
             </a:extLst>
           </p:cNvPr>
@@ -3745,54 +3745,54 @@
           <p:cNvPr id="4" name="">
             <a:extLst xmlns:a="http://schemas.openxmlformats.org/drawingml/2006/main">
               <a:ext uri="{FF2B5EF4-FFF2-40B4-BE49-F238E27FC236}">
-                <a16:creationId xmlns:a16="http://schemas.microsoft.com/office/drawing/2014/main" id="{2F592E29-4FED-4FAF-8125-9DEED26D95F0}"/>
-              </a:ext>
-            </a:extLst>
-          </p:cNvPr>
-          <p:cNvSpPr>
-            <a:spLocks xmlns:a="http://schemas.openxmlformats.org/drawingml/2006/main" noGrp="1"/>
-          </p:cNvSpPr>
-          <p:nvPr/>
-        </p:nvSpPr>
-        <p:spPr>
-          <a:xfrm xmlns:a="http://schemas.openxmlformats.org/drawingml/2006/main">
-            <a:off x="609600" y="2428875"/>
-            <a:ext cx="5238750" cy="419100"/>
-          </a:xfrm>
-          <a:prstGeom xmlns:a="http://schemas.openxmlformats.org/drawingml/2006/main" prst="rect">
-            <a:avLst/>
-          </a:prstGeom>
-          <a:noFill xmlns:a="http://schemas.openxmlformats.org/drawingml/2006/main"/>
-          <a:ln xmlns:a="http://schemas.openxmlformats.org/drawingml/2006/main" w="0">
-            <a:noFill/>
-          </a:ln>
-        </p:spPr>
-        <p:txBody>
-          <a:bodyPr xmlns:a="http://schemas.openxmlformats.org/drawingml/2006/main">
-            <a:noAutofit/>
-          </a:bodyPr>
-          <a:lstStyle xmlns:a="http://schemas.openxmlformats.org/drawingml/2006/main"/>
-          <a:p xmlns:a="http://schemas.openxmlformats.org/drawingml/2006/main">
-            <a:pPr>
-              <a:defRPr sz="2175" b="1">
-                <a:solidFill>
-                  <a:srgbClr val="243E35"/>
-                </a:solidFill>
-                <a:latin typeface="Helvetica Neue"/>
-                <a:ea typeface="Helvetica Neue"/>
-                <a:cs typeface="Helvetica Neue"/>
-              </a:defRPr>
-            </a:pPr>
-            <a:r>
-              <a:rPr sz="2175" b="1">
-                <a:solidFill>
-                  <a:srgbClr val="243E35"/>
-                </a:solidFill>
-                <a:latin typeface="Helvetica Neue"/>
-                <a:ea typeface="Helvetica Neue"/>
-                <a:cs typeface="Helvetica Neue"/>
-              </a:rPr>
-              <a:t>What this demonstration includes</a:t>
+                <a16:creationId xmlns:a16="http://schemas.microsoft.com/office/drawing/2014/main" id="{904F85F9-9B9B-49EA-B0FE-38BAB7069FCB}"/>
+              </a:ext>
+            </a:extLst>
+          </p:cNvPr>
+          <p:cNvSpPr>
+            <a:spLocks xmlns:a="http://schemas.openxmlformats.org/drawingml/2006/main" noGrp="1"/>
+          </p:cNvSpPr>
+          <p:nvPr/>
+        </p:nvSpPr>
+        <p:spPr>
+          <a:xfrm xmlns:a="http://schemas.openxmlformats.org/drawingml/2006/main">
+            <a:off x="609600" y="1847850"/>
+            <a:ext cx="2286000" cy="666750"/>
+          </a:xfrm>
+          <a:prstGeom xmlns:a="http://schemas.openxmlformats.org/drawingml/2006/main" prst="rect">
+            <a:avLst/>
+          </a:prstGeom>
+          <a:noFill xmlns:a="http://schemas.openxmlformats.org/drawingml/2006/main"/>
+          <a:ln xmlns:a="http://schemas.openxmlformats.org/drawingml/2006/main" w="0">
+            <a:noFill/>
+          </a:ln>
+        </p:spPr>
+        <p:txBody>
+          <a:bodyPr xmlns:a="http://schemas.openxmlformats.org/drawingml/2006/main">
+            <a:noAutofit/>
+          </a:bodyPr>
+          <a:lstStyle xmlns:a="http://schemas.openxmlformats.org/drawingml/2006/main"/>
+          <a:p xmlns:a="http://schemas.openxmlformats.org/drawingml/2006/main">
+            <a:pPr>
+              <a:defRPr sz="3900" b="1">
+                <a:solidFill>
+                  <a:srgbClr val="243E35"/>
+                </a:solidFill>
+                <a:latin typeface="Helvetica Neue"/>
+                <a:ea typeface="Helvetica Neue"/>
+                <a:cs typeface="Helvetica Neue"/>
+              </a:defRPr>
+            </a:pPr>
+            <a:r>
+              <a:rPr sz="3900" b="1">
+                <a:solidFill>
+                  <a:srgbClr val="243E35"/>
+                </a:solidFill>
+                <a:latin typeface="Helvetica Neue"/>
+                <a:ea typeface="Helvetica Neue"/>
+                <a:cs typeface="Helvetica Neue"/>
+              </a:rPr>
+              <a:t>2 weeks</a:t>
             </a:r>
           </a:p>
         </p:txBody>
@@ -3802,174 +3802,54 @@
           <p:cNvPr id="5" name="">
             <a:extLst xmlns:a="http://schemas.openxmlformats.org/drawingml/2006/main">
               <a:ext uri="{FF2B5EF4-FFF2-40B4-BE49-F238E27FC236}">
-                <a16:creationId xmlns:a16="http://schemas.microsoft.com/office/drawing/2014/main" id="{209E3E52-A101-4749-95B0-FA5D89127EAE}"/>
-              </a:ext>
-            </a:extLst>
-          </p:cNvPr>
-          <p:cNvSpPr>
-            <a:spLocks xmlns:a="http://schemas.openxmlformats.org/drawingml/2006/main" noGrp="1"/>
-          </p:cNvSpPr>
-          <p:nvPr/>
-        </p:nvSpPr>
-        <p:spPr>
-          <a:xfrm xmlns:a="http://schemas.openxmlformats.org/drawingml/2006/main">
-            <a:off x="609600" y="3038475"/>
-            <a:ext cx="5191125" cy="2571750"/>
-          </a:xfrm>
-          <a:prstGeom xmlns:a="http://schemas.openxmlformats.org/drawingml/2006/main" prst="rect">
-            <a:avLst/>
-          </a:prstGeom>
-          <a:noFill xmlns:a="http://schemas.openxmlformats.org/drawingml/2006/main"/>
-          <a:ln xmlns:a="http://schemas.openxmlformats.org/drawingml/2006/main" w="0">
-            <a:noFill/>
-          </a:ln>
-        </p:spPr>
-        <p:txBody>
-          <a:bodyPr xmlns:a="http://schemas.openxmlformats.org/drawingml/2006/main">
-            <a:noAutofit/>
-          </a:bodyPr>
-          <a:lstStyle xmlns:a="http://schemas.openxmlformats.org/drawingml/2006/main"/>
-          <a:p xmlns:a="http://schemas.openxmlformats.org/drawingml/2006/main">
-            <a:pPr>
-              <a:defRPr sz="1875" b="0">
-                <a:solidFill>
-                  <a:srgbClr val="243E35"/>
-                </a:solidFill>
-                <a:latin typeface="Helvetica Neue"/>
-                <a:ea typeface="Helvetica Neue"/>
-                <a:cs typeface="Helvetica Neue"/>
-              </a:defRPr>
-            </a:pPr>
-            <a:r>
-              <a:rPr sz="1875" b="0">
-                <a:solidFill>
-                  <a:srgbClr val="243E35"/>
-                </a:solidFill>
-                <a:latin typeface="Helvetica Neue"/>
-                <a:ea typeface="Helvetica Neue"/>
-                <a:cs typeface="Helvetica Neue"/>
-              </a:rPr>
-              <a:t>A working local Temporal process.</a:t>
-            </a:r>
-          </a:p>
-          <a:p xmlns:a="http://schemas.openxmlformats.org/drawingml/2006/main">
-            <a:pPr>
-              <a:defRPr sz="1875" b="0">
-                <a:solidFill>
-                  <a:srgbClr val="243E35"/>
-                </a:solidFill>
-                <a:latin typeface="Helvetica Neue"/>
-                <a:ea typeface="Helvetica Neue"/>
-                <a:cs typeface="Helvetica Neue"/>
-              </a:defRPr>
-            </a:pPr>
-            <a:r>
-              <a:rPr sz="1875" b="0">
-                <a:solidFill>
-                  <a:srgbClr val="243E35"/>
-                </a:solidFill>
-                <a:latin typeface="Helvetica Neue"/>
-                <a:ea typeface="Helvetica Neue"/>
-                <a:cs typeface="Helvetica Neue"/>
-              </a:rPr>
-              <a:t>Fictional waitlist and simulated texts.</a:t>
-            </a:r>
-          </a:p>
-          <a:p xmlns:a="http://schemas.openxmlformats.org/drawingml/2006/main">
-            <a:pPr>
-              <a:defRPr sz="1875" b="0">
-                <a:solidFill>
-                  <a:srgbClr val="243E35"/>
-                </a:solidFill>
-                <a:latin typeface="Helvetica Neue"/>
-                <a:ea typeface="Helvetica Neue"/>
-                <a:cs typeface="Helvetica Neue"/>
-              </a:defRPr>
-            </a:pPr>
-            <a:r>
-              <a:rPr sz="1875" b="0">
-                <a:solidFill>
-                  <a:srgbClr val="243E35"/>
-                </a:solidFill>
-                <a:latin typeface="Helvetica Neue"/>
-                <a:ea typeface="Helvetica Neue"/>
-                <a:cs typeface="Helvetica Neue"/>
-              </a:rPr>
-              <a:t>One active opening at a time.</a:t>
-            </a:r>
-          </a:p>
-          <a:p xmlns:a="http://schemas.openxmlformats.org/drawingml/2006/main">
-            <a:pPr>
-              <a:defRPr sz="1875" b="0">
-                <a:solidFill>
-                  <a:srgbClr val="243E35"/>
-                </a:solidFill>
-                <a:latin typeface="Helvetica Neue"/>
-                <a:ea typeface="Helvetica Neue"/>
-                <a:cs typeface="Helvetica Neue"/>
-              </a:defRPr>
-            </a:pPr>
-            <a:r>
-              <a:rPr sz="1875" b="0">
-                <a:solidFill>
-                  <a:srgbClr val="243E35"/>
-                </a:solidFill>
-                <a:latin typeface="Helvetica Neue"/>
-                <a:ea typeface="Helvetica Neue"/>
-                <a:cs typeface="Helvetica Neue"/>
-              </a:rPr>
-              <a:t>Manual Square confirmation.</a:t>
-            </a:r>
-          </a:p>
-          <a:p xmlns:a="http://schemas.openxmlformats.org/drawingml/2006/main">
-            <a:r>
-              <a:t/>
-            </a:r>
-          </a:p>
-          <a:p xmlns:a="http://schemas.openxmlformats.org/drawingml/2006/main">
-            <a:pPr>
-              <a:defRPr sz="1875" b="0">
-                <a:solidFill>
-                  <a:srgbClr val="243E35"/>
-                </a:solidFill>
-                <a:latin typeface="Helvetica Neue"/>
-                <a:ea typeface="Helvetica Neue"/>
-                <a:cs typeface="Helvetica Neue"/>
-              </a:defRPr>
-            </a:pPr>
-            <a:r>
-              <a:rPr sz="1875" b="0">
-                <a:solidFill>
-                  <a:srgbClr val="243E35"/>
-                </a:solidFill>
-                <a:latin typeface="Helvetica Neue"/>
-                <a:ea typeface="Helvetica Neue"/>
-                <a:cs typeface="Helvetica Neue"/>
-              </a:rPr>
-              <a:t>Quick demo: 20-second offers.</a:t>
-            </a:r>
-          </a:p>
-          <a:p xmlns:a="http://schemas.openxmlformats.org/drawingml/2006/main">
-            <a:pPr>
-              <a:defRPr sz="1875" b="0">
-                <a:solidFill>
-                  <a:srgbClr val="243E35"/>
-                </a:solidFill>
-                <a:latin typeface="Helvetica Neue"/>
-                <a:ea typeface="Helvetica Neue"/>
-                <a:cs typeface="Helvetica Neue"/>
-              </a:defRPr>
-            </a:pPr>
-            <a:r>
-              <a:rPr sz="1875" b="0">
-                <a:solidFill>
-                  <a:srgbClr val="243E35"/>
-                </a:solidFill>
-                <a:latin typeface="Helvetica Neue"/>
-                <a:ea typeface="Helvetica Neue"/>
-                <a:cs typeface="Helvetica Neue"/>
-              </a:rPr>
-              <a:t>Standard mode: 15-minute offers.</a:t>
+                <a16:creationId xmlns:a16="http://schemas.microsoft.com/office/drawing/2014/main" id="{AF568852-3276-4338-BFC7-DA4229FF7249}"/>
+              </a:ext>
+            </a:extLst>
+          </p:cNvPr>
+          <p:cNvSpPr>
+            <a:spLocks xmlns:a="http://schemas.openxmlformats.org/drawingml/2006/main" noGrp="1"/>
+          </p:cNvSpPr>
+          <p:nvPr/>
+        </p:nvSpPr>
+        <p:spPr>
+          <a:xfrm xmlns:a="http://schemas.openxmlformats.org/drawingml/2006/main">
+            <a:off x="609600" y="2524125"/>
+            <a:ext cx="2095500" cy="333375"/>
+          </a:xfrm>
+          <a:prstGeom xmlns:a="http://schemas.openxmlformats.org/drawingml/2006/main" prst="rect">
+            <a:avLst/>
+          </a:prstGeom>
+          <a:noFill xmlns:a="http://schemas.openxmlformats.org/drawingml/2006/main"/>
+          <a:ln xmlns:a="http://schemas.openxmlformats.org/drawingml/2006/main" w="0">
+            <a:noFill/>
+          </a:ln>
+        </p:spPr>
+        <p:txBody>
+          <a:bodyPr xmlns:a="http://schemas.openxmlformats.org/drawingml/2006/main">
+            <a:noAutofit/>
+          </a:bodyPr>
+          <a:lstStyle xmlns:a="http://schemas.openxmlformats.org/drawingml/2006/main"/>
+          <a:p xmlns:a="http://schemas.openxmlformats.org/drawingml/2006/main">
+            <a:pPr>
+              <a:defRPr sz="1725" b="0">
+                <a:solidFill>
+                  <a:srgbClr val="617166"/>
+                </a:solidFill>
+                <a:latin typeface="Helvetica Neue"/>
+                <a:ea typeface="Helvetica Neue"/>
+                <a:cs typeface="Helvetica Neue"/>
+              </a:defRPr>
+            </a:pPr>
+            <a:r>
+              <a:rPr sz="1725" b="0">
+                <a:solidFill>
+                  <a:srgbClr val="617166"/>
+                </a:solidFill>
+                <a:latin typeface="Helvetica Neue"/>
+                <a:ea typeface="Helvetica Neue"/>
+                <a:cs typeface="Helvetica Neue"/>
+              </a:rPr>
+              <a:t>trial length</a:t>
             </a:r>
           </a:p>
         </p:txBody>
@@ -3979,54 +3859,54 @@
           <p:cNvPr id="6" name="">
             <a:extLst xmlns:a="http://schemas.openxmlformats.org/drawingml/2006/main">
               <a:ext uri="{FF2B5EF4-FFF2-40B4-BE49-F238E27FC236}">
-                <a16:creationId xmlns:a16="http://schemas.microsoft.com/office/drawing/2014/main" id="{3A9B8D80-C27D-4D64-921D-E39736ADD737}"/>
-              </a:ext>
-            </a:extLst>
-          </p:cNvPr>
-          <p:cNvSpPr>
-            <a:spLocks xmlns:a="http://schemas.openxmlformats.org/drawingml/2006/main" noGrp="1"/>
-          </p:cNvSpPr>
-          <p:nvPr/>
-        </p:nvSpPr>
-        <p:spPr>
-          <a:xfrm xmlns:a="http://schemas.openxmlformats.org/drawingml/2006/main">
-            <a:off x="6705600" y="2428875"/>
-            <a:ext cx="4857750" cy="419100"/>
-          </a:xfrm>
-          <a:prstGeom xmlns:a="http://schemas.openxmlformats.org/drawingml/2006/main" prst="rect">
-            <a:avLst/>
-          </a:prstGeom>
-          <a:noFill xmlns:a="http://schemas.openxmlformats.org/drawingml/2006/main"/>
-          <a:ln xmlns:a="http://schemas.openxmlformats.org/drawingml/2006/main" w="0">
-            <a:noFill/>
-          </a:ln>
-        </p:spPr>
-        <p:txBody>
-          <a:bodyPr xmlns:a="http://schemas.openxmlformats.org/drawingml/2006/main">
-            <a:noAutofit/>
-          </a:bodyPr>
-          <a:lstStyle xmlns:a="http://schemas.openxmlformats.org/drawingml/2006/main"/>
-          <a:p xmlns:a="http://schemas.openxmlformats.org/drawingml/2006/main">
-            <a:pPr>
-              <a:defRPr sz="2175" b="1">
-                <a:solidFill>
-                  <a:srgbClr val="243E35"/>
-                </a:solidFill>
-                <a:latin typeface="Helvetica Neue"/>
-                <a:ea typeface="Helvetica Neue"/>
-                <a:cs typeface="Helvetica Neue"/>
-              </a:defRPr>
-            </a:pPr>
-            <a:r>
-              <a:rPr sz="2175" b="1">
-                <a:solidFill>
-                  <a:srgbClr val="243E35"/>
-                </a:solidFill>
-                <a:latin typeface="Helvetica Neue"/>
-                <a:ea typeface="Helvetica Neue"/>
-                <a:cs typeface="Helvetica Neue"/>
-              </a:rPr>
-              <a:t>Before contacting real clients</a:t>
+                <a16:creationId xmlns:a16="http://schemas.microsoft.com/office/drawing/2014/main" id="{19535AD4-5A01-4DFD-BA4B-FA9149191549}"/>
+              </a:ext>
+            </a:extLst>
+          </p:cNvPr>
+          <p:cNvSpPr>
+            <a:spLocks xmlns:a="http://schemas.openxmlformats.org/drawingml/2006/main" noGrp="1"/>
+          </p:cNvSpPr>
+          <p:nvPr/>
+        </p:nvSpPr>
+        <p:spPr>
+          <a:xfrm xmlns:a="http://schemas.openxmlformats.org/drawingml/2006/main">
+            <a:off x="3143250" y="1847850"/>
+            <a:ext cx="2095500" cy="666750"/>
+          </a:xfrm>
+          <a:prstGeom xmlns:a="http://schemas.openxmlformats.org/drawingml/2006/main" prst="rect">
+            <a:avLst/>
+          </a:prstGeom>
+          <a:noFill xmlns:a="http://schemas.openxmlformats.org/drawingml/2006/main"/>
+          <a:ln xmlns:a="http://schemas.openxmlformats.org/drawingml/2006/main" w="0">
+            <a:noFill/>
+          </a:ln>
+        </p:spPr>
+        <p:txBody>
+          <a:bodyPr xmlns:a="http://schemas.openxmlformats.org/drawingml/2006/main">
+            <a:noAutofit/>
+          </a:bodyPr>
+          <a:lstStyle xmlns:a="http://schemas.openxmlformats.org/drawingml/2006/main"/>
+          <a:p xmlns:a="http://schemas.openxmlformats.org/drawingml/2006/main">
+            <a:pPr>
+              <a:defRPr sz="3900" b="1">
+                <a:solidFill>
+                  <a:srgbClr val="243E35"/>
+                </a:solidFill>
+                <a:latin typeface="Helvetica Neue"/>
+                <a:ea typeface="Helvetica Neue"/>
+                <a:cs typeface="Helvetica Neue"/>
+              </a:defRPr>
+            </a:pPr>
+            <a:r>
+              <a:rPr sz="3900" b="1">
+                <a:solidFill>
+                  <a:srgbClr val="243E35"/>
+                </a:solidFill>
+                <a:latin typeface="Helvetica Neue"/>
+                <a:ea typeface="Helvetica Neue"/>
+                <a:cs typeface="Helvetica Neue"/>
+              </a:rPr>
+              <a:t>≥50%</a:t>
             </a:r>
           </a:p>
         </p:txBody>
@@ -4036,174 +3916,54 @@
           <p:cNvPr id="7" name="">
             <a:extLst xmlns:a="http://schemas.openxmlformats.org/drawingml/2006/main">
               <a:ext uri="{FF2B5EF4-FFF2-40B4-BE49-F238E27FC236}">
-                <a16:creationId xmlns:a16="http://schemas.microsoft.com/office/drawing/2014/main" id="{06F929FA-F197-4718-A629-4A1A51B14A3D}"/>
-              </a:ext>
-            </a:extLst>
-          </p:cNvPr>
-          <p:cNvSpPr>
-            <a:spLocks xmlns:a="http://schemas.openxmlformats.org/drawingml/2006/main" noGrp="1"/>
-          </p:cNvSpPr>
-          <p:nvPr/>
-        </p:nvSpPr>
-        <p:spPr>
-          <a:xfrm xmlns:a="http://schemas.openxmlformats.org/drawingml/2006/main">
-            <a:off x="6705600" y="3038475"/>
-            <a:ext cx="4857750" cy="2857500"/>
-          </a:xfrm>
-          <a:prstGeom xmlns:a="http://schemas.openxmlformats.org/drawingml/2006/main" prst="rect">
-            <a:avLst/>
-          </a:prstGeom>
-          <a:noFill xmlns:a="http://schemas.openxmlformats.org/drawingml/2006/main"/>
-          <a:ln xmlns:a="http://schemas.openxmlformats.org/drawingml/2006/main" w="0">
-            <a:noFill/>
-          </a:ln>
-        </p:spPr>
-        <p:txBody>
-          <a:bodyPr xmlns:a="http://schemas.openxmlformats.org/drawingml/2006/main">
-            <a:noAutofit/>
-          </a:bodyPr>
-          <a:lstStyle xmlns:a="http://schemas.openxmlformats.org/drawingml/2006/main"/>
-          <a:p xmlns:a="http://schemas.openxmlformats.org/drawingml/2006/main">
-            <a:pPr>
-              <a:defRPr sz="1875" b="0">
-                <a:solidFill>
-                  <a:srgbClr val="243E35"/>
-                </a:solidFill>
-                <a:latin typeface="Helvetica Neue"/>
-                <a:ea typeface="Helvetica Neue"/>
-                <a:cs typeface="Helvetica Neue"/>
-              </a:defRPr>
-            </a:pPr>
-            <a:r>
-              <a:rPr sz="1875" b="0">
-                <a:solidFill>
-                  <a:srgbClr val="243E35"/>
-                </a:solidFill>
-                <a:latin typeface="Helvetica Neue"/>
-                <a:ea typeface="Helvetica Neue"/>
-                <a:cs typeface="Helvetica Neue"/>
-              </a:rPr>
-              <a:t>Connect the waitlist and SMS provider.</a:t>
-            </a:r>
-          </a:p>
-          <a:p xmlns:a="http://schemas.openxmlformats.org/drawingml/2006/main">
-            <a:pPr>
-              <a:defRPr sz="1875" b="0">
-                <a:solidFill>
-                  <a:srgbClr val="243E35"/>
-                </a:solidFill>
-                <a:latin typeface="Helvetica Neue"/>
-                <a:ea typeface="Helvetica Neue"/>
-                <a:cs typeface="Helvetica Neue"/>
-              </a:defRPr>
-            </a:pPr>
-            <a:r>
-              <a:rPr sz="1875" b="0">
-                <a:solidFill>
-                  <a:srgbClr val="243E35"/>
-                </a:solidFill>
-                <a:latin typeface="Helvetica Neue"/>
-                <a:ea typeface="Helvetica Neue"/>
-                <a:cs typeface="Helvetica Neue"/>
-              </a:rPr>
-              <a:t>Add staff sign-in, consent records, and</a:t>
-            </a:r>
-          </a:p>
-          <a:p xmlns:a="http://schemas.openxmlformats.org/drawingml/2006/main">
-            <a:pPr>
-              <a:defRPr sz="1875" b="0">
-                <a:solidFill>
-                  <a:srgbClr val="243E35"/>
-                </a:solidFill>
-                <a:latin typeface="Helvetica Neue"/>
-                <a:ea typeface="Helvetica Neue"/>
-                <a:cs typeface="Helvetica Neue"/>
-              </a:defRPr>
-            </a:pPr>
-            <a:r>
-              <a:rPr sz="1875" b="0">
-                <a:solidFill>
-                  <a:srgbClr val="243E35"/>
-                </a:solidFill>
-                <a:latin typeface="Helvetica Neue"/>
-                <a:ea typeface="Helvetica Neue"/>
-                <a:cs typeface="Helvetica Neue"/>
-              </a:rPr>
-              <a:t>booking reconciliation with Square.</a:t>
-            </a:r>
-          </a:p>
-          <a:p xmlns:a="http://schemas.openxmlformats.org/drawingml/2006/main">
-            <a:r>
-              <a:t/>
-            </a:r>
-          </a:p>
-          <a:p xmlns:a="http://schemas.openxmlformats.org/drawingml/2006/main">
-            <a:pPr>
-              <a:defRPr sz="1875" b="0">
-                <a:solidFill>
-                  <a:srgbClr val="243E35"/>
-                </a:solidFill>
-                <a:latin typeface="Helvetica Neue"/>
-                <a:ea typeface="Helvetica Neue"/>
-                <a:cs typeface="Helvetica Neue"/>
-              </a:defRPr>
-            </a:pPr>
-            <a:r>
-              <a:rPr sz="1875" b="0">
-                <a:solidFill>
-                  <a:srgbClr val="243E35"/>
-                </a:solidFill>
-                <a:latin typeface="Helvetica Neue"/>
-                <a:ea typeface="Helvetica Neue"/>
-                <a:cs typeface="Helvetica Neue"/>
-              </a:rPr>
-              <a:t>Then Lena and Carla try a two-week pilot.</a:t>
-            </a:r>
-          </a:p>
-          <a:p xmlns:a="http://schemas.openxmlformats.org/drawingml/2006/main">
-            <a:pPr>
-              <a:defRPr sz="1875" b="0">
-                <a:solidFill>
-                  <a:srgbClr val="243E35"/>
-                </a:solidFill>
-                <a:latin typeface="Helvetica Neue"/>
-                <a:ea typeface="Helvetica Neue"/>
-                <a:cs typeface="Helvetica Neue"/>
-              </a:defRPr>
-            </a:pPr>
-            <a:r>
-              <a:rPr sz="1875" b="0">
-                <a:solidFill>
-                  <a:srgbClr val="243E35"/>
-                </a:solidFill>
-                <a:latin typeface="Helvetica Neue"/>
-                <a:ea typeface="Helvetica Neue"/>
-                <a:cs typeface="Helvetica Neue"/>
-              </a:rPr>
-              <a:t>Track confirmed refills / eligible openings,</a:t>
-            </a:r>
-          </a:p>
-          <a:p xmlns:a="http://schemas.openxmlformats.org/drawingml/2006/main">
-            <a:pPr>
-              <a:defRPr sz="1875" b="0">
-                <a:solidFill>
-                  <a:srgbClr val="243E35"/>
-                </a:solidFill>
-                <a:latin typeface="Helvetica Neue"/>
-                <a:ea typeface="Helvetica Neue"/>
-                <a:cs typeface="Helvetica Neue"/>
-              </a:defRPr>
-            </a:pPr>
-            <a:r>
-              <a:rPr sz="1875" b="0">
-                <a:solidFill>
-                  <a:srgbClr val="243E35"/>
-                </a:solidFill>
-                <a:latin typeface="Helvetica Neue"/>
-                <a:ea typeface="Helvetica Neue"/>
-                <a:cs typeface="Helvetica Neue"/>
-              </a:rPr>
-              <a:t>staff follow-ups, and booking conflicts.</a:t>
+                <a16:creationId xmlns:a16="http://schemas.microsoft.com/office/drawing/2014/main" id="{0907EE51-502C-4700-A4DB-B0B0E823EEA4}"/>
+              </a:ext>
+            </a:extLst>
+          </p:cNvPr>
+          <p:cNvSpPr>
+            <a:spLocks xmlns:a="http://schemas.openxmlformats.org/drawingml/2006/main" noGrp="1"/>
+          </p:cNvSpPr>
+          <p:nvPr/>
+        </p:nvSpPr>
+        <p:spPr>
+          <a:xfrm xmlns:a="http://schemas.openxmlformats.org/drawingml/2006/main">
+            <a:off x="3143250" y="2524125"/>
+            <a:ext cx="2857500" cy="333375"/>
+          </a:xfrm>
+          <a:prstGeom xmlns:a="http://schemas.openxmlformats.org/drawingml/2006/main" prst="rect">
+            <a:avLst/>
+          </a:prstGeom>
+          <a:noFill xmlns:a="http://schemas.openxmlformats.org/drawingml/2006/main"/>
+          <a:ln xmlns:a="http://schemas.openxmlformats.org/drawingml/2006/main" w="0">
+            <a:noFill/>
+          </a:ln>
+        </p:spPr>
+        <p:txBody>
+          <a:bodyPr xmlns:a="http://schemas.openxmlformats.org/drawingml/2006/main">
+            <a:noAutofit/>
+          </a:bodyPr>
+          <a:lstStyle xmlns:a="http://schemas.openxmlformats.org/drawingml/2006/main"/>
+          <a:p xmlns:a="http://schemas.openxmlformats.org/drawingml/2006/main">
+            <a:pPr>
+              <a:defRPr sz="1725" b="0">
+                <a:solidFill>
+                  <a:srgbClr val="617166"/>
+                </a:solidFill>
+                <a:latin typeface="Helvetica Neue"/>
+                <a:ea typeface="Helvetica Neue"/>
+                <a:cs typeface="Helvetica Neue"/>
+              </a:defRPr>
+            </a:pPr>
+            <a:r>
+              <a:rPr sz="1725" b="0">
+                <a:solidFill>
+                  <a:srgbClr val="617166"/>
+                </a:solidFill>
+                <a:latin typeface="Helvetica Neue"/>
+                <a:ea typeface="Helvetica Neue"/>
+                <a:cs typeface="Helvetica Neue"/>
+              </a:rPr>
+              <a:t>openings refilled: target</a:t>
             </a:r>
           </a:p>
         </p:txBody>
@@ -4213,36 +3973,93 @@
           <p:cNvPr id="8" name="">
             <a:extLst xmlns:a="http://schemas.openxmlformats.org/drawingml/2006/main">
               <a:ext uri="{FF2B5EF4-FFF2-40B4-BE49-F238E27FC236}">
-                <a16:creationId xmlns:a16="http://schemas.microsoft.com/office/drawing/2014/main" id="{DE08D76B-C418-4D74-B0D2-5D04F50800E1}"/>
-              </a:ext>
-            </a:extLst>
-          </p:cNvPr>
-          <p:cNvSpPr>
-            <a:spLocks xmlns:a="http://schemas.openxmlformats.org/drawingml/2006/main" noGrp="1"/>
-          </p:cNvSpPr>
-          <p:nvPr/>
-        </p:nvSpPr>
-        <p:spPr>
-          <a:xfrm xmlns:a="http://schemas.openxmlformats.org/drawingml/2006/main">
-            <a:off x="609600" y="6076950"/>
-            <a:ext cx="10668000" cy="523875"/>
-          </a:xfrm>
-          <a:prstGeom xmlns:a="http://schemas.openxmlformats.org/drawingml/2006/main" prst="rect">
-            <a:avLst/>
-          </a:prstGeom>
-          <a:noFill xmlns:a="http://schemas.openxmlformats.org/drawingml/2006/main"/>
-          <a:ln xmlns:a="http://schemas.openxmlformats.org/drawingml/2006/main" w="0">
-            <a:noFill/>
-          </a:ln>
-        </p:spPr>
-        <p:txBody>
-          <a:bodyPr xmlns:a="http://schemas.openxmlformats.org/drawingml/2006/main">
-            <a:noAutofit/>
-          </a:bodyPr>
-          <a:lstStyle xmlns:a="http://schemas.openxmlformats.org/drawingml/2006/main"/>
-          <a:p xmlns:a="http://schemas.openxmlformats.org/drawingml/2006/main">
-            <a:pPr>
-              <a:defRPr sz="1425" b="0">
+                <a16:creationId xmlns:a16="http://schemas.microsoft.com/office/drawing/2014/main" id="{C3E62FF1-7CCF-449B-8731-209B7CD5D07D}"/>
+              </a:ext>
+            </a:extLst>
+          </p:cNvPr>
+          <p:cNvSpPr>
+            <a:spLocks xmlns:a="http://schemas.openxmlformats.org/drawingml/2006/main" noGrp="1"/>
+          </p:cNvSpPr>
+          <p:nvPr/>
+        </p:nvSpPr>
+        <p:spPr>
+          <a:xfrm xmlns:a="http://schemas.openxmlformats.org/drawingml/2006/main">
+            <a:off x="6229350" y="1847850"/>
+            <a:ext cx="1619250" cy="666750"/>
+          </a:xfrm>
+          <a:prstGeom xmlns:a="http://schemas.openxmlformats.org/drawingml/2006/main" prst="rect">
+            <a:avLst/>
+          </a:prstGeom>
+          <a:noFill xmlns:a="http://schemas.openxmlformats.org/drawingml/2006/main"/>
+          <a:ln xmlns:a="http://schemas.openxmlformats.org/drawingml/2006/main" w="0">
+            <a:noFill/>
+          </a:ln>
+        </p:spPr>
+        <p:txBody>
+          <a:bodyPr xmlns:a="http://schemas.openxmlformats.org/drawingml/2006/main">
+            <a:noAutofit/>
+          </a:bodyPr>
+          <a:lstStyle xmlns:a="http://schemas.openxmlformats.org/drawingml/2006/main"/>
+          <a:p xmlns:a="http://schemas.openxmlformats.org/drawingml/2006/main">
+            <a:pPr>
+              <a:defRPr sz="3900" b="1">
+                <a:solidFill>
+                  <a:srgbClr val="243E35"/>
+                </a:solidFill>
+                <a:latin typeface="Helvetica Neue"/>
+                <a:ea typeface="Helvetica Neue"/>
+                <a:cs typeface="Helvetica Neue"/>
+              </a:defRPr>
+            </a:pPr>
+            <a:r>
+              <a:rPr sz="3900" b="1">
+                <a:solidFill>
+                  <a:srgbClr val="243E35"/>
+                </a:solidFill>
+                <a:latin typeface="Helvetica Neue"/>
+                <a:ea typeface="Helvetica Neue"/>
+                <a:cs typeface="Helvetica Neue"/>
+              </a:rPr>
+              <a:t>0</a:t>
+            </a:r>
+          </a:p>
+        </p:txBody>
+      </p:sp>
+      <p:sp>
+        <p:nvSpPr>
+          <p:cNvPr id="9" name="">
+            <a:extLst xmlns:a="http://schemas.openxmlformats.org/drawingml/2006/main">
+              <a:ext uri="{FF2B5EF4-FFF2-40B4-BE49-F238E27FC236}">
+                <a16:creationId xmlns:a16="http://schemas.microsoft.com/office/drawing/2014/main" id="{1915E6C9-BC43-420C-848C-77CC3722030A}"/>
+              </a:ext>
+            </a:extLst>
+          </p:cNvPr>
+          <p:cNvSpPr>
+            <a:spLocks xmlns:a="http://schemas.openxmlformats.org/drawingml/2006/main" noGrp="1"/>
+          </p:cNvSpPr>
+          <p:nvPr/>
+        </p:nvSpPr>
+        <p:spPr>
+          <a:xfrm xmlns:a="http://schemas.openxmlformats.org/drawingml/2006/main">
+            <a:off x="6229350" y="2524125"/>
+            <a:ext cx="3333750" cy="333375"/>
+          </a:xfrm>
+          <a:prstGeom xmlns:a="http://schemas.openxmlformats.org/drawingml/2006/main" prst="rect">
+            <a:avLst/>
+          </a:prstGeom>
+          <a:noFill xmlns:a="http://schemas.openxmlformats.org/drawingml/2006/main"/>
+          <a:ln xmlns:a="http://schemas.openxmlformats.org/drawingml/2006/main" w="0">
+            <a:noFill/>
+          </a:ln>
+        </p:spPr>
+        <p:txBody>
+          <a:bodyPr xmlns:a="http://schemas.openxmlformats.org/drawingml/2006/main">
+            <a:noAutofit/>
+          </a:bodyPr>
+          <a:lstStyle xmlns:a="http://schemas.openxmlformats.org/drawingml/2006/main"/>
+          <a:p xmlns:a="http://schemas.openxmlformats.org/drawingml/2006/main">
+            <a:pPr>
+              <a:defRPr sz="1725" b="0">
                 <a:solidFill>
                   <a:srgbClr val="617166"/>
                 </a:solidFill>
@@ -4252,7 +4069,7 @@
               </a:defRPr>
             </a:pPr>
             <a:r>
-              <a:rPr sz="1425" b="0">
+              <a:rPr sz="1725" b="0">
                 <a:solidFill>
                   <a:srgbClr val="617166"/>
                 </a:solidFill>
@@ -4260,7 +4077,846 @@
                 <a:ea typeface="Helvetica Neue"/>
                 <a:cs typeface="Helvetica Neue"/>
               </a:rPr>
-              <a:t>Decision: aim for ≥50% refilled, fewer manual checks, and no conflicting booking promises. Results are still to be measured.</a:t>
+              <a:t>slots promised to two clients</a:t>
+            </a:r>
+          </a:p>
+        </p:txBody>
+      </p:sp>
+      <p:sp>
+        <p:nvSpPr>
+          <p:cNvPr id="10" name="">
+            <a:extLst xmlns:a="http://schemas.openxmlformats.org/drawingml/2006/main">
+              <a:ext uri="{FF2B5EF4-FFF2-40B4-BE49-F238E27FC236}">
+                <a16:creationId xmlns:a16="http://schemas.microsoft.com/office/drawing/2014/main" id="{442039A8-D9CB-496F-A9E7-5EB0D1979C1C}"/>
+              </a:ext>
+            </a:extLst>
+          </p:cNvPr>
+          <p:cNvSpPr>
+            <a:spLocks xmlns:a="http://schemas.openxmlformats.org/drawingml/2006/main" noGrp="1"/>
+          </p:cNvSpPr>
+          <p:nvPr/>
+        </p:nvSpPr>
+        <p:spPr>
+          <a:xfrm xmlns:a="http://schemas.openxmlformats.org/drawingml/2006/main">
+            <a:off x="609600" y="3124200"/>
+            <a:ext cx="6762750" cy="381000"/>
+          </a:xfrm>
+          <a:prstGeom xmlns:a="http://schemas.openxmlformats.org/drawingml/2006/main" prst="rect">
+            <a:avLst/>
+          </a:prstGeom>
+          <a:noFill xmlns:a="http://schemas.openxmlformats.org/drawingml/2006/main"/>
+          <a:ln xmlns:a="http://schemas.openxmlformats.org/drawingml/2006/main" w="0">
+            <a:noFill/>
+          </a:ln>
+        </p:spPr>
+        <p:txBody>
+          <a:bodyPr xmlns:a="http://schemas.openxmlformats.org/drawingml/2006/main">
+            <a:noAutofit/>
+          </a:bodyPr>
+          <a:lstStyle xmlns:a="http://schemas.openxmlformats.org/drawingml/2006/main"/>
+          <a:p xmlns:a="http://schemas.openxmlformats.org/drawingml/2006/main">
+            <a:pPr>
+              <a:defRPr sz="2100" b="1">
+                <a:solidFill>
+                  <a:srgbClr val="243E35"/>
+                </a:solidFill>
+                <a:latin typeface="Helvetica Neue"/>
+                <a:ea typeface="Helvetica Neue"/>
+                <a:cs typeface="Helvetica Neue"/>
+              </a:defRPr>
+            </a:pPr>
+            <a:r>
+              <a:rPr sz="2100" b="1">
+                <a:solidFill>
+                  <a:srgbClr val="243E35"/>
+                </a:solidFill>
+                <a:latin typeface="Helvetica Neue"/>
+                <a:ea typeface="Helvetica Neue"/>
+                <a:cs typeface="Helvetica Neue"/>
+              </a:rPr>
+              <a:t>Before the first real text</a:t>
+            </a:r>
+          </a:p>
+        </p:txBody>
+      </p:sp>
+      <p:sp>
+        <p:nvSpPr>
+          <p:cNvPr id="11" name="">
+            <a:extLst xmlns:a="http://schemas.openxmlformats.org/drawingml/2006/main">
+              <a:ext uri="{FF2B5EF4-FFF2-40B4-BE49-F238E27FC236}">
+                <a16:creationId xmlns:a16="http://schemas.microsoft.com/office/drawing/2014/main" id="{B4B5B455-783E-4287-9FF6-EE2FC9CD52E7}"/>
+              </a:ext>
+            </a:extLst>
+          </p:cNvPr>
+          <p:cNvSpPr>
+            <a:spLocks xmlns:a="http://schemas.openxmlformats.org/drawingml/2006/main" noGrp="1"/>
+          </p:cNvSpPr>
+          <p:nvPr/>
+        </p:nvSpPr>
+        <p:spPr>
+          <a:xfrm xmlns:a="http://schemas.openxmlformats.org/drawingml/2006/main">
+            <a:off x="609600" y="3590925"/>
+            <a:ext cx="7000875" cy="1285875"/>
+          </a:xfrm>
+          <a:prstGeom xmlns:a="http://schemas.openxmlformats.org/drawingml/2006/main" prst="rect">
+            <a:avLst/>
+          </a:prstGeom>
+          <a:noFill xmlns:a="http://schemas.openxmlformats.org/drawingml/2006/main"/>
+          <a:ln xmlns:a="http://schemas.openxmlformats.org/drawingml/2006/main" w="0">
+            <a:noFill/>
+          </a:ln>
+        </p:spPr>
+        <p:txBody>
+          <a:bodyPr xmlns:a="http://schemas.openxmlformats.org/drawingml/2006/main">
+            <a:noAutofit/>
+          </a:bodyPr>
+          <a:lstStyle xmlns:a="http://schemas.openxmlformats.org/drawingml/2006/main"/>
+          <a:p xmlns:a="http://schemas.openxmlformats.org/drawingml/2006/main">
+            <a:pPr marL="228600" indent="-114300">
+              <a:spcAft>
+                <a:spcPts val="900"/>
+              </a:spcAft>
+              <a:buChar char="•"/>
+              <a:defRPr sz="1800" b="0">
+                <a:solidFill>
+                  <a:srgbClr val="243E35"/>
+                </a:solidFill>
+                <a:latin typeface="Helvetica Neue"/>
+                <a:ea typeface="Helvetica Neue"/>
+                <a:cs typeface="Helvetica Neue"/>
+              </a:defRPr>
+            </a:pPr>
+            <a:r>
+              <a:rPr sz="1800" b="0">
+                <a:solidFill>
+                  <a:srgbClr val="243E35"/>
+                </a:solidFill>
+                <a:latin typeface="Helvetica Neue"/>
+                <a:ea typeface="Helvetica Neue"/>
+                <a:cs typeface="Helvetica Neue"/>
+              </a:rPr>
+              <a:t>Connect real texts and the waitlist.</a:t>
+            </a:r>
+          </a:p>
+          <a:p xmlns:a="http://schemas.openxmlformats.org/drawingml/2006/main">
+            <a:pPr marL="228600" indent="-114300">
+              <a:spcAft>
+                <a:spcPts val="900"/>
+              </a:spcAft>
+              <a:buChar char="•"/>
+              <a:defRPr sz="1800" b="0">
+                <a:solidFill>
+                  <a:srgbClr val="243E35"/>
+                </a:solidFill>
+                <a:latin typeface="Helvetica Neue"/>
+                <a:ea typeface="Helvetica Neue"/>
+                <a:cs typeface="Helvetica Neue"/>
+              </a:defRPr>
+            </a:pPr>
+            <a:r>
+              <a:rPr sz="1800" b="0">
+                <a:solidFill>
+                  <a:srgbClr val="243E35"/>
+                </a:solidFill>
+                <a:latin typeface="Helvetica Neue"/>
+                <a:ea typeface="Helvetica Neue"/>
+                <a:cs typeface="Helvetica Neue"/>
+              </a:rPr>
+              <a:t>Add staff sign-in and permission to text clients.</a:t>
+            </a:r>
+          </a:p>
+          <a:p xmlns:a="http://schemas.openxmlformats.org/drawingml/2006/main">
+            <a:pPr marL="228600" indent="-114300">
+              <a:spcAft>
+                <a:spcPts val="900"/>
+              </a:spcAft>
+              <a:buChar char="•"/>
+              <a:defRPr sz="1800" b="0">
+                <a:solidFill>
+                  <a:srgbClr val="243E35"/>
+                </a:solidFill>
+                <a:latin typeface="Helvetica Neue"/>
+                <a:ea typeface="Helvetica Neue"/>
+                <a:cs typeface="Helvetica Neue"/>
+              </a:defRPr>
+            </a:pPr>
+            <a:r>
+              <a:rPr sz="1800" b="0">
+                <a:solidFill>
+                  <a:srgbClr val="243E35"/>
+                </a:solidFill>
+                <a:latin typeface="Helvetica Neue"/>
+                <a:ea typeface="Helvetica Neue"/>
+                <a:cs typeface="Helvetica Neue"/>
+              </a:rPr>
+              <a:t>Check Square before confirming each booking.</a:t>
+            </a:r>
+          </a:p>
+        </p:txBody>
+      </p:sp>
+      <p:pic>
+        <p:nvPicPr>
+          <p:cNvPr id="36" name=""/>
+          <p:cNvPicPr>
+            <a:picLocks xmlns:a="http://schemas.openxmlformats.org/drawingml/2006/main" noChangeAspect="1"/>
+          </p:cNvPicPr>
+          <p:nvPr/>
+        </p:nvPicPr>
+        <p:blipFill>
+          <a:blip xmlns:r="http://schemas.openxmlformats.org/officeDocument/2006/relationships" xmlns:a="http://schemas.openxmlformats.org/drawingml/2006/main" r:embed="R1eb257aac937472d"/>
+          <a:stretch xmlns:a="http://schemas.openxmlformats.org/drawingml/2006/main"/>
+        </p:blipFill>
+        <p:spPr>
+          <a:xfrm xmlns:a="http://schemas.openxmlformats.org/drawingml/2006/main">
+            <a:off x="7717790" y="3143250"/>
+            <a:ext cx="3900170" cy="1581150"/>
+          </a:xfrm>
+          <a:prstGeom xmlns:a="http://schemas.openxmlformats.org/drawingml/2006/main" prst="rect">
+            <a:avLst/>
+          </a:prstGeom>
+        </p:spPr>
+      </p:pic>
+      <p:sp>
+        <p:nvSpPr>
+          <p:cNvPr id="13" name="">
+            <a:extLst xmlns:a="http://schemas.openxmlformats.org/drawingml/2006/main">
+              <a:ext uri="{FF2B5EF4-FFF2-40B4-BE49-F238E27FC236}">
+                <a16:creationId xmlns:a16="http://schemas.microsoft.com/office/drawing/2014/main" id="{BA9B6797-081B-46AF-A557-CDC1700F0E39}"/>
+              </a:ext>
+            </a:extLst>
+          </p:cNvPr>
+          <p:cNvSpPr>
+            <a:spLocks xmlns:a="http://schemas.openxmlformats.org/drawingml/2006/main" noGrp="1"/>
+          </p:cNvSpPr>
+          <p:nvPr/>
+        </p:nvSpPr>
+        <p:spPr>
+          <a:xfrm xmlns:a="http://schemas.openxmlformats.org/drawingml/2006/main">
+            <a:off x="8524875" y="4791075"/>
+            <a:ext cx="3190875" cy="457200"/>
+          </a:xfrm>
+          <a:prstGeom xmlns:a="http://schemas.openxmlformats.org/drawingml/2006/main" prst="rect">
+            <a:avLst/>
+          </a:prstGeom>
+          <a:noFill xmlns:a="http://schemas.openxmlformats.org/drawingml/2006/main"/>
+          <a:ln xmlns:a="http://schemas.openxmlformats.org/drawingml/2006/main" w="0">
+            <a:noFill/>
+          </a:ln>
+        </p:spPr>
+        <p:txBody>
+          <a:bodyPr xmlns:a="http://schemas.openxmlformats.org/drawingml/2006/main">
+            <a:noAutofit/>
+          </a:bodyPr>
+          <a:lstStyle xmlns:a="http://schemas.openxmlformats.org/drawingml/2006/main"/>
+          <a:p xmlns:a="http://schemas.openxmlformats.org/drawingml/2006/main">
+            <a:pPr>
+              <a:defRPr sz="1275" b="0">
+                <a:solidFill>
+                  <a:srgbClr val="617166"/>
+                </a:solidFill>
+                <a:latin typeface="Helvetica Neue"/>
+                <a:ea typeface="Helvetica Neue"/>
+                <a:cs typeface="Helvetica Neue"/>
+              </a:defRPr>
+            </a:pPr>
+            <a:r>
+              <a:rPr sz="1275" b="0">
+                <a:solidFill>
+                  <a:srgbClr val="617166"/>
+                </a:solidFill>
+                <a:latin typeface="Helvetica Neue"/>
+                <a:ea typeface="Helvetica Neue"/>
+                <a:cs typeface="Helvetica Neue"/>
+              </a:rPr>
+              <a:t>Demo: fictional clients and texts.</a:t>
+            </a:r>
+          </a:p>
+          <a:p xmlns:a="http://schemas.openxmlformats.org/drawingml/2006/main">
+            <a:pPr>
+              <a:defRPr sz="1275" b="0">
+                <a:solidFill>
+                  <a:srgbClr val="617166"/>
+                </a:solidFill>
+                <a:latin typeface="Helvetica Neue"/>
+                <a:ea typeface="Helvetica Neue"/>
+                <a:cs typeface="Helvetica Neue"/>
+              </a:defRPr>
+            </a:pPr>
+            <a:r>
+              <a:rPr sz="1275" b="0">
+                <a:solidFill>
+                  <a:srgbClr val="617166"/>
+                </a:solidFill>
+                <a:latin typeface="Helvetica Neue"/>
+                <a:ea typeface="Helvetica Neue"/>
+                <a:cs typeface="Helvetica Neue"/>
+              </a:rPr>
+              <a:t>Staff still update Square manually.</a:t>
+            </a:r>
+          </a:p>
+        </p:txBody>
+      </p:sp>
+      <p:sp>
+        <p:nvSpPr>
+          <p:cNvPr id="14" name="">
+            <a:extLst xmlns:a="http://schemas.openxmlformats.org/drawingml/2006/main">
+              <a:ext uri="{FF2B5EF4-FFF2-40B4-BE49-F238E27FC236}">
+                <a16:creationId xmlns:a16="http://schemas.microsoft.com/office/drawing/2014/main" id="{FD9503E6-784A-4698-8AC4-301D3CE6B650}"/>
+              </a:ext>
+            </a:extLst>
+          </p:cNvPr>
+          <p:cNvSpPr>
+            <a:spLocks xmlns:a="http://schemas.openxmlformats.org/drawingml/2006/main" noGrp="1"/>
+          </p:cNvSpPr>
+          <p:nvPr/>
+        </p:nvSpPr>
+        <p:spPr>
+          <a:xfrm xmlns:a="http://schemas.openxmlformats.org/drawingml/2006/main">
+            <a:off x="742950" y="5276850"/>
+            <a:ext cx="9734550" cy="0"/>
+          </a:xfrm>
+          <a:prstGeom xmlns:a="http://schemas.openxmlformats.org/drawingml/2006/main" prst="line">
+            <a:avLst/>
+          </a:prstGeom>
+          <a:noFill xmlns:a="http://schemas.openxmlformats.org/drawingml/2006/main"/>
+          <a:ln xmlns:a="http://schemas.openxmlformats.org/drawingml/2006/main" w="19050">
+            <a:solidFill>
+              <a:srgbClr val="93A78D"/>
+            </a:solidFill>
+          </a:ln>
+        </p:spPr>
+      </p:sp>
+      <p:sp>
+        <p:nvSpPr>
+          <p:cNvPr id="15" name="">
+            <a:extLst xmlns:a="http://schemas.openxmlformats.org/drawingml/2006/main">
+              <a:ext uri="{FF2B5EF4-FFF2-40B4-BE49-F238E27FC236}">
+                <a16:creationId xmlns:a16="http://schemas.microsoft.com/office/drawing/2014/main" id="{F24DB107-FB5E-4979-98FA-709495C7B123}"/>
+              </a:ext>
+            </a:extLst>
+          </p:cNvPr>
+          <p:cNvSpPr>
+            <a:spLocks xmlns:a="http://schemas.openxmlformats.org/drawingml/2006/main" noGrp="1"/>
+          </p:cNvSpPr>
+          <p:nvPr/>
+        </p:nvSpPr>
+        <p:spPr>
+          <a:xfrm xmlns:a="http://schemas.openxmlformats.org/drawingml/2006/main">
+            <a:off x="695325" y="5229225"/>
+            <a:ext cx="95250" cy="95250"/>
+          </a:xfrm>
+          <a:prstGeom xmlns:a="http://schemas.openxmlformats.org/drawingml/2006/main" prst="ellipse">
+            <a:avLst/>
+          </a:prstGeom>
+          <a:solidFill xmlns:a="http://schemas.openxmlformats.org/drawingml/2006/main">
+            <a:srgbClr val="243E35"/>
+          </a:solidFill>
+          <a:ln xmlns:a="http://schemas.openxmlformats.org/drawingml/2006/main" w="0">
+            <a:noFill/>
+          </a:ln>
+        </p:spPr>
+      </p:sp>
+      <p:sp>
+        <p:nvSpPr>
+          <p:cNvPr id="16" name="">
+            <a:extLst xmlns:a="http://schemas.openxmlformats.org/drawingml/2006/main">
+              <a:ext uri="{FF2B5EF4-FFF2-40B4-BE49-F238E27FC236}">
+                <a16:creationId xmlns:a16="http://schemas.microsoft.com/office/drawing/2014/main" id="{18CFF7FF-0D9D-49EE-94A2-6050A6C0AB25}"/>
+              </a:ext>
+            </a:extLst>
+          </p:cNvPr>
+          <p:cNvSpPr>
+            <a:spLocks xmlns:a="http://schemas.openxmlformats.org/drawingml/2006/main" noGrp="1"/>
+          </p:cNvSpPr>
+          <p:nvPr/>
+        </p:nvSpPr>
+        <p:spPr>
+          <a:xfrm xmlns:a="http://schemas.openxmlformats.org/drawingml/2006/main">
+            <a:off x="4524375" y="5229225"/>
+            <a:ext cx="95250" cy="95250"/>
+          </a:xfrm>
+          <a:prstGeom xmlns:a="http://schemas.openxmlformats.org/drawingml/2006/main" prst="ellipse">
+            <a:avLst/>
+          </a:prstGeom>
+          <a:solidFill xmlns:a="http://schemas.openxmlformats.org/drawingml/2006/main">
+            <a:srgbClr val="243E35"/>
+          </a:solidFill>
+          <a:ln xmlns:a="http://schemas.openxmlformats.org/drawingml/2006/main" w="0">
+            <a:noFill/>
+          </a:ln>
+        </p:spPr>
+      </p:sp>
+      <p:sp>
+        <p:nvSpPr>
+          <p:cNvPr id="17" name="">
+            <a:extLst xmlns:a="http://schemas.openxmlformats.org/drawingml/2006/main">
+              <a:ext uri="{FF2B5EF4-FFF2-40B4-BE49-F238E27FC236}">
+                <a16:creationId xmlns:a16="http://schemas.microsoft.com/office/drawing/2014/main" id="{D4B55C44-09D1-493A-AC6F-C1C4EDCC9769}"/>
+              </a:ext>
+            </a:extLst>
+          </p:cNvPr>
+          <p:cNvSpPr>
+            <a:spLocks xmlns:a="http://schemas.openxmlformats.org/drawingml/2006/main" noGrp="1"/>
+          </p:cNvSpPr>
+          <p:nvPr/>
+        </p:nvSpPr>
+        <p:spPr>
+          <a:xfrm xmlns:a="http://schemas.openxmlformats.org/drawingml/2006/main">
+            <a:off x="10429875" y="5229225"/>
+            <a:ext cx="95250" cy="95250"/>
+          </a:xfrm>
+          <a:prstGeom xmlns:a="http://schemas.openxmlformats.org/drawingml/2006/main" prst="ellipse">
+            <a:avLst/>
+          </a:prstGeom>
+          <a:solidFill xmlns:a="http://schemas.openxmlformats.org/drawingml/2006/main">
+            <a:srgbClr val="243E35"/>
+          </a:solidFill>
+          <a:ln xmlns:a="http://schemas.openxmlformats.org/drawingml/2006/main" w="0">
+            <a:noFill/>
+          </a:ln>
+        </p:spPr>
+      </p:sp>
+      <p:sp>
+        <p:nvSpPr>
+          <p:cNvPr id="18" name="">
+            <a:extLst xmlns:a="http://schemas.openxmlformats.org/drawingml/2006/main">
+              <a:ext uri="{FF2B5EF4-FFF2-40B4-BE49-F238E27FC236}">
+                <a16:creationId xmlns:a16="http://schemas.microsoft.com/office/drawing/2014/main" id="{61F97F11-C551-4B81-A860-6531860D7BCB}"/>
+              </a:ext>
+            </a:extLst>
+          </p:cNvPr>
+          <p:cNvSpPr>
+            <a:spLocks xmlns:a="http://schemas.openxmlformats.org/drawingml/2006/main" noGrp="1"/>
+          </p:cNvSpPr>
+          <p:nvPr/>
+        </p:nvSpPr>
+        <p:spPr>
+          <a:xfrm xmlns:a="http://schemas.openxmlformats.org/drawingml/2006/main">
+            <a:off x="609600" y="5429250"/>
+            <a:ext cx="2571750" cy="266700"/>
+          </a:xfrm>
+          <a:prstGeom xmlns:a="http://schemas.openxmlformats.org/drawingml/2006/main" prst="rect">
+            <a:avLst/>
+          </a:prstGeom>
+          <a:noFill xmlns:a="http://schemas.openxmlformats.org/drawingml/2006/main"/>
+          <a:ln xmlns:a="http://schemas.openxmlformats.org/drawingml/2006/main" w="0">
+            <a:noFill/>
+          </a:ln>
+        </p:spPr>
+        <p:txBody>
+          <a:bodyPr xmlns:a="http://schemas.openxmlformats.org/drawingml/2006/main">
+            <a:noAutofit/>
+          </a:bodyPr>
+          <a:lstStyle xmlns:a="http://schemas.openxmlformats.org/drawingml/2006/main"/>
+          <a:p xmlns:a="http://schemas.openxmlformats.org/drawingml/2006/main">
+            <a:pPr>
+              <a:defRPr sz="1575" b="1">
+                <a:solidFill>
+                  <a:srgbClr val="243E35"/>
+                </a:solidFill>
+                <a:latin typeface="Helvetica Neue"/>
+                <a:ea typeface="Helvetica Neue"/>
+                <a:cs typeface="Helvetica Neue"/>
+              </a:defRPr>
+            </a:pPr>
+            <a:r>
+              <a:rPr sz="1575" b="1">
+                <a:solidFill>
+                  <a:srgbClr val="243E35"/>
+                </a:solidFill>
+                <a:latin typeface="Helvetica Neue"/>
+                <a:ea typeface="Helvetica Neue"/>
+                <a:cs typeface="Helvetica Neue"/>
+              </a:rPr>
+              <a:t>1  OCT 4</a:t>
+            </a:r>
+          </a:p>
+        </p:txBody>
+      </p:sp>
+      <p:sp>
+        <p:nvSpPr>
+          <p:cNvPr id="19" name="">
+            <a:extLst xmlns:a="http://schemas.openxmlformats.org/drawingml/2006/main">
+              <a:ext uri="{FF2B5EF4-FFF2-40B4-BE49-F238E27FC236}">
+                <a16:creationId xmlns:a16="http://schemas.microsoft.com/office/drawing/2014/main" id="{92CBEBCE-8EC0-4873-A26A-A7BD11509AF8}"/>
+              </a:ext>
+            </a:extLst>
+          </p:cNvPr>
+          <p:cNvSpPr>
+            <a:spLocks xmlns:a="http://schemas.openxmlformats.org/drawingml/2006/main" noGrp="1"/>
+          </p:cNvSpPr>
+          <p:nvPr/>
+        </p:nvSpPr>
+        <p:spPr>
+          <a:xfrm xmlns:a="http://schemas.openxmlformats.org/drawingml/2006/main">
+            <a:off x="609600" y="5810250"/>
+            <a:ext cx="2762250" cy="285750"/>
+          </a:xfrm>
+          <a:prstGeom xmlns:a="http://schemas.openxmlformats.org/drawingml/2006/main" prst="rect">
+            <a:avLst/>
+          </a:prstGeom>
+          <a:noFill xmlns:a="http://schemas.openxmlformats.org/drawingml/2006/main"/>
+          <a:ln xmlns:a="http://schemas.openxmlformats.org/drawingml/2006/main" w="0">
+            <a:noFill/>
+          </a:ln>
+        </p:spPr>
+        <p:txBody>
+          <a:bodyPr xmlns:a="http://schemas.openxmlformats.org/drawingml/2006/main">
+            <a:noAutofit/>
+          </a:bodyPr>
+          <a:lstStyle xmlns:a="http://schemas.openxmlformats.org/drawingml/2006/main"/>
+          <a:p xmlns:a="http://schemas.openxmlformats.org/drawingml/2006/main">
+            <a:pPr>
+              <a:defRPr sz="1575" b="0">
+                <a:solidFill>
+                  <a:srgbClr val="243E35"/>
+                </a:solidFill>
+                <a:latin typeface="Helvetica Neue"/>
+                <a:ea typeface="Helvetica Neue"/>
+                <a:cs typeface="Helvetica Neue"/>
+              </a:defRPr>
+            </a:pPr>
+            <a:r>
+              <a:rPr sz="1575" b="0">
+                <a:solidFill>
+                  <a:srgbClr val="243E35"/>
+                </a:solidFill>
+                <a:latin typeface="Helvetica Neue"/>
+                <a:ea typeface="Helvetica Neue"/>
+                <a:cs typeface="Helvetica Neue"/>
+              </a:rPr>
+              <a:t>Prepare the checklist</a:t>
+            </a:r>
+          </a:p>
+        </p:txBody>
+      </p:sp>
+      <p:sp>
+        <p:nvSpPr>
+          <p:cNvPr id="20" name="">
+            <a:extLst xmlns:a="http://schemas.openxmlformats.org/drawingml/2006/main">
+              <a:ext uri="{FF2B5EF4-FFF2-40B4-BE49-F238E27FC236}">
+                <a16:creationId xmlns:a16="http://schemas.microsoft.com/office/drawing/2014/main" id="{09B02EB1-B726-4B85-84FA-3D5E5DA1004C}"/>
+              </a:ext>
+            </a:extLst>
+          </p:cNvPr>
+          <p:cNvSpPr>
+            <a:spLocks xmlns:a="http://schemas.openxmlformats.org/drawingml/2006/main" noGrp="1"/>
+          </p:cNvSpPr>
+          <p:nvPr/>
+        </p:nvSpPr>
+        <p:spPr>
+          <a:xfrm xmlns:a="http://schemas.openxmlformats.org/drawingml/2006/main">
+            <a:off x="4381500" y="5429250"/>
+            <a:ext cx="2857500" cy="266700"/>
+          </a:xfrm>
+          <a:prstGeom xmlns:a="http://schemas.openxmlformats.org/drawingml/2006/main" prst="rect">
+            <a:avLst/>
+          </a:prstGeom>
+          <a:noFill xmlns:a="http://schemas.openxmlformats.org/drawingml/2006/main"/>
+          <a:ln xmlns:a="http://schemas.openxmlformats.org/drawingml/2006/main" w="0">
+            <a:noFill/>
+          </a:ln>
+        </p:spPr>
+        <p:txBody>
+          <a:bodyPr xmlns:a="http://schemas.openxmlformats.org/drawingml/2006/main">
+            <a:noAutofit/>
+          </a:bodyPr>
+          <a:lstStyle xmlns:a="http://schemas.openxmlformats.org/drawingml/2006/main"/>
+          <a:p xmlns:a="http://schemas.openxmlformats.org/drawingml/2006/main">
+            <a:pPr>
+              <a:defRPr sz="1575" b="1">
+                <a:solidFill>
+                  <a:srgbClr val="243E35"/>
+                </a:solidFill>
+                <a:latin typeface="Helvetica Neue"/>
+                <a:ea typeface="Helvetica Neue"/>
+                <a:cs typeface="Helvetica Neue"/>
+              </a:defRPr>
+            </a:pPr>
+            <a:r>
+              <a:rPr sz="1575" b="1">
+                <a:solidFill>
+                  <a:srgbClr val="243E35"/>
+                </a:solidFill>
+                <a:latin typeface="Helvetica Neue"/>
+                <a:ea typeface="Helvetica Neue"/>
+                <a:cs typeface="Helvetica Neue"/>
+              </a:rPr>
+              <a:t>2  OCT 18</a:t>
+            </a:r>
+          </a:p>
+        </p:txBody>
+      </p:sp>
+      <p:sp>
+        <p:nvSpPr>
+          <p:cNvPr id="21" name="">
+            <a:extLst xmlns:a="http://schemas.openxmlformats.org/drawingml/2006/main">
+              <a:ext uri="{FF2B5EF4-FFF2-40B4-BE49-F238E27FC236}">
+                <a16:creationId xmlns:a16="http://schemas.microsoft.com/office/drawing/2014/main" id="{01A3A245-E72A-4C54-BD0F-7738C1B0DBDB}"/>
+              </a:ext>
+            </a:extLst>
+          </p:cNvPr>
+          <p:cNvSpPr>
+            <a:spLocks xmlns:a="http://schemas.openxmlformats.org/drawingml/2006/main" noGrp="1"/>
+          </p:cNvSpPr>
+          <p:nvPr/>
+        </p:nvSpPr>
+        <p:spPr>
+          <a:xfrm xmlns:a="http://schemas.openxmlformats.org/drawingml/2006/main">
+            <a:off x="4381500" y="5810250"/>
+            <a:ext cx="3143250" cy="523875"/>
+          </a:xfrm>
+          <a:prstGeom xmlns:a="http://schemas.openxmlformats.org/drawingml/2006/main" prst="rect">
+            <a:avLst/>
+          </a:prstGeom>
+          <a:noFill xmlns:a="http://schemas.openxmlformats.org/drawingml/2006/main"/>
+          <a:ln xmlns:a="http://schemas.openxmlformats.org/drawingml/2006/main" w="0">
+            <a:noFill/>
+          </a:ln>
+        </p:spPr>
+        <p:txBody>
+          <a:bodyPr xmlns:a="http://schemas.openxmlformats.org/drawingml/2006/main">
+            <a:noAutofit/>
+          </a:bodyPr>
+          <a:lstStyle xmlns:a="http://schemas.openxmlformats.org/drawingml/2006/main"/>
+          <a:p xmlns:a="http://schemas.openxmlformats.org/drawingml/2006/main">
+            <a:pPr>
+              <a:defRPr sz="1575" b="0">
+                <a:solidFill>
+                  <a:srgbClr val="243E35"/>
+                </a:solidFill>
+                <a:latin typeface="Helvetica Neue"/>
+                <a:ea typeface="Helvetica Neue"/>
+                <a:cs typeface="Helvetica Neue"/>
+              </a:defRPr>
+            </a:pPr>
+            <a:r>
+              <a:rPr sz="1575" b="0">
+                <a:solidFill>
+                  <a:srgbClr val="243E35"/>
+                </a:solidFill>
+                <a:latin typeface="Helvetica Neue"/>
+                <a:ea typeface="Helvetica Neue"/>
+                <a:cs typeface="Helvetica Neue"/>
+              </a:rPr>
+              <a:t>Start the two-week trial</a:t>
+            </a:r>
+          </a:p>
+          <a:p xmlns:a="http://schemas.openxmlformats.org/drawingml/2006/main">
+            <a:pPr>
+              <a:defRPr sz="1575" b="0">
+                <a:solidFill>
+                  <a:srgbClr val="243E35"/>
+                </a:solidFill>
+                <a:latin typeface="Helvetica Neue"/>
+                <a:ea typeface="Helvetica Neue"/>
+                <a:cs typeface="Helvetica Neue"/>
+              </a:defRPr>
+            </a:pPr>
+            <a:r>
+              <a:rPr sz="1575" b="0">
+                <a:solidFill>
+                  <a:srgbClr val="243E35"/>
+                </a:solidFill>
+                <a:latin typeface="Helvetica Neue"/>
+                <a:ea typeface="Helvetica Neue"/>
+                <a:cs typeface="Helvetica Neue"/>
+              </a:rPr>
+              <a:t>1 opening at a time</a:t>
+            </a:r>
+          </a:p>
+        </p:txBody>
+      </p:sp>
+      <p:sp>
+        <p:nvSpPr>
+          <p:cNvPr id="22" name="">
+            <a:extLst xmlns:a="http://schemas.openxmlformats.org/drawingml/2006/main">
+              <a:ext uri="{FF2B5EF4-FFF2-40B4-BE49-F238E27FC236}">
+                <a16:creationId xmlns:a16="http://schemas.microsoft.com/office/drawing/2014/main" id="{8C2F575C-CFB9-4301-A20B-6DAD567D1EF8}"/>
+              </a:ext>
+            </a:extLst>
+          </p:cNvPr>
+          <p:cNvSpPr>
+            <a:spLocks xmlns:a="http://schemas.openxmlformats.org/drawingml/2006/main" noGrp="1"/>
+          </p:cNvSpPr>
+          <p:nvPr/>
+        </p:nvSpPr>
+        <p:spPr>
+          <a:xfrm xmlns:a="http://schemas.openxmlformats.org/drawingml/2006/main">
+            <a:off x="8763000" y="5429250"/>
+            <a:ext cx="2667000" cy="266700"/>
+          </a:xfrm>
+          <a:prstGeom xmlns:a="http://schemas.openxmlformats.org/drawingml/2006/main" prst="rect">
+            <a:avLst/>
+          </a:prstGeom>
+          <a:noFill xmlns:a="http://schemas.openxmlformats.org/drawingml/2006/main"/>
+          <a:ln xmlns:a="http://schemas.openxmlformats.org/drawingml/2006/main" w="0">
+            <a:noFill/>
+          </a:ln>
+        </p:spPr>
+        <p:txBody>
+          <a:bodyPr xmlns:a="http://schemas.openxmlformats.org/drawingml/2006/main">
+            <a:noAutofit/>
+          </a:bodyPr>
+          <a:lstStyle xmlns:a="http://schemas.openxmlformats.org/drawingml/2006/main"/>
+          <a:p xmlns:a="http://schemas.openxmlformats.org/drawingml/2006/main">
+            <a:pPr>
+              <a:defRPr sz="1575" b="1">
+                <a:solidFill>
+                  <a:srgbClr val="243E35"/>
+                </a:solidFill>
+                <a:latin typeface="Helvetica Neue"/>
+                <a:ea typeface="Helvetica Neue"/>
+                <a:cs typeface="Helvetica Neue"/>
+              </a:defRPr>
+            </a:pPr>
+            <a:r>
+              <a:rPr sz="1575" b="1">
+                <a:solidFill>
+                  <a:srgbClr val="243E35"/>
+                </a:solidFill>
+                <a:latin typeface="Helvetica Neue"/>
+                <a:ea typeface="Helvetica Neue"/>
+                <a:cs typeface="Helvetica Neue"/>
+              </a:rPr>
+              <a:t>3  NOV 1</a:t>
+            </a:r>
+          </a:p>
+        </p:txBody>
+      </p:sp>
+      <p:sp>
+        <p:nvSpPr>
+          <p:cNvPr id="23" name="">
+            <a:extLst xmlns:a="http://schemas.openxmlformats.org/drawingml/2006/main">
+              <a:ext uri="{FF2B5EF4-FFF2-40B4-BE49-F238E27FC236}">
+                <a16:creationId xmlns:a16="http://schemas.microsoft.com/office/drawing/2014/main" id="{944EBBE7-24BA-4519-8ED7-A8F872AB5899}"/>
+              </a:ext>
+            </a:extLst>
+          </p:cNvPr>
+          <p:cNvSpPr>
+            <a:spLocks xmlns:a="http://schemas.openxmlformats.org/drawingml/2006/main" noGrp="1"/>
+          </p:cNvSpPr>
+          <p:nvPr/>
+        </p:nvSpPr>
+        <p:spPr>
+          <a:xfrm xmlns:a="http://schemas.openxmlformats.org/drawingml/2006/main">
+            <a:off x="8763000" y="5810250"/>
+            <a:ext cx="2857500" cy="504825"/>
+          </a:xfrm>
+          <a:prstGeom xmlns:a="http://schemas.openxmlformats.org/drawingml/2006/main" prst="rect">
+            <a:avLst/>
+          </a:prstGeom>
+          <a:noFill xmlns:a="http://schemas.openxmlformats.org/drawingml/2006/main"/>
+          <a:ln xmlns:a="http://schemas.openxmlformats.org/drawingml/2006/main" w="0">
+            <a:noFill/>
+          </a:ln>
+        </p:spPr>
+        <p:txBody>
+          <a:bodyPr xmlns:a="http://schemas.openxmlformats.org/drawingml/2006/main">
+            <a:noAutofit/>
+          </a:bodyPr>
+          <a:lstStyle xmlns:a="http://schemas.openxmlformats.org/drawingml/2006/main"/>
+          <a:p xmlns:a="http://schemas.openxmlformats.org/drawingml/2006/main">
+            <a:pPr>
+              <a:defRPr sz="1575" b="0">
+                <a:solidFill>
+                  <a:srgbClr val="243E35"/>
+                </a:solidFill>
+                <a:latin typeface="Helvetica Neue"/>
+                <a:ea typeface="Helvetica Neue"/>
+                <a:cs typeface="Helvetica Neue"/>
+              </a:defRPr>
+            </a:pPr>
+            <a:r>
+              <a:rPr sz="1575" b="0">
+                <a:solidFill>
+                  <a:srgbClr val="243E35"/>
+                </a:solidFill>
+                <a:latin typeface="Helvetica Neue"/>
+                <a:ea typeface="Helvetica Neue"/>
+                <a:cs typeface="Helvetica Neue"/>
+              </a:rPr>
+              <a:t>Review refills and</a:t>
+            </a:r>
+          </a:p>
+          <a:p xmlns:a="http://schemas.openxmlformats.org/drawingml/2006/main">
+            <a:pPr>
+              <a:defRPr sz="1575" b="0">
+                <a:solidFill>
+                  <a:srgbClr val="243E35"/>
+                </a:solidFill>
+                <a:latin typeface="Helvetica Neue"/>
+                <a:ea typeface="Helvetica Neue"/>
+                <a:cs typeface="Helvetica Neue"/>
+              </a:defRPr>
+            </a:pPr>
+            <a:r>
+              <a:rPr sz="1575" b="0">
+                <a:solidFill>
+                  <a:srgbClr val="243E35"/>
+                </a:solidFill>
+                <a:latin typeface="Helvetica Neue"/>
+                <a:ea typeface="Helvetica Neue"/>
+                <a:cs typeface="Helvetica Neue"/>
+              </a:rPr>
+              <a:t>staff follow-ups</a:t>
+            </a:r>
+          </a:p>
+        </p:txBody>
+      </p:sp>
+      <p:sp>
+        <p:nvSpPr>
+          <p:cNvPr id="24" name="">
+            <a:extLst xmlns:a="http://schemas.openxmlformats.org/drawingml/2006/main">
+              <a:ext uri="{FF2B5EF4-FFF2-40B4-BE49-F238E27FC236}">
+                <a16:creationId xmlns:a16="http://schemas.microsoft.com/office/drawing/2014/main" id="{0EDC6629-7978-484A-ABA0-2496C86F0BBD}"/>
+              </a:ext>
+            </a:extLst>
+          </p:cNvPr>
+          <p:cNvSpPr>
+            <a:spLocks xmlns:a="http://schemas.openxmlformats.org/drawingml/2006/main" noGrp="1"/>
+          </p:cNvSpPr>
+          <p:nvPr/>
+        </p:nvSpPr>
+        <p:spPr>
+          <a:xfrm xmlns:a="http://schemas.openxmlformats.org/drawingml/2006/main">
+            <a:off x="609600" y="6381750"/>
+            <a:ext cx="10001250" cy="266700"/>
+          </a:xfrm>
+          <a:prstGeom xmlns:a="http://schemas.openxmlformats.org/drawingml/2006/main" prst="rect">
+            <a:avLst/>
+          </a:prstGeom>
+          <a:noFill xmlns:a="http://schemas.openxmlformats.org/drawingml/2006/main"/>
+          <a:ln xmlns:a="http://schemas.openxmlformats.org/drawingml/2006/main" w="0">
+            <a:noFill/>
+          </a:ln>
+        </p:spPr>
+        <p:txBody>
+          <a:bodyPr xmlns:a="http://schemas.openxmlformats.org/drawingml/2006/main">
+            <a:noAutofit/>
+          </a:bodyPr>
+          <a:lstStyle xmlns:a="http://schemas.openxmlformats.org/drawingml/2006/main"/>
+          <a:p xmlns:a="http://schemas.openxmlformats.org/drawingml/2006/main">
+            <a:pPr>
+              <a:defRPr sz="1200" b="0">
+                <a:solidFill>
+                  <a:srgbClr val="617166"/>
+                </a:solidFill>
+                <a:latin typeface="Helvetica Neue"/>
+                <a:ea typeface="Helvetica Neue"/>
+                <a:cs typeface="Helvetica Neue"/>
+              </a:defRPr>
+            </a:pPr>
+            <a:r>
+              <a:rPr sz="1200" b="0">
+                <a:solidFill>
+                  <a:srgbClr val="617166"/>
+                </a:solidFill>
+                <a:latin typeface="Helvetica Neue"/>
+                <a:ea typeface="Helvetica Neue"/>
+                <a:cs typeface="Helvetica Neue"/>
+              </a:rPr>
+              <a:t>Example dates, not a commitment. Start only after setup and testing. Targets are not results.</a:t>
             </a:r>
           </a:p>
         </p:txBody>
@@ -4268,7 +4924,7 @@
     </p:spTree>
     <p:extLst>
       <p:ext uri="{BB962C8B-B14F-4D97-AF65-F5344CB8AC3E}">
-        <p14:creationId xmlns:p14="http://schemas.microsoft.com/office/powerpoint/2010/main" val="2070891760"/>
+        <p14:creationId xmlns:p14="http://schemas.microsoft.com/office/powerpoint/2010/main" val="187540573"/>
       </p:ext>
     </p:extLst>
   </p:cSld>

</xml_diff>

<commit_message>
Guide salon staff through offers and add searchable client contact profiles
</commit_message>
<xml_diff>
--- a/presentation/juniper-salon.pptx
+++ b/presentation/juniper-salon.pptx
@@ -2,16 +2,16 @@
 <file path=ppt/presentation.xml><?xml version="1.0" encoding="utf-8"?>
 <p:presentation xmlns:p="http://schemas.openxmlformats.org/presentationml/2006/main">
   <p:sldMasterIdLst>
-    <p:sldMasterId xmlns:r="http://schemas.openxmlformats.org/officeDocument/2006/relationships" id="2147483648" r:id="R9a6615819391494b"/>
+    <p:sldMasterId xmlns:r="http://schemas.openxmlformats.org/officeDocument/2006/relationships" id="2147483648" r:id="Rdf53a0993b964adf"/>
   </p:sldMasterIdLst>
   <p:notesMasterIdLst>
-    <p:notesMasterId xmlns:r="http://schemas.openxmlformats.org/officeDocument/2006/relationships" r:id="Raa0e2d66774d4afb"/>
+    <p:notesMasterId xmlns:r="http://schemas.openxmlformats.org/officeDocument/2006/relationships" r:id="R92403e7fd00943f0"/>
   </p:notesMasterIdLst>
   <p:sldIdLst>
-    <p:sldId xmlns:r="http://schemas.openxmlformats.org/officeDocument/2006/relationships" id="256" r:id="Rcf8c569c6eb74c0f"/>
-    <p:sldId xmlns:r="http://schemas.openxmlformats.org/officeDocument/2006/relationships" id="257" r:id="Rc49d2d771abb4b7b"/>
-    <p:sldId xmlns:r="http://schemas.openxmlformats.org/officeDocument/2006/relationships" id="258" r:id="Rfda8c2bc8eec4f68"/>
-    <p:sldId xmlns:r="http://schemas.openxmlformats.org/officeDocument/2006/relationships" id="259" r:id="R07cbcfb1994b4e87"/>
+    <p:sldId xmlns:r="http://schemas.openxmlformats.org/officeDocument/2006/relationships" id="256" r:id="R09c755f11bc147fc"/>
+    <p:sldId xmlns:r="http://schemas.openxmlformats.org/officeDocument/2006/relationships" id="257" r:id="Reb6a6780adf04ba5"/>
+    <p:sldId xmlns:r="http://schemas.openxmlformats.org/officeDocument/2006/relationships" id="258" r:id="Rcf4df51bc78244ba"/>
+    <p:sldId xmlns:r="http://schemas.openxmlformats.org/officeDocument/2006/relationships" id="259" r:id="Rb002f693c429431e"/>
   </p:sldIdLst>
   <p:sldSz cx="12192000" cy="6858000"/>
   <p:notesSz cx="6858000" cy="9144000"/>
@@ -723,7 +723,7 @@
   </p:cSld>
   <p:clrMap bg1="lt1" tx1="dk1" bg2="lt2" tx2="dk2" accent1="accent1" accent2="accent2" accent3="accent3" accent4="accent4" accent5="accent5" accent6="accent6" hlink="hlink" folHlink="folHlink"/>
   <p:sldLayoutIdLst>
-    <p:sldLayoutId xmlns:r="http://schemas.openxmlformats.org/officeDocument/2006/relationships" id="2147483649" r:id="R3aa5e60be52c47a7"/>
+    <p:sldLayoutId xmlns:r="http://schemas.openxmlformats.org/officeDocument/2006/relationships" id="2147483649" r:id="R315cb1e0033f45c8"/>
   </p:sldLayoutIdLst>
   <p:txStyles>
     <p:titleStyle>
@@ -1274,7 +1274,7 @@
           <p:cNvPr id="12" name="">
             <a:extLst xmlns:a="http://schemas.openxmlformats.org/drawingml/2006/main">
               <a:ext uri="{FF2B5EF4-FFF2-40B4-BE49-F238E27FC236}">
-                <a16:creationId xmlns:a16="http://schemas.microsoft.com/office/drawing/2014/main" id="{3448D9F0-E679-4E03-B305-0AE980F07FEF}"/>
+                <a16:creationId xmlns:a16="http://schemas.microsoft.com/office/drawing/2014/main" id="{C3C286E3-4D41-4E40-8D1E-FD8351C31A8F}"/>
               </a:ext>
             </a:extLst>
           </p:cNvPr>
@@ -1331,7 +1331,7 @@
           <p:cNvPr id="2" name="">
             <a:extLst xmlns:a="http://schemas.openxmlformats.org/drawingml/2006/main">
               <a:ext uri="{FF2B5EF4-FFF2-40B4-BE49-F238E27FC236}">
-                <a16:creationId xmlns:a16="http://schemas.microsoft.com/office/drawing/2014/main" id="{A04B0700-AE97-48E9-9959-44C9DA4B76A9}"/>
+                <a16:creationId xmlns:a16="http://schemas.microsoft.com/office/drawing/2014/main" id="{ACEC5786-EF65-4123-9B3C-6CF9DC413586}"/>
               </a:ext>
             </a:extLst>
           </p:cNvPr>
@@ -1411,7 +1411,7 @@
           <p:cNvPr id="3" name="">
             <a:extLst xmlns:a="http://schemas.openxmlformats.org/drawingml/2006/main">
               <a:ext uri="{FF2B5EF4-FFF2-40B4-BE49-F238E27FC236}">
-                <a16:creationId xmlns:a16="http://schemas.microsoft.com/office/drawing/2014/main" id="{30662F14-F0B4-4A0E-96A1-095BC5DBFFF9}"/>
+                <a16:creationId xmlns:a16="http://schemas.microsoft.com/office/drawing/2014/main" id="{09C6B261-4EA6-428D-A955-A7E872C9F2C2}"/>
               </a:ext>
             </a:extLst>
           </p:cNvPr>
@@ -1468,7 +1468,7 @@
           <p:cNvPr id="4" name="">
             <a:extLst xmlns:a="http://schemas.openxmlformats.org/drawingml/2006/main">
               <a:ext uri="{FF2B5EF4-FFF2-40B4-BE49-F238E27FC236}">
-                <a16:creationId xmlns:a16="http://schemas.microsoft.com/office/drawing/2014/main" id="{61DD2F07-F226-414A-A2CA-CFC9B71D54C0}"/>
+                <a16:creationId xmlns:a16="http://schemas.microsoft.com/office/drawing/2014/main" id="{46EE7A9F-0870-45EC-AD8F-C6686ED3D164}"/>
               </a:ext>
             </a:extLst>
           </p:cNvPr>
@@ -1548,7 +1548,7 @@
           <p:cNvPr id="5" name="">
             <a:extLst xmlns:a="http://schemas.openxmlformats.org/drawingml/2006/main">
               <a:ext uri="{FF2B5EF4-FFF2-40B4-BE49-F238E27FC236}">
-                <a16:creationId xmlns:a16="http://schemas.microsoft.com/office/drawing/2014/main" id="{A92A4B60-F941-4D51-A171-8384634B5E15}"/>
+                <a16:creationId xmlns:a16="http://schemas.microsoft.com/office/drawing/2014/main" id="{F6853599-60E8-4374-AE85-399FBFF37230}"/>
               </a:ext>
             </a:extLst>
           </p:cNvPr>
@@ -1605,7 +1605,7 @@
           <p:cNvPr id="6" name="">
             <a:extLst xmlns:a="http://schemas.openxmlformats.org/drawingml/2006/main">
               <a:ext uri="{FF2B5EF4-FFF2-40B4-BE49-F238E27FC236}">
-                <a16:creationId xmlns:a16="http://schemas.microsoft.com/office/drawing/2014/main" id="{BB222718-FBB6-421E-A8CE-47255332841C}"/>
+                <a16:creationId xmlns:a16="http://schemas.microsoft.com/office/drawing/2014/main" id="{850E78C9-99AC-47CB-9491-EC46D2C30813}"/>
               </a:ext>
             </a:extLst>
           </p:cNvPr>
@@ -1662,7 +1662,7 @@
           <p:cNvPr id="7" name="">
             <a:extLst xmlns:a="http://schemas.openxmlformats.org/drawingml/2006/main">
               <a:ext uri="{FF2B5EF4-FFF2-40B4-BE49-F238E27FC236}">
-                <a16:creationId xmlns:a16="http://schemas.microsoft.com/office/drawing/2014/main" id="{B0A60463-D536-4F01-A9E4-32F15D23A5DC}"/>
+                <a16:creationId xmlns:a16="http://schemas.microsoft.com/office/drawing/2014/main" id="{486A182B-3C61-4097-8331-AD33741B8B97}"/>
               </a:ext>
             </a:extLst>
           </p:cNvPr>
@@ -1719,7 +1719,7 @@
           <p:cNvPr id="8" name="">
             <a:extLst xmlns:a="http://schemas.openxmlformats.org/drawingml/2006/main">
               <a:ext uri="{FF2B5EF4-FFF2-40B4-BE49-F238E27FC236}">
-                <a16:creationId xmlns:a16="http://schemas.microsoft.com/office/drawing/2014/main" id="{E952921F-4569-4953-B26E-11DB8F7DDF90}"/>
+                <a16:creationId xmlns:a16="http://schemas.microsoft.com/office/drawing/2014/main" id="{5AE33054-982B-4B8D-B02D-5F0436B766D9}"/>
               </a:ext>
             </a:extLst>
           </p:cNvPr>
@@ -1776,7 +1776,7 @@
           <p:cNvPr id="9" name="">
             <a:extLst xmlns:a="http://schemas.openxmlformats.org/drawingml/2006/main">
               <a:ext uri="{FF2B5EF4-FFF2-40B4-BE49-F238E27FC236}">
-                <a16:creationId xmlns:a16="http://schemas.microsoft.com/office/drawing/2014/main" id="{85AA7D18-05E8-4F62-9120-78147475436F}"/>
+                <a16:creationId xmlns:a16="http://schemas.microsoft.com/office/drawing/2014/main" id="{B6D0842B-F5F2-4DC5-B986-261A0171A151}"/>
               </a:ext>
             </a:extLst>
           </p:cNvPr>
@@ -1833,7 +1833,7 @@
           <p:cNvPr id="10" name="">
             <a:extLst xmlns:a="http://schemas.openxmlformats.org/drawingml/2006/main">
               <a:ext uri="{FF2B5EF4-FFF2-40B4-BE49-F238E27FC236}">
-                <a16:creationId xmlns:a16="http://schemas.microsoft.com/office/drawing/2014/main" id="{CDF0E997-95FC-40B5-B3D4-5AACCC62CA13}"/>
+                <a16:creationId xmlns:a16="http://schemas.microsoft.com/office/drawing/2014/main" id="{31E32CD8-1B79-48C5-9135-A7B382E869EE}"/>
               </a:ext>
             </a:extLst>
           </p:cNvPr>
@@ -1890,7 +1890,7 @@
           <p:cNvPr id="11" name="">
             <a:extLst xmlns:a="http://schemas.openxmlformats.org/drawingml/2006/main">
               <a:ext uri="{FF2B5EF4-FFF2-40B4-BE49-F238E27FC236}">
-                <a16:creationId xmlns:a16="http://schemas.microsoft.com/office/drawing/2014/main" id="{FB336A34-2C02-4826-9373-CC721F338004}"/>
+                <a16:creationId xmlns:a16="http://schemas.microsoft.com/office/drawing/2014/main" id="{03F02048-ABA3-4C19-ADD9-1E37377EAEC5}"/>
               </a:ext>
             </a:extLst>
           </p:cNvPr>
@@ -1945,7 +1945,7 @@
     </p:spTree>
     <p:extLst>
       <p:ext uri="{BB962C8B-B14F-4D97-AF65-F5344CB8AC3E}">
-        <p14:creationId xmlns:p14="http://schemas.microsoft.com/office/powerpoint/2010/main" val="949768049"/>
+        <p14:creationId xmlns:p14="http://schemas.microsoft.com/office/powerpoint/2010/main" val="944568946"/>
       </p:ext>
     </p:extLst>
   </p:cSld>
@@ -1976,7 +1976,7 @@
           <p:cNvPr id="12" name="">
             <a:extLst xmlns:a="http://schemas.openxmlformats.org/drawingml/2006/main">
               <a:ext uri="{FF2B5EF4-FFF2-40B4-BE49-F238E27FC236}">
-                <a16:creationId xmlns:a16="http://schemas.microsoft.com/office/drawing/2014/main" id="{7D38ED2B-410F-49E4-B95B-BBDE6A51EB5C}"/>
+                <a16:creationId xmlns:a16="http://schemas.microsoft.com/office/drawing/2014/main" id="{836DFB49-7848-49E3-8E77-DC4B03AB0240}"/>
               </a:ext>
             </a:extLst>
           </p:cNvPr>
@@ -2033,7 +2033,7 @@
           <p:cNvPr id="2" name="">
             <a:extLst xmlns:a="http://schemas.openxmlformats.org/drawingml/2006/main">
               <a:ext uri="{FF2B5EF4-FFF2-40B4-BE49-F238E27FC236}">
-                <a16:creationId xmlns:a16="http://schemas.microsoft.com/office/drawing/2014/main" id="{795976B4-4352-49EB-BE39-7D29685A4F29}"/>
+                <a16:creationId xmlns:a16="http://schemas.microsoft.com/office/drawing/2014/main" id="{9A7FFC7B-2155-47D2-BC4F-E7CA32C08EDE}"/>
               </a:ext>
             </a:extLst>
           </p:cNvPr>
@@ -2090,7 +2090,7 @@
           <p:cNvPr id="3" name="">
             <a:extLst xmlns:a="http://schemas.openxmlformats.org/drawingml/2006/main">
               <a:ext uri="{FF2B5EF4-FFF2-40B4-BE49-F238E27FC236}">
-                <a16:creationId xmlns:a16="http://schemas.microsoft.com/office/drawing/2014/main" id="{6340D9C3-2977-4A73-BAD4-AD12CB510742}"/>
+                <a16:creationId xmlns:a16="http://schemas.microsoft.com/office/drawing/2014/main" id="{DC2DBB09-7438-4D98-A374-9C0B1393338A}"/>
               </a:ext>
             </a:extLst>
           </p:cNvPr>
@@ -2147,7 +2147,7 @@
           <p:cNvPr id="4" name="">
             <a:extLst xmlns:a="http://schemas.openxmlformats.org/drawingml/2006/main">
               <a:ext uri="{FF2B5EF4-FFF2-40B4-BE49-F238E27FC236}">
-                <a16:creationId xmlns:a16="http://schemas.microsoft.com/office/drawing/2014/main" id="{B3069AF4-5175-406B-A002-8B665E827053}"/>
+                <a16:creationId xmlns:a16="http://schemas.microsoft.com/office/drawing/2014/main" id="{5CD0EF14-F0BD-4EF3-87E7-535ABF49832D}"/>
               </a:ext>
             </a:extLst>
           </p:cNvPr>
@@ -2204,7 +2204,7 @@
           <p:cNvPr id="5" name="">
             <a:extLst xmlns:a="http://schemas.openxmlformats.org/drawingml/2006/main">
               <a:ext uri="{FF2B5EF4-FFF2-40B4-BE49-F238E27FC236}">
-                <a16:creationId xmlns:a16="http://schemas.microsoft.com/office/drawing/2014/main" id="{B53DA1F9-E489-4F93-8CF4-88C504E8BF11}"/>
+                <a16:creationId xmlns:a16="http://schemas.microsoft.com/office/drawing/2014/main" id="{9B7411EB-C93C-4C12-ABBA-9A6902CE0520}"/>
               </a:ext>
             </a:extLst>
           </p:cNvPr>
@@ -2261,7 +2261,7 @@
           <p:cNvPr id="6" name="">
             <a:extLst xmlns:a="http://schemas.openxmlformats.org/drawingml/2006/main">
               <a:ext uri="{FF2B5EF4-FFF2-40B4-BE49-F238E27FC236}">
-                <a16:creationId xmlns:a16="http://schemas.microsoft.com/office/drawing/2014/main" id="{052CB5D9-5CE8-43CF-A42F-502E68DF00C3}"/>
+                <a16:creationId xmlns:a16="http://schemas.microsoft.com/office/drawing/2014/main" id="{98B971E1-733B-41BF-A73A-770044384AAA}"/>
               </a:ext>
             </a:extLst>
           </p:cNvPr>
@@ -2341,7 +2341,7 @@
           <p:cNvPr id="7" name="">
             <a:extLst xmlns:a="http://schemas.openxmlformats.org/drawingml/2006/main">
               <a:ext uri="{FF2B5EF4-FFF2-40B4-BE49-F238E27FC236}">
-                <a16:creationId xmlns:a16="http://schemas.microsoft.com/office/drawing/2014/main" id="{5017F93D-5187-4886-9CFE-63F1A19F59AD}"/>
+                <a16:creationId xmlns:a16="http://schemas.microsoft.com/office/drawing/2014/main" id="{AC116BD7-BE58-4AD5-9424-EF66D9EDA117}"/>
               </a:ext>
             </a:extLst>
           </p:cNvPr>
@@ -2398,7 +2398,7 @@
           <p:cNvPr id="8" name="">
             <a:extLst xmlns:a="http://schemas.openxmlformats.org/drawingml/2006/main">
               <a:ext uri="{FF2B5EF4-FFF2-40B4-BE49-F238E27FC236}">
-                <a16:creationId xmlns:a16="http://schemas.microsoft.com/office/drawing/2014/main" id="{2BFFA573-1B6A-428A-8FD7-F4C0BD1D3371}"/>
+                <a16:creationId xmlns:a16="http://schemas.microsoft.com/office/drawing/2014/main" id="{941A51DC-13C8-48B2-B0A2-D8893589514D}"/>
               </a:ext>
             </a:extLst>
           </p:cNvPr>
@@ -2478,7 +2478,7 @@
           <p:cNvPr id="9" name="">
             <a:extLst xmlns:a="http://schemas.openxmlformats.org/drawingml/2006/main">
               <a:ext uri="{FF2B5EF4-FFF2-40B4-BE49-F238E27FC236}">
-                <a16:creationId xmlns:a16="http://schemas.microsoft.com/office/drawing/2014/main" id="{9A2D9F47-259E-41BB-B010-CC533BA30524}"/>
+                <a16:creationId xmlns:a16="http://schemas.microsoft.com/office/drawing/2014/main" id="{7914CA0D-3601-4F1E-BFC1-DA1F0F4F3281}"/>
               </a:ext>
             </a:extLst>
           </p:cNvPr>
@@ -2535,7 +2535,7 @@
           <p:cNvPr id="10" name="">
             <a:extLst xmlns:a="http://schemas.openxmlformats.org/drawingml/2006/main">
               <a:ext uri="{FF2B5EF4-FFF2-40B4-BE49-F238E27FC236}">
-                <a16:creationId xmlns:a16="http://schemas.microsoft.com/office/drawing/2014/main" id="{53B994CA-814F-4E69-AA57-5330A76F469E}"/>
+                <a16:creationId xmlns:a16="http://schemas.microsoft.com/office/drawing/2014/main" id="{60F81633-6978-4FF9-99C8-47A443DA86B6}"/>
               </a:ext>
             </a:extLst>
           </p:cNvPr>
@@ -2596,13 +2596,13 @@
           <p:nvPr/>
         </p:nvPicPr>
         <p:blipFill>
-          <a:blip xmlns:r="http://schemas.openxmlformats.org/officeDocument/2006/relationships" xmlns:a="http://schemas.openxmlformats.org/drawingml/2006/main" r:embed="Rd42b87c8051b4193"/>
+          <a:blip xmlns:r="http://schemas.openxmlformats.org/officeDocument/2006/relationships" xmlns:a="http://schemas.openxmlformats.org/drawingml/2006/main" r:embed="R66b7f2fc75d9469f"/>
           <a:stretch xmlns:a="http://schemas.openxmlformats.org/drawingml/2006/main"/>
         </p:blipFill>
         <p:spPr>
           <a:xfrm xmlns:a="http://schemas.openxmlformats.org/drawingml/2006/main">
-            <a:off x="4553048" y="2524125"/>
-            <a:ext cx="7048304" cy="3810000"/>
+            <a:off x="4552950" y="2661126"/>
+            <a:ext cx="7048500" cy="3535998"/>
           </a:xfrm>
           <a:prstGeom xmlns:a="http://schemas.openxmlformats.org/drawingml/2006/main" prst="rect">
             <a:avLst/>
@@ -2612,7 +2612,7 @@
     </p:spTree>
     <p:extLst>
       <p:ext uri="{BB962C8B-B14F-4D97-AF65-F5344CB8AC3E}">
-        <p14:creationId xmlns:p14="http://schemas.microsoft.com/office/powerpoint/2010/main" val="1058087644"/>
+        <p14:creationId xmlns:p14="http://schemas.microsoft.com/office/powerpoint/2010/main" val="639441901"/>
       </p:ext>
     </p:extLst>
   </p:cSld>
@@ -2643,7 +2643,7 @@
           <p:cNvPr id="14" name="">
             <a:extLst xmlns:a="http://schemas.openxmlformats.org/drawingml/2006/main">
               <a:ext uri="{FF2B5EF4-FFF2-40B4-BE49-F238E27FC236}">
-                <a16:creationId xmlns:a16="http://schemas.microsoft.com/office/drawing/2014/main" id="{1469748A-5541-4E49-AC14-8456E17F0F1A}"/>
+                <a16:creationId xmlns:a16="http://schemas.microsoft.com/office/drawing/2014/main" id="{0971C75A-9ED2-4F06-8DEA-78B6669D893B}"/>
               </a:ext>
             </a:extLst>
           </p:cNvPr>
@@ -2700,7 +2700,7 @@
           <p:cNvPr id="2" name="">
             <a:extLst xmlns:a="http://schemas.openxmlformats.org/drawingml/2006/main">
               <a:ext uri="{FF2B5EF4-FFF2-40B4-BE49-F238E27FC236}">
-                <a16:creationId xmlns:a16="http://schemas.microsoft.com/office/drawing/2014/main" id="{43DFAC28-F090-45A8-9F66-928401A534EC}"/>
+                <a16:creationId xmlns:a16="http://schemas.microsoft.com/office/drawing/2014/main" id="{FD161829-D271-485D-A9D2-4BFF6DDC5C98}"/>
               </a:ext>
             </a:extLst>
           </p:cNvPr>
@@ -2757,7 +2757,7 @@
           <p:cNvPr id="3" name="">
             <a:extLst xmlns:a="http://schemas.openxmlformats.org/drawingml/2006/main">
               <a:ext uri="{FF2B5EF4-FFF2-40B4-BE49-F238E27FC236}">
-                <a16:creationId xmlns:a16="http://schemas.microsoft.com/office/drawing/2014/main" id="{52C10EA7-512A-489E-A26A-6A7C70E0A18E}"/>
+                <a16:creationId xmlns:a16="http://schemas.microsoft.com/office/drawing/2014/main" id="{7777A004-D73F-44C4-8264-3A156B750389}"/>
               </a:ext>
             </a:extLst>
           </p:cNvPr>
@@ -2814,7 +2814,7 @@
           <p:cNvPr id="4" name="">
             <a:extLst xmlns:a="http://schemas.openxmlformats.org/drawingml/2006/main">
               <a:ext uri="{FF2B5EF4-FFF2-40B4-BE49-F238E27FC236}">
-                <a16:creationId xmlns:a16="http://schemas.microsoft.com/office/drawing/2014/main" id="{697E6FF1-CF50-4EF1-A148-748C8EF78783}"/>
+                <a16:creationId xmlns:a16="http://schemas.microsoft.com/office/drawing/2014/main" id="{054B9002-2261-4E44-91B8-24BA5E8AB98D}"/>
               </a:ext>
             </a:extLst>
           </p:cNvPr>
@@ -2871,7 +2871,7 @@
           <p:cNvPr id="5" name="">
             <a:extLst xmlns:a="http://schemas.openxmlformats.org/drawingml/2006/main">
               <a:ext uri="{FF2B5EF4-FFF2-40B4-BE49-F238E27FC236}">
-                <a16:creationId xmlns:a16="http://schemas.microsoft.com/office/drawing/2014/main" id="{9D4F38B6-94FA-46B7-ACDC-6C6CBB5E2239}"/>
+                <a16:creationId xmlns:a16="http://schemas.microsoft.com/office/drawing/2014/main" id="{A345767C-3212-46EB-948D-E86FA38CC305}"/>
               </a:ext>
             </a:extLst>
           </p:cNvPr>
@@ -2928,7 +2928,7 @@
           <p:cNvPr id="6" name="">
             <a:extLst xmlns:a="http://schemas.openxmlformats.org/drawingml/2006/main">
               <a:ext uri="{FF2B5EF4-FFF2-40B4-BE49-F238E27FC236}">
-                <a16:creationId xmlns:a16="http://schemas.microsoft.com/office/drawing/2014/main" id="{D247A882-2E7E-4493-9329-02D05CD52B60}"/>
+                <a16:creationId xmlns:a16="http://schemas.microsoft.com/office/drawing/2014/main" id="{29A923B8-404B-4AF7-8C8A-028ECA1A85C5}"/>
               </a:ext>
             </a:extLst>
           </p:cNvPr>
@@ -3031,7 +3031,7 @@
           <p:cNvPr id="7" name="">
             <a:extLst xmlns:a="http://schemas.openxmlformats.org/drawingml/2006/main">
               <a:ext uri="{FF2B5EF4-FFF2-40B4-BE49-F238E27FC236}">
-                <a16:creationId xmlns:a16="http://schemas.microsoft.com/office/drawing/2014/main" id="{43B180D2-548C-4575-9D87-1AEAE08FBBE8}"/>
+                <a16:creationId xmlns:a16="http://schemas.microsoft.com/office/drawing/2014/main" id="{0A813F5B-C547-4FEE-9098-631B7FC48810}"/>
               </a:ext>
             </a:extLst>
           </p:cNvPr>
@@ -3088,7 +3088,7 @@
           <p:cNvPr id="8" name="">
             <a:extLst xmlns:a="http://schemas.openxmlformats.org/drawingml/2006/main">
               <a:ext uri="{FF2B5EF4-FFF2-40B4-BE49-F238E27FC236}">
-                <a16:creationId xmlns:a16="http://schemas.microsoft.com/office/drawing/2014/main" id="{072D427E-C1CA-45E1-99FC-06EDCC2D0909}"/>
+                <a16:creationId xmlns:a16="http://schemas.microsoft.com/office/drawing/2014/main" id="{A1B0D521-6A0B-4141-9EF1-F8918CA08499}"/>
               </a:ext>
             </a:extLst>
           </p:cNvPr>
@@ -3191,7 +3191,7 @@
           <p:cNvPr id="9" name="">
             <a:extLst xmlns:a="http://schemas.openxmlformats.org/drawingml/2006/main">
               <a:ext uri="{FF2B5EF4-FFF2-40B4-BE49-F238E27FC236}">
-                <a16:creationId xmlns:a16="http://schemas.microsoft.com/office/drawing/2014/main" id="{CAAF31FE-B679-42D9-88AA-3157A0E94211}"/>
+                <a16:creationId xmlns:a16="http://schemas.microsoft.com/office/drawing/2014/main" id="{91D10AEA-C86A-499A-B88E-37E82682C86D}"/>
               </a:ext>
             </a:extLst>
           </p:cNvPr>
@@ -3248,7 +3248,7 @@
           <p:cNvPr id="10" name="">
             <a:extLst xmlns:a="http://schemas.openxmlformats.org/drawingml/2006/main">
               <a:ext uri="{FF2B5EF4-FFF2-40B4-BE49-F238E27FC236}">
-                <a16:creationId xmlns:a16="http://schemas.microsoft.com/office/drawing/2014/main" id="{302579B1-D62E-49FB-9638-1D1BABD14A08}"/>
+                <a16:creationId xmlns:a16="http://schemas.microsoft.com/office/drawing/2014/main" id="{E3FF118C-3B60-4158-886A-8F0AC45C8A9F}"/>
               </a:ext>
             </a:extLst>
           </p:cNvPr>
@@ -3351,7 +3351,7 @@
           <p:cNvPr id="11" name="">
             <a:extLst xmlns:a="http://schemas.openxmlformats.org/drawingml/2006/main">
               <a:ext uri="{FF2B5EF4-FFF2-40B4-BE49-F238E27FC236}">
-                <a16:creationId xmlns:a16="http://schemas.microsoft.com/office/drawing/2014/main" id="{54D5491A-CB87-4480-A5E9-79601D7D823E}"/>
+                <a16:creationId xmlns:a16="http://schemas.microsoft.com/office/drawing/2014/main" id="{9A45C75B-C220-48A1-8E7C-515686120F50}"/>
               </a:ext>
             </a:extLst>
           </p:cNvPr>
@@ -3408,7 +3408,7 @@
           <p:cNvPr id="12" name="">
             <a:extLst xmlns:a="http://schemas.openxmlformats.org/drawingml/2006/main">
               <a:ext uri="{FF2B5EF4-FFF2-40B4-BE49-F238E27FC236}">
-                <a16:creationId xmlns:a16="http://schemas.microsoft.com/office/drawing/2014/main" id="{12DE19F2-E7F6-4D57-B476-4AF0723738B9}"/>
+                <a16:creationId xmlns:a16="http://schemas.microsoft.com/office/drawing/2014/main" id="{2DCE11CC-D3F3-45D3-8D7C-C9CB48360ED2}"/>
               </a:ext>
             </a:extLst>
           </p:cNvPr>
@@ -3488,7 +3488,7 @@
           <p:cNvPr id="13" name="">
             <a:extLst xmlns:a="http://schemas.openxmlformats.org/drawingml/2006/main">
               <a:ext uri="{FF2B5EF4-FFF2-40B4-BE49-F238E27FC236}">
-                <a16:creationId xmlns:a16="http://schemas.microsoft.com/office/drawing/2014/main" id="{B95BD128-91C8-4CC3-A16D-4B77F9D79A8B}"/>
+                <a16:creationId xmlns:a16="http://schemas.microsoft.com/office/drawing/2014/main" id="{36483E62-7207-4DF5-BCDE-98089EBCE649}"/>
               </a:ext>
             </a:extLst>
           </p:cNvPr>
@@ -3543,7 +3543,7 @@
     </p:spTree>
     <p:extLst>
       <p:ext uri="{BB962C8B-B14F-4D97-AF65-F5344CB8AC3E}">
-        <p14:creationId xmlns:p14="http://schemas.microsoft.com/office/powerpoint/2010/main" val="446883130"/>
+        <p14:creationId xmlns:p14="http://schemas.microsoft.com/office/powerpoint/2010/main" val="144218413"/>
       </p:ext>
     </p:extLst>
   </p:cSld>
@@ -3574,7 +3574,7 @@
           <p:cNvPr id="25" name="">
             <a:extLst xmlns:a="http://schemas.openxmlformats.org/drawingml/2006/main">
               <a:ext uri="{FF2B5EF4-FFF2-40B4-BE49-F238E27FC236}">
-                <a16:creationId xmlns:a16="http://schemas.microsoft.com/office/drawing/2014/main" id="{24AE8050-7B44-4943-B171-7C10557740CA}"/>
+                <a16:creationId xmlns:a16="http://schemas.microsoft.com/office/drawing/2014/main" id="{3BFE49B6-CBBA-4E22-9EE5-06A756254097}"/>
               </a:ext>
             </a:extLst>
           </p:cNvPr>
@@ -3631,7 +3631,7 @@
           <p:cNvPr id="2" name="">
             <a:extLst xmlns:a="http://schemas.openxmlformats.org/drawingml/2006/main">
               <a:ext uri="{FF2B5EF4-FFF2-40B4-BE49-F238E27FC236}">
-                <a16:creationId xmlns:a16="http://schemas.microsoft.com/office/drawing/2014/main" id="{7693A194-2518-4BFF-9A8D-7B0569507966}"/>
+                <a16:creationId xmlns:a16="http://schemas.microsoft.com/office/drawing/2014/main" id="{E661A26B-FA1E-4928-A5CF-B5F37FC2E27E}"/>
               </a:ext>
             </a:extLst>
           </p:cNvPr>
@@ -3688,7 +3688,7 @@
           <p:cNvPr id="3" name="">
             <a:extLst xmlns:a="http://schemas.openxmlformats.org/drawingml/2006/main">
               <a:ext uri="{FF2B5EF4-FFF2-40B4-BE49-F238E27FC236}">
-                <a16:creationId xmlns:a16="http://schemas.microsoft.com/office/drawing/2014/main" id="{E4242A96-3537-497B-AA2B-F4AEEA1B3823}"/>
+                <a16:creationId xmlns:a16="http://schemas.microsoft.com/office/drawing/2014/main" id="{50619EF7-DEF3-45DC-B821-024A50B3A56C}"/>
               </a:ext>
             </a:extLst>
           </p:cNvPr>
@@ -3745,7 +3745,7 @@
           <p:cNvPr id="4" name="">
             <a:extLst xmlns:a="http://schemas.openxmlformats.org/drawingml/2006/main">
               <a:ext uri="{FF2B5EF4-FFF2-40B4-BE49-F238E27FC236}">
-                <a16:creationId xmlns:a16="http://schemas.microsoft.com/office/drawing/2014/main" id="{904F85F9-9B9B-49EA-B0FE-38BAB7069FCB}"/>
+                <a16:creationId xmlns:a16="http://schemas.microsoft.com/office/drawing/2014/main" id="{CD8E8075-1BAB-4382-B797-01C2B841FAAC}"/>
               </a:ext>
             </a:extLst>
           </p:cNvPr>
@@ -3802,7 +3802,7 @@
           <p:cNvPr id="5" name="">
             <a:extLst xmlns:a="http://schemas.openxmlformats.org/drawingml/2006/main">
               <a:ext uri="{FF2B5EF4-FFF2-40B4-BE49-F238E27FC236}">
-                <a16:creationId xmlns:a16="http://schemas.microsoft.com/office/drawing/2014/main" id="{AF568852-3276-4338-BFC7-DA4229FF7249}"/>
+                <a16:creationId xmlns:a16="http://schemas.microsoft.com/office/drawing/2014/main" id="{3FCF4246-08F7-4769-A5A9-FF3DE4778330}"/>
               </a:ext>
             </a:extLst>
           </p:cNvPr>
@@ -3859,7 +3859,7 @@
           <p:cNvPr id="6" name="">
             <a:extLst xmlns:a="http://schemas.openxmlformats.org/drawingml/2006/main">
               <a:ext uri="{FF2B5EF4-FFF2-40B4-BE49-F238E27FC236}">
-                <a16:creationId xmlns:a16="http://schemas.microsoft.com/office/drawing/2014/main" id="{19535AD4-5A01-4DFD-BA4B-FA9149191549}"/>
+                <a16:creationId xmlns:a16="http://schemas.microsoft.com/office/drawing/2014/main" id="{E10CD383-59C2-48EE-ACC3-FC7CDE97CCFC}"/>
               </a:ext>
             </a:extLst>
           </p:cNvPr>
@@ -3916,7 +3916,7 @@
           <p:cNvPr id="7" name="">
             <a:extLst xmlns:a="http://schemas.openxmlformats.org/drawingml/2006/main">
               <a:ext uri="{FF2B5EF4-FFF2-40B4-BE49-F238E27FC236}">
-                <a16:creationId xmlns:a16="http://schemas.microsoft.com/office/drawing/2014/main" id="{0907EE51-502C-4700-A4DB-B0B0E823EEA4}"/>
+                <a16:creationId xmlns:a16="http://schemas.microsoft.com/office/drawing/2014/main" id="{1E818863-693E-4868-B2F8-A99F7F61A4CC}"/>
               </a:ext>
             </a:extLst>
           </p:cNvPr>
@@ -3973,7 +3973,7 @@
           <p:cNvPr id="8" name="">
             <a:extLst xmlns:a="http://schemas.openxmlformats.org/drawingml/2006/main">
               <a:ext uri="{FF2B5EF4-FFF2-40B4-BE49-F238E27FC236}">
-                <a16:creationId xmlns:a16="http://schemas.microsoft.com/office/drawing/2014/main" id="{C3E62FF1-7CCF-449B-8731-209B7CD5D07D}"/>
+                <a16:creationId xmlns:a16="http://schemas.microsoft.com/office/drawing/2014/main" id="{9DB6D4B5-893A-48F0-8D61-E208C25F705E}"/>
               </a:ext>
             </a:extLst>
           </p:cNvPr>
@@ -4030,7 +4030,7 @@
           <p:cNvPr id="9" name="">
             <a:extLst xmlns:a="http://schemas.openxmlformats.org/drawingml/2006/main">
               <a:ext uri="{FF2B5EF4-FFF2-40B4-BE49-F238E27FC236}">
-                <a16:creationId xmlns:a16="http://schemas.microsoft.com/office/drawing/2014/main" id="{1915E6C9-BC43-420C-848C-77CC3722030A}"/>
+                <a16:creationId xmlns:a16="http://schemas.microsoft.com/office/drawing/2014/main" id="{DEE8D802-4BB2-4768-AE25-F53BFF4AF420}"/>
               </a:ext>
             </a:extLst>
           </p:cNvPr>
@@ -4087,7 +4087,7 @@
           <p:cNvPr id="10" name="">
             <a:extLst xmlns:a="http://schemas.openxmlformats.org/drawingml/2006/main">
               <a:ext uri="{FF2B5EF4-FFF2-40B4-BE49-F238E27FC236}">
-                <a16:creationId xmlns:a16="http://schemas.microsoft.com/office/drawing/2014/main" id="{442039A8-D9CB-496F-A9E7-5EB0D1979C1C}"/>
+                <a16:creationId xmlns:a16="http://schemas.microsoft.com/office/drawing/2014/main" id="{071269D6-8E11-4733-B9AD-82BB6D01688D}"/>
               </a:ext>
             </a:extLst>
           </p:cNvPr>
@@ -4144,7 +4144,7 @@
           <p:cNvPr id="11" name="">
             <a:extLst xmlns:a="http://schemas.openxmlformats.org/drawingml/2006/main">
               <a:ext uri="{FF2B5EF4-FFF2-40B4-BE49-F238E27FC236}">
-                <a16:creationId xmlns:a16="http://schemas.microsoft.com/office/drawing/2014/main" id="{B4B5B455-783E-4287-9FF6-EE2FC9CD52E7}"/>
+                <a16:creationId xmlns:a16="http://schemas.microsoft.com/office/drawing/2014/main" id="{00D5974D-96B8-431D-9D59-574F6FBA6E0B}"/>
               </a:ext>
             </a:extLst>
           </p:cNvPr>
@@ -4263,13 +4263,13 @@
           <p:nvPr/>
         </p:nvPicPr>
         <p:blipFill>
-          <a:blip xmlns:r="http://schemas.openxmlformats.org/officeDocument/2006/relationships" xmlns:a="http://schemas.openxmlformats.org/drawingml/2006/main" r:embed="R1eb257aac937472d"/>
+          <a:blip xmlns:r="http://schemas.openxmlformats.org/officeDocument/2006/relationships" xmlns:a="http://schemas.openxmlformats.org/drawingml/2006/main" r:embed="R48b92b5706eb4d9b"/>
           <a:stretch xmlns:a="http://schemas.openxmlformats.org/drawingml/2006/main"/>
         </p:blipFill>
         <p:spPr>
           <a:xfrm xmlns:a="http://schemas.openxmlformats.org/drawingml/2006/main">
-            <a:off x="7717790" y="3143250"/>
-            <a:ext cx="3900170" cy="1581150"/>
+            <a:off x="8480660" y="2952750"/>
+            <a:ext cx="2374429" cy="1809750"/>
           </a:xfrm>
           <a:prstGeom xmlns:a="http://schemas.openxmlformats.org/drawingml/2006/main" prst="rect">
             <a:avLst/>
@@ -4281,7 +4281,7 @@
           <p:cNvPr id="13" name="">
             <a:extLst xmlns:a="http://schemas.openxmlformats.org/drawingml/2006/main">
               <a:ext uri="{FF2B5EF4-FFF2-40B4-BE49-F238E27FC236}">
-                <a16:creationId xmlns:a16="http://schemas.microsoft.com/office/drawing/2014/main" id="{BA9B6797-081B-46AF-A557-CDC1700F0E39}"/>
+                <a16:creationId xmlns:a16="http://schemas.microsoft.com/office/drawing/2014/main" id="{62F85413-5D2E-4981-97ED-9C0F0178A147}"/>
               </a:ext>
             </a:extLst>
           </p:cNvPr>
@@ -4361,7 +4361,7 @@
           <p:cNvPr id="14" name="">
             <a:extLst xmlns:a="http://schemas.openxmlformats.org/drawingml/2006/main">
               <a:ext uri="{FF2B5EF4-FFF2-40B4-BE49-F238E27FC236}">
-                <a16:creationId xmlns:a16="http://schemas.microsoft.com/office/drawing/2014/main" id="{FD9503E6-784A-4698-8AC4-301D3CE6B650}"/>
+                <a16:creationId xmlns:a16="http://schemas.microsoft.com/office/drawing/2014/main" id="{53E12188-9780-4EE4-9113-846B5B2C055F}"/>
               </a:ext>
             </a:extLst>
           </p:cNvPr>
@@ -4391,7 +4391,7 @@
           <p:cNvPr id="15" name="">
             <a:extLst xmlns:a="http://schemas.openxmlformats.org/drawingml/2006/main">
               <a:ext uri="{FF2B5EF4-FFF2-40B4-BE49-F238E27FC236}">
-                <a16:creationId xmlns:a16="http://schemas.microsoft.com/office/drawing/2014/main" id="{F24DB107-FB5E-4979-98FA-709495C7B123}"/>
+                <a16:creationId xmlns:a16="http://schemas.microsoft.com/office/drawing/2014/main" id="{C0A0AC3C-352D-424D-86A0-0CEC803ABEF0}"/>
               </a:ext>
             </a:extLst>
           </p:cNvPr>
@@ -4421,7 +4421,7 @@
           <p:cNvPr id="16" name="">
             <a:extLst xmlns:a="http://schemas.openxmlformats.org/drawingml/2006/main">
               <a:ext uri="{FF2B5EF4-FFF2-40B4-BE49-F238E27FC236}">
-                <a16:creationId xmlns:a16="http://schemas.microsoft.com/office/drawing/2014/main" id="{18CFF7FF-0D9D-49EE-94A2-6050A6C0AB25}"/>
+                <a16:creationId xmlns:a16="http://schemas.microsoft.com/office/drawing/2014/main" id="{E1DB2196-59B5-459C-B66B-65DED1AA6D4D}"/>
               </a:ext>
             </a:extLst>
           </p:cNvPr>
@@ -4451,7 +4451,7 @@
           <p:cNvPr id="17" name="">
             <a:extLst xmlns:a="http://schemas.openxmlformats.org/drawingml/2006/main">
               <a:ext uri="{FF2B5EF4-FFF2-40B4-BE49-F238E27FC236}">
-                <a16:creationId xmlns:a16="http://schemas.microsoft.com/office/drawing/2014/main" id="{D4B55C44-09D1-493A-AC6F-C1C4EDCC9769}"/>
+                <a16:creationId xmlns:a16="http://schemas.microsoft.com/office/drawing/2014/main" id="{E74E03AF-D50A-4517-BD15-99C1CE059DD1}"/>
               </a:ext>
             </a:extLst>
           </p:cNvPr>
@@ -4481,7 +4481,7 @@
           <p:cNvPr id="18" name="">
             <a:extLst xmlns:a="http://schemas.openxmlformats.org/drawingml/2006/main">
               <a:ext uri="{FF2B5EF4-FFF2-40B4-BE49-F238E27FC236}">
-                <a16:creationId xmlns:a16="http://schemas.microsoft.com/office/drawing/2014/main" id="{61F97F11-C551-4B81-A860-6531860D7BCB}"/>
+                <a16:creationId xmlns:a16="http://schemas.microsoft.com/office/drawing/2014/main" id="{FEC2873C-8DCC-40E8-94FE-13D8EAFCA580}"/>
               </a:ext>
             </a:extLst>
           </p:cNvPr>
@@ -4538,7 +4538,7 @@
           <p:cNvPr id="19" name="">
             <a:extLst xmlns:a="http://schemas.openxmlformats.org/drawingml/2006/main">
               <a:ext uri="{FF2B5EF4-FFF2-40B4-BE49-F238E27FC236}">
-                <a16:creationId xmlns:a16="http://schemas.microsoft.com/office/drawing/2014/main" id="{92CBEBCE-8EC0-4873-A26A-A7BD11509AF8}"/>
+                <a16:creationId xmlns:a16="http://schemas.microsoft.com/office/drawing/2014/main" id="{535B92A7-5721-43B5-857B-B07834941567}"/>
               </a:ext>
             </a:extLst>
           </p:cNvPr>
@@ -4595,7 +4595,7 @@
           <p:cNvPr id="20" name="">
             <a:extLst xmlns:a="http://schemas.openxmlformats.org/drawingml/2006/main">
               <a:ext uri="{FF2B5EF4-FFF2-40B4-BE49-F238E27FC236}">
-                <a16:creationId xmlns:a16="http://schemas.microsoft.com/office/drawing/2014/main" id="{09B02EB1-B726-4B85-84FA-3D5E5DA1004C}"/>
+                <a16:creationId xmlns:a16="http://schemas.microsoft.com/office/drawing/2014/main" id="{02F11E8E-0306-46C8-BF9D-383DB9F67E23}"/>
               </a:ext>
             </a:extLst>
           </p:cNvPr>
@@ -4652,7 +4652,7 @@
           <p:cNvPr id="21" name="">
             <a:extLst xmlns:a="http://schemas.openxmlformats.org/drawingml/2006/main">
               <a:ext uri="{FF2B5EF4-FFF2-40B4-BE49-F238E27FC236}">
-                <a16:creationId xmlns:a16="http://schemas.microsoft.com/office/drawing/2014/main" id="{01A3A245-E72A-4C54-BD0F-7738C1B0DBDB}"/>
+                <a16:creationId xmlns:a16="http://schemas.microsoft.com/office/drawing/2014/main" id="{CC26F3CD-02A7-43C0-9BCF-8F9DF900E58E}"/>
               </a:ext>
             </a:extLst>
           </p:cNvPr>
@@ -4732,7 +4732,7 @@
           <p:cNvPr id="22" name="">
             <a:extLst xmlns:a="http://schemas.openxmlformats.org/drawingml/2006/main">
               <a:ext uri="{FF2B5EF4-FFF2-40B4-BE49-F238E27FC236}">
-                <a16:creationId xmlns:a16="http://schemas.microsoft.com/office/drawing/2014/main" id="{8C2F575C-CFB9-4301-A20B-6DAD567D1EF8}"/>
+                <a16:creationId xmlns:a16="http://schemas.microsoft.com/office/drawing/2014/main" id="{03DFAC24-CFDE-4D81-901C-55448F492461}"/>
               </a:ext>
             </a:extLst>
           </p:cNvPr>
@@ -4789,7 +4789,7 @@
           <p:cNvPr id="23" name="">
             <a:extLst xmlns:a="http://schemas.openxmlformats.org/drawingml/2006/main">
               <a:ext uri="{FF2B5EF4-FFF2-40B4-BE49-F238E27FC236}">
-                <a16:creationId xmlns:a16="http://schemas.microsoft.com/office/drawing/2014/main" id="{944EBBE7-24BA-4519-8ED7-A8F872AB5899}"/>
+                <a16:creationId xmlns:a16="http://schemas.microsoft.com/office/drawing/2014/main" id="{6934D731-EDC1-40DE-B1BC-AD8541A50278}"/>
               </a:ext>
             </a:extLst>
           </p:cNvPr>
@@ -4869,7 +4869,7 @@
           <p:cNvPr id="24" name="">
             <a:extLst xmlns:a="http://schemas.openxmlformats.org/drawingml/2006/main">
               <a:ext uri="{FF2B5EF4-FFF2-40B4-BE49-F238E27FC236}">
-                <a16:creationId xmlns:a16="http://schemas.microsoft.com/office/drawing/2014/main" id="{0EDC6629-7978-484A-ABA0-2496C86F0BBD}"/>
+                <a16:creationId xmlns:a16="http://schemas.microsoft.com/office/drawing/2014/main" id="{9F6C366B-A72E-46B3-915D-E7D2CFF0F4DC}"/>
               </a:ext>
             </a:extLst>
           </p:cNvPr>
@@ -4924,7 +4924,7 @@
     </p:spTree>
     <p:extLst>
       <p:ext uri="{BB962C8B-B14F-4D97-AF65-F5344CB8AC3E}">
-        <p14:creationId xmlns:p14="http://schemas.microsoft.com/office/powerpoint/2010/main" val="187540573"/>
+        <p14:creationId xmlns:p14="http://schemas.microsoft.com/office/powerpoint/2010/main" val="1377754616"/>
       </p:ext>
     </p:extLst>
   </p:cSld>

</xml_diff>